<commit_message>
Refined presentation and final project updates
</commit_message>
<xml_diff>
--- a/presentation/healthcare_pipeline_presentation.pptx
+++ b/presentation/healthcare_pipeline_presentation.pptx
@@ -5,28 +5,23 @@
     <p:sldMasterId id="2147483660" r:id="rId1"/>
   </p:sldMasterIdLst>
   <p:notesMasterIdLst>
-    <p:notesMasterId r:id="rId21"/>
+    <p:notesMasterId r:id="rId16"/>
   </p:notesMasterIdLst>
   <p:sldIdLst>
     <p:sldId id="270" r:id="rId2"/>
     <p:sldId id="273" r:id="rId3"/>
     <p:sldId id="258" r:id="rId4"/>
-    <p:sldId id="259" r:id="rId5"/>
-    <p:sldId id="272" r:id="rId6"/>
-    <p:sldId id="260" r:id="rId7"/>
-    <p:sldId id="274" r:id="rId8"/>
-    <p:sldId id="262" r:id="rId9"/>
-    <p:sldId id="263" r:id="rId10"/>
-    <p:sldId id="264" r:id="rId11"/>
-    <p:sldId id="276" r:id="rId12"/>
-    <p:sldId id="277" r:id="rId13"/>
-    <p:sldId id="278" r:id="rId14"/>
-    <p:sldId id="279" r:id="rId15"/>
-    <p:sldId id="265" r:id="rId16"/>
-    <p:sldId id="275" r:id="rId17"/>
-    <p:sldId id="267" r:id="rId18"/>
-    <p:sldId id="268" r:id="rId19"/>
-    <p:sldId id="269" r:id="rId20"/>
+    <p:sldId id="272" r:id="rId5"/>
+    <p:sldId id="260" r:id="rId6"/>
+    <p:sldId id="274" r:id="rId7"/>
+    <p:sldId id="262" r:id="rId8"/>
+    <p:sldId id="263" r:id="rId9"/>
+    <p:sldId id="280" r:id="rId10"/>
+    <p:sldId id="265" r:id="rId11"/>
+    <p:sldId id="275" r:id="rId12"/>
+    <p:sldId id="267" r:id="rId13"/>
+    <p:sldId id="268" r:id="rId14"/>
+    <p:sldId id="269" r:id="rId15"/>
   </p:sldIdLst>
   <p:sldSz cx="9144000" cy="6858000" type="screen4x3"/>
   <p:notesSz cx="6858000" cy="9144000"/>
@@ -951,7 +946,11 @@
         <a:p>
           <a:r>
             <a:rPr lang="en-US" sz="2000" dirty="0"/>
-            <a:t>01_ingest.R</a:t>
+            <a:t>01_ingest.R – </a:t>
+          </a:r>
+          <a:r>
+            <a:rPr lang="en-US" sz="1400" dirty="0"/>
+            <a:t>data ingestion &amp; validation</a:t>
           </a:r>
           <a:endParaRPr lang="en-GY" sz="2000" dirty="0"/>
         </a:p>
@@ -1025,7 +1024,11 @@
         <a:p>
           <a:r>
             <a:rPr lang="en-US" sz="2000" dirty="0"/>
-            <a:t>02_diagnose.R </a:t>
+            <a:t>02_diagnose.R- </a:t>
+          </a:r>
+          <a:r>
+            <a:rPr lang="en-US" sz="1400" dirty="0"/>
+            <a:t>diagnostics &amp; logging</a:t>
           </a:r>
           <a:endParaRPr lang="en-GY" sz="2000" dirty="0"/>
         </a:p>
@@ -1099,7 +1102,11 @@
         <a:p>
           <a:r>
             <a:rPr lang="en-US" sz="2000" dirty="0"/>
-            <a:t>07_report.Rmd</a:t>
+            <a:t>07_report.Rmd – </a:t>
+          </a:r>
+          <a:r>
+            <a:rPr lang="en-US" sz="1400" dirty="0"/>
+            <a:t>automated word report</a:t>
           </a:r>
           <a:endParaRPr lang="en-GY" sz="2000" dirty="0"/>
         </a:p>
@@ -1284,7 +1291,11 @@
         <a:p>
           <a:r>
             <a:rPr lang="en-US" sz="2000" dirty="0"/>
-            <a:t>03_clean.R</a:t>
+            <a:t>03_clean.R – </a:t>
+          </a:r>
+          <a:r>
+            <a:rPr lang="en-US" sz="1400" dirty="0"/>
+            <a:t>cleaning &amp; duplicate handling</a:t>
           </a:r>
           <a:endParaRPr lang="en-GY" sz="2000" dirty="0"/>
         </a:p>
@@ -1321,7 +1332,11 @@
         <a:p>
           <a:r>
             <a:rPr lang="en-US" sz="2000" dirty="0"/>
-            <a:t>04_impute.R</a:t>
+            <a:t>04_impute.R - </a:t>
+          </a:r>
+          <a:r>
+            <a:rPr lang="en-US" sz="1400" dirty="0"/>
+            <a:t>imputation</a:t>
           </a:r>
           <a:endParaRPr lang="en-GY" sz="2000" dirty="0"/>
         </a:p>
@@ -1358,7 +1373,11 @@
         <a:p>
           <a:r>
             <a:rPr lang="en-US" sz="2000" dirty="0"/>
-            <a:t>05_dictionary.R</a:t>
+            <a:t>05_dictionary.R – </a:t>
+          </a:r>
+          <a:r>
+            <a:rPr lang="en-US" sz="1400" dirty="0"/>
+            <a:t>data dictionary generation</a:t>
           </a:r>
           <a:endParaRPr lang="en-GY" sz="2000" dirty="0"/>
         </a:p>
@@ -1395,7 +1414,11 @@
         <a:p>
           <a:r>
             <a:rPr lang="en-US" sz="2000" dirty="0"/>
-            <a:t>06_export.R</a:t>
+            <a:t>06_export.R – </a:t>
+          </a:r>
+          <a:r>
+            <a:rPr lang="en-US" sz="1400" dirty="0"/>
+            <a:t>export outputs</a:t>
           </a:r>
           <a:endParaRPr lang="en-GY" sz="2000" dirty="0"/>
         </a:p>
@@ -1423,6 +1446,80 @@
         </a:p>
       </dgm:t>
     </dgm:pt>
+    <dgm:pt modelId="{361F74F0-2D03-474D-B91B-FE875CF5ED9A}">
+      <dgm:prSet/>
+      <dgm:spPr/>
+      <dgm:t>
+        <a:bodyPr/>
+        <a:lstStyle/>
+        <a:p>
+          <a:endParaRPr lang="en-GY"/>
+        </a:p>
+      </dgm:t>
+    </dgm:pt>
+    <dgm:pt modelId="{49CFA8C3-8FEF-44E5-9FA4-05F20D07420C}" type="parTrans" cxnId="{EFF10F31-9357-4ADC-BE39-8D525F333FBF}">
+      <dgm:prSet/>
+      <dgm:spPr/>
+      <dgm:t>
+        <a:bodyPr/>
+        <a:lstStyle/>
+        <a:p>
+          <a:endParaRPr lang="en-GY"/>
+        </a:p>
+      </dgm:t>
+    </dgm:pt>
+    <dgm:pt modelId="{C5159945-39D9-477A-9D8E-4FFBE8A467F4}" type="sibTrans" cxnId="{EFF10F31-9357-4ADC-BE39-8D525F333FBF}">
+      <dgm:prSet/>
+      <dgm:spPr/>
+      <dgm:t>
+        <a:bodyPr/>
+        <a:lstStyle/>
+        <a:p>
+          <a:endParaRPr lang="en-GY"/>
+        </a:p>
+      </dgm:t>
+    </dgm:pt>
+    <dgm:pt modelId="{66B85507-ED1F-4365-B000-A5A8BDF9129B}">
+      <dgm:prSet custT="1"/>
+      <dgm:spPr/>
+      <dgm:t>
+        <a:bodyPr/>
+        <a:lstStyle/>
+        <a:p>
+          <a:r>
+            <a:rPr lang="en-US" sz="2000" dirty="0"/>
+            <a:t>00_config.R –</a:t>
+          </a:r>
+          <a:r>
+            <a:rPr lang="en-US" sz="1400" dirty="0"/>
+            <a:t> global paths and settings</a:t>
+          </a:r>
+          <a:endParaRPr lang="en-GY" sz="1400" dirty="0"/>
+        </a:p>
+      </dgm:t>
+    </dgm:pt>
+    <dgm:pt modelId="{45ABD367-49DE-4E22-8284-E58AFC079920}" type="parTrans" cxnId="{6915F89F-5863-4900-A1AE-3150933E998F}">
+      <dgm:prSet/>
+      <dgm:spPr/>
+      <dgm:t>
+        <a:bodyPr/>
+        <a:lstStyle/>
+        <a:p>
+          <a:endParaRPr lang="en-GY"/>
+        </a:p>
+      </dgm:t>
+    </dgm:pt>
+    <dgm:pt modelId="{0796BBC6-76EA-474B-A4FB-0B20CBFC4AA1}" type="sibTrans" cxnId="{6915F89F-5863-4900-A1AE-3150933E998F}">
+      <dgm:prSet/>
+      <dgm:spPr/>
+      <dgm:t>
+        <a:bodyPr/>
+        <a:lstStyle/>
+        <a:p>
+          <a:endParaRPr lang="en-GY"/>
+        </a:p>
+      </dgm:t>
+    </dgm:pt>
     <dgm:pt modelId="{B28987B3-919C-45F4-95A1-F0E90EE1BE74}" type="pres">
       <dgm:prSet presAssocID="{E00F0641-6FE9-4B06-A486-203C921AF9F6}" presName="linearFlow" presStyleCnt="0">
         <dgm:presLayoutVars>
@@ -1433,12 +1530,37 @@
       </dgm:prSet>
       <dgm:spPr/>
     </dgm:pt>
+    <dgm:pt modelId="{E4FAB94E-C29E-4AC6-8631-D35743AEFFF4}" type="pres">
+      <dgm:prSet presAssocID="{361F74F0-2D03-474D-B91B-FE875CF5ED9A}" presName="composite" presStyleCnt="0"/>
+      <dgm:spPr/>
+    </dgm:pt>
+    <dgm:pt modelId="{B754CC4D-D8D5-45C0-B29A-A53032317F91}" type="pres">
+      <dgm:prSet presAssocID="{361F74F0-2D03-474D-B91B-FE875CF5ED9A}" presName="parentText" presStyleLbl="alignNode1" presStyleIdx="0" presStyleCnt="8">
+        <dgm:presLayoutVars>
+          <dgm:chMax val="1"/>
+          <dgm:bulletEnabled val="1"/>
+        </dgm:presLayoutVars>
+      </dgm:prSet>
+      <dgm:spPr/>
+    </dgm:pt>
+    <dgm:pt modelId="{6D6E2A0C-1BA7-4A63-84A2-5A5FF93E87A8}" type="pres">
+      <dgm:prSet presAssocID="{361F74F0-2D03-474D-B91B-FE875CF5ED9A}" presName="descendantText" presStyleLbl="alignAcc1" presStyleIdx="0" presStyleCnt="8">
+        <dgm:presLayoutVars>
+          <dgm:bulletEnabled val="1"/>
+        </dgm:presLayoutVars>
+      </dgm:prSet>
+      <dgm:spPr/>
+    </dgm:pt>
+    <dgm:pt modelId="{BCD80044-DE74-4C0E-853E-59AB6D2B6096}" type="pres">
+      <dgm:prSet presAssocID="{C5159945-39D9-477A-9D8E-4FFBE8A467F4}" presName="sp" presStyleCnt="0"/>
+      <dgm:spPr/>
+    </dgm:pt>
     <dgm:pt modelId="{7DAF7208-6CFC-499C-B241-6F6850B44715}" type="pres">
       <dgm:prSet presAssocID="{D319ED06-36C1-477D-B2C4-14829CE6AED6}" presName="composite" presStyleCnt="0"/>
       <dgm:spPr/>
     </dgm:pt>
     <dgm:pt modelId="{B95750CF-B3B9-4E5B-9E01-CAE67414321B}" type="pres">
-      <dgm:prSet presAssocID="{D319ED06-36C1-477D-B2C4-14829CE6AED6}" presName="parentText" presStyleLbl="alignNode1" presStyleIdx="0" presStyleCnt="7">
+      <dgm:prSet presAssocID="{D319ED06-36C1-477D-B2C4-14829CE6AED6}" presName="parentText" presStyleLbl="alignNode1" presStyleIdx="1" presStyleCnt="8">
         <dgm:presLayoutVars>
           <dgm:chMax val="1"/>
           <dgm:bulletEnabled val="1"/>
@@ -1447,7 +1569,7 @@
       <dgm:spPr/>
     </dgm:pt>
     <dgm:pt modelId="{2749BC35-B99E-4AF8-B81F-FC9C89E9AB83}" type="pres">
-      <dgm:prSet presAssocID="{D319ED06-36C1-477D-B2C4-14829CE6AED6}" presName="descendantText" presStyleLbl="alignAcc1" presStyleIdx="0" presStyleCnt="7">
+      <dgm:prSet presAssocID="{D319ED06-36C1-477D-B2C4-14829CE6AED6}" presName="descendantText" presStyleLbl="alignAcc1" presStyleIdx="1" presStyleCnt="8">
         <dgm:presLayoutVars>
           <dgm:bulletEnabled val="1"/>
         </dgm:presLayoutVars>
@@ -1463,7 +1585,7 @@
       <dgm:spPr/>
     </dgm:pt>
     <dgm:pt modelId="{89BAFE56-39DE-40A4-B59E-AF9C5C343566}" type="pres">
-      <dgm:prSet presAssocID="{FD175BB3-DE6D-4A45-BDA6-9A6682EA910D}" presName="parentText" presStyleLbl="alignNode1" presStyleIdx="1" presStyleCnt="7">
+      <dgm:prSet presAssocID="{FD175BB3-DE6D-4A45-BDA6-9A6682EA910D}" presName="parentText" presStyleLbl="alignNode1" presStyleIdx="2" presStyleCnt="8">
         <dgm:presLayoutVars>
           <dgm:chMax val="1"/>
           <dgm:bulletEnabled val="1"/>
@@ -1472,7 +1594,7 @@
       <dgm:spPr/>
     </dgm:pt>
     <dgm:pt modelId="{D279EA2D-C7D4-4A2D-B832-CE671E9A5420}" type="pres">
-      <dgm:prSet presAssocID="{FD175BB3-DE6D-4A45-BDA6-9A6682EA910D}" presName="descendantText" presStyleLbl="alignAcc1" presStyleIdx="1" presStyleCnt="7">
+      <dgm:prSet presAssocID="{FD175BB3-DE6D-4A45-BDA6-9A6682EA910D}" presName="descendantText" presStyleLbl="alignAcc1" presStyleIdx="2" presStyleCnt="8">
         <dgm:presLayoutVars>
           <dgm:bulletEnabled val="1"/>
         </dgm:presLayoutVars>
@@ -1488,7 +1610,7 @@
       <dgm:spPr/>
     </dgm:pt>
     <dgm:pt modelId="{E1632E70-2FF3-409A-B038-7AEB0326704A}" type="pres">
-      <dgm:prSet presAssocID="{003C26E8-68FD-4340-B203-8836F4FAE147}" presName="parentText" presStyleLbl="alignNode1" presStyleIdx="2" presStyleCnt="7">
+      <dgm:prSet presAssocID="{003C26E8-68FD-4340-B203-8836F4FAE147}" presName="parentText" presStyleLbl="alignNode1" presStyleIdx="3" presStyleCnt="8">
         <dgm:presLayoutVars>
           <dgm:chMax val="1"/>
           <dgm:bulletEnabled val="1"/>
@@ -1497,7 +1619,7 @@
       <dgm:spPr/>
     </dgm:pt>
     <dgm:pt modelId="{EAE7CF5D-BE4F-4BB2-821E-27277B2EEBFB}" type="pres">
-      <dgm:prSet presAssocID="{003C26E8-68FD-4340-B203-8836F4FAE147}" presName="descendantText" presStyleLbl="alignAcc1" presStyleIdx="2" presStyleCnt="7">
+      <dgm:prSet presAssocID="{003C26E8-68FD-4340-B203-8836F4FAE147}" presName="descendantText" presStyleLbl="alignAcc1" presStyleIdx="3" presStyleCnt="8">
         <dgm:presLayoutVars>
           <dgm:bulletEnabled val="1"/>
         </dgm:presLayoutVars>
@@ -1513,7 +1635,7 @@
       <dgm:spPr/>
     </dgm:pt>
     <dgm:pt modelId="{600F4A9E-2A62-476E-9727-BFFBBFC2BF53}" type="pres">
-      <dgm:prSet presAssocID="{EF5A87F7-9184-4338-B681-103AE7020E8F}" presName="parentText" presStyleLbl="alignNode1" presStyleIdx="3" presStyleCnt="7">
+      <dgm:prSet presAssocID="{EF5A87F7-9184-4338-B681-103AE7020E8F}" presName="parentText" presStyleLbl="alignNode1" presStyleIdx="4" presStyleCnt="8">
         <dgm:presLayoutVars>
           <dgm:chMax val="1"/>
           <dgm:bulletEnabled val="1"/>
@@ -1522,7 +1644,7 @@
       <dgm:spPr/>
     </dgm:pt>
     <dgm:pt modelId="{DAE9D0B7-60EC-4A80-BFC1-C54B7FDE7B39}" type="pres">
-      <dgm:prSet presAssocID="{EF5A87F7-9184-4338-B681-103AE7020E8F}" presName="descendantText" presStyleLbl="alignAcc1" presStyleIdx="3" presStyleCnt="7">
+      <dgm:prSet presAssocID="{EF5A87F7-9184-4338-B681-103AE7020E8F}" presName="descendantText" presStyleLbl="alignAcc1" presStyleIdx="4" presStyleCnt="8">
         <dgm:presLayoutVars>
           <dgm:bulletEnabled val="1"/>
         </dgm:presLayoutVars>
@@ -1538,7 +1660,7 @@
       <dgm:spPr/>
     </dgm:pt>
     <dgm:pt modelId="{87BEBA03-C076-4656-9A59-6931769357D3}" type="pres">
-      <dgm:prSet presAssocID="{3BADAD2D-6184-474B-9930-EFCB1B5C7FE0}" presName="parentText" presStyleLbl="alignNode1" presStyleIdx="4" presStyleCnt="7">
+      <dgm:prSet presAssocID="{3BADAD2D-6184-474B-9930-EFCB1B5C7FE0}" presName="parentText" presStyleLbl="alignNode1" presStyleIdx="5" presStyleCnt="8">
         <dgm:presLayoutVars>
           <dgm:chMax val="1"/>
           <dgm:bulletEnabled val="1"/>
@@ -1547,7 +1669,7 @@
       <dgm:spPr/>
     </dgm:pt>
     <dgm:pt modelId="{E914C9C4-1E45-4BE2-B20B-6FFE9FEF7EBC}" type="pres">
-      <dgm:prSet presAssocID="{3BADAD2D-6184-474B-9930-EFCB1B5C7FE0}" presName="descendantText" presStyleLbl="alignAcc1" presStyleIdx="4" presStyleCnt="7">
+      <dgm:prSet presAssocID="{3BADAD2D-6184-474B-9930-EFCB1B5C7FE0}" presName="descendantText" presStyleLbl="alignAcc1" presStyleIdx="5" presStyleCnt="8">
         <dgm:presLayoutVars>
           <dgm:bulletEnabled val="1"/>
         </dgm:presLayoutVars>
@@ -1563,7 +1685,7 @@
       <dgm:spPr/>
     </dgm:pt>
     <dgm:pt modelId="{71A5F4AA-3510-4A80-95AA-B3CAE0BDA320}" type="pres">
-      <dgm:prSet presAssocID="{63D7A911-C7BD-4135-B458-BF039ED3972C}" presName="parentText" presStyleLbl="alignNode1" presStyleIdx="5" presStyleCnt="7">
+      <dgm:prSet presAssocID="{63D7A911-C7BD-4135-B458-BF039ED3972C}" presName="parentText" presStyleLbl="alignNode1" presStyleIdx="6" presStyleCnt="8">
         <dgm:presLayoutVars>
           <dgm:chMax val="1"/>
           <dgm:bulletEnabled val="1"/>
@@ -1572,7 +1694,7 @@
       <dgm:spPr/>
     </dgm:pt>
     <dgm:pt modelId="{CEEDEFDD-B88A-41A5-BB1B-D61F5FEED36F}" type="pres">
-      <dgm:prSet presAssocID="{63D7A911-C7BD-4135-B458-BF039ED3972C}" presName="descendantText" presStyleLbl="alignAcc1" presStyleIdx="5" presStyleCnt="7">
+      <dgm:prSet presAssocID="{63D7A911-C7BD-4135-B458-BF039ED3972C}" presName="descendantText" presStyleLbl="alignAcc1" presStyleIdx="6" presStyleCnt="8">
         <dgm:presLayoutVars>
           <dgm:bulletEnabled val="1"/>
         </dgm:presLayoutVars>
@@ -1588,7 +1710,7 @@
       <dgm:spPr/>
     </dgm:pt>
     <dgm:pt modelId="{7086D58B-66BB-48EF-9B71-F024F3911F29}" type="pres">
-      <dgm:prSet presAssocID="{66732301-5E01-4D2E-8D29-5EA430D9DF9D}" presName="parentText" presStyleLbl="alignNode1" presStyleIdx="6" presStyleCnt="7">
+      <dgm:prSet presAssocID="{66732301-5E01-4D2E-8D29-5EA430D9DF9D}" presName="parentText" presStyleLbl="alignNode1" presStyleIdx="7" presStyleCnt="8">
         <dgm:presLayoutVars>
           <dgm:chMax val="1"/>
           <dgm:bulletEnabled val="1"/>
@@ -1597,7 +1719,7 @@
       <dgm:spPr/>
     </dgm:pt>
     <dgm:pt modelId="{9831EBFE-52E3-4421-8DB6-43CE44ABBB9E}" type="pres">
-      <dgm:prSet presAssocID="{66732301-5E01-4D2E-8D29-5EA430D9DF9D}" presName="descendantText" presStyleLbl="alignAcc1" presStyleIdx="6" presStyleCnt="7">
+      <dgm:prSet presAssocID="{66732301-5E01-4D2E-8D29-5EA430D9DF9D}" presName="descendantText" presStyleLbl="alignAcc1" presStyleIdx="7" presStyleCnt="8">
         <dgm:presLayoutVars>
           <dgm:bulletEnabled val="1"/>
         </dgm:presLayoutVars>
@@ -1606,62 +1728,70 @@
     </dgm:pt>
   </dgm:ptLst>
   <dgm:cxnLst>
-    <dgm:cxn modelId="{84FDFC02-4C97-4AE2-89AE-98A50449226D}" type="presOf" srcId="{7C88B815-0664-4BBE-B655-01EC3A0B432E}" destId="{EAE7CF5D-BE4F-4BB2-821E-27277B2EEBFB}" srcOrd="0" destOrd="0" presId="urn:microsoft.com/office/officeart/2005/8/layout/chevron2"/>
-    <dgm:cxn modelId="{D7F64303-D913-4C58-AA04-4C04AA1802EE}" type="presOf" srcId="{63D7A911-C7BD-4135-B458-BF039ED3972C}" destId="{71A5F4AA-3510-4A80-95AA-B3CAE0BDA320}" srcOrd="0" destOrd="0" presId="urn:microsoft.com/office/officeart/2005/8/layout/chevron2"/>
-    <dgm:cxn modelId="{5B20010B-159D-49B4-88F6-51032C96481B}" type="presOf" srcId="{FD175BB3-DE6D-4A45-BDA6-9A6682EA910D}" destId="{89BAFE56-39DE-40A4-B59E-AF9C5C343566}" srcOrd="0" destOrd="0" presId="urn:microsoft.com/office/officeart/2005/8/layout/chevron2"/>
-    <dgm:cxn modelId="{B869A20B-CCE1-454C-98C1-D8200D412253}" type="presOf" srcId="{D319ED06-36C1-477D-B2C4-14829CE6AED6}" destId="{B95750CF-B3B9-4E5B-9E01-CAE67414321B}" srcOrd="0" destOrd="0" presId="urn:microsoft.com/office/officeart/2005/8/layout/chevron2"/>
-    <dgm:cxn modelId="{55B7960D-E144-44A2-A0C9-00589393783B}" srcId="{E00F0641-6FE9-4B06-A486-203C921AF9F6}" destId="{FD175BB3-DE6D-4A45-BDA6-9A6682EA910D}" srcOrd="1" destOrd="0" parTransId="{70D492BF-6E7C-4E92-A656-BFF5B3D2F916}" sibTransId="{846374F9-8997-4D60-A52E-041B13B70619}"/>
-    <dgm:cxn modelId="{B8FDAA0F-D190-4376-A119-57FCFDD56D14}" srcId="{E00F0641-6FE9-4B06-A486-203C921AF9F6}" destId="{EF5A87F7-9184-4338-B681-103AE7020E8F}" srcOrd="3" destOrd="0" parTransId="{E72232AA-E8E0-4F91-95F7-EEAAE9E9898F}" sibTransId="{017BD5B4-86DF-45D3-B43E-ADA1A1723E2A}"/>
+    <dgm:cxn modelId="{4707E10C-15A1-485D-A514-3BF4270572AE}" type="presOf" srcId="{003C26E8-68FD-4340-B203-8836F4FAE147}" destId="{E1632E70-2FF3-409A-B038-7AEB0326704A}" srcOrd="0" destOrd="0" presId="urn:microsoft.com/office/officeart/2005/8/layout/chevron2"/>
+    <dgm:cxn modelId="{55B7960D-E144-44A2-A0C9-00589393783B}" srcId="{E00F0641-6FE9-4B06-A486-203C921AF9F6}" destId="{FD175BB3-DE6D-4A45-BDA6-9A6682EA910D}" srcOrd="2" destOrd="0" parTransId="{70D492BF-6E7C-4E92-A656-BFF5B3D2F916}" sibTransId="{846374F9-8997-4D60-A52E-041B13B70619}"/>
+    <dgm:cxn modelId="{B8FDAA0F-D190-4376-A119-57FCFDD56D14}" srcId="{E00F0641-6FE9-4B06-A486-203C921AF9F6}" destId="{EF5A87F7-9184-4338-B681-103AE7020E8F}" srcOrd="4" destOrd="0" parTransId="{E72232AA-E8E0-4F91-95F7-EEAAE9E9898F}" sibTransId="{017BD5B4-86DF-45D3-B43E-ADA1A1723E2A}"/>
     <dgm:cxn modelId="{BFFE4519-65D4-4246-A35E-B374922F42C3}" srcId="{FD175BB3-DE6D-4A45-BDA6-9A6682EA910D}" destId="{6A5213D9-4189-4405-8486-867A94BFBC61}" srcOrd="0" destOrd="0" parTransId="{F26735A8-CBF6-4158-AB2E-54F4DEB4F8AB}" sibTransId="{26E335D2-8120-4F42-9D49-FECEB251AE86}"/>
-    <dgm:cxn modelId="{F9287E19-1F64-41F7-AF10-4002F0213D45}" type="presOf" srcId="{0586F6F3-F6BC-42C3-A360-AC09FFF4B164}" destId="{E914C9C4-1E45-4BE2-B20B-6FFE9FEF7EBC}" srcOrd="0" destOrd="0" presId="urn:microsoft.com/office/officeart/2005/8/layout/chevron2"/>
-    <dgm:cxn modelId="{0680471A-3B01-42E6-9772-44EE7995B8C8}" type="presOf" srcId="{9FE5993A-D9AF-4AEC-B763-794BAA96F210}" destId="{9831EBFE-52E3-4421-8DB6-43CE44ABBB9E}" srcOrd="0" destOrd="0" presId="urn:microsoft.com/office/officeart/2005/8/layout/chevron2"/>
-    <dgm:cxn modelId="{7D3E1D1B-30E7-43A4-945D-EC9EAE3B6794}" type="presOf" srcId="{EF5A87F7-9184-4338-B681-103AE7020E8F}" destId="{600F4A9E-2A62-476E-9727-BFFBBFC2BF53}" srcOrd="0" destOrd="0" presId="urn:microsoft.com/office/officeart/2005/8/layout/chevron2"/>
+    <dgm:cxn modelId="{96917919-A110-49C4-9AA8-E3135AD3D8C4}" type="presOf" srcId="{EF5A87F7-9184-4338-B681-103AE7020E8F}" destId="{600F4A9E-2A62-476E-9727-BFFBBFC2BF53}" srcOrd="0" destOrd="0" presId="urn:microsoft.com/office/officeart/2005/8/layout/chevron2"/>
+    <dgm:cxn modelId="{BBA4022B-CD44-4227-AF4C-FF284BE20CED}" type="presOf" srcId="{67B851F8-3514-4395-8791-E780F081A898}" destId="{CEEDEFDD-B88A-41A5-BB1B-D61F5FEED36F}" srcOrd="0" destOrd="0" presId="urn:microsoft.com/office/officeart/2005/8/layout/chevron2"/>
     <dgm:cxn modelId="{3567A42F-BDE8-4D63-B500-37A7F608BCD7}" srcId="{D319ED06-36C1-477D-B2C4-14829CE6AED6}" destId="{2CF8132D-0BBD-4431-A3B3-7DAC277FCC4E}" srcOrd="0" destOrd="0" parTransId="{F551AA26-A5A1-4ACC-81A3-D7035A0BACC5}" sibTransId="{4C7D462E-4211-47C3-B191-8732D9106D6B}"/>
-    <dgm:cxn modelId="{0C398632-6866-4203-881D-66421D9CA10D}" type="presOf" srcId="{66732301-5E01-4D2E-8D29-5EA430D9DF9D}" destId="{7086D58B-66BB-48EF-9B71-F024F3911F29}" srcOrd="0" destOrd="0" presId="urn:microsoft.com/office/officeart/2005/8/layout/chevron2"/>
-    <dgm:cxn modelId="{AEAD4633-627F-4087-B0C6-7F38A7B157A1}" type="presOf" srcId="{6A5213D9-4189-4405-8486-867A94BFBC61}" destId="{D279EA2D-C7D4-4A2D-B832-CE671E9A5420}" srcOrd="0" destOrd="0" presId="urn:microsoft.com/office/officeart/2005/8/layout/chevron2"/>
-    <dgm:cxn modelId="{6CE3655F-9A42-496F-8B05-C6C99B200777}" srcId="{E00F0641-6FE9-4B06-A486-203C921AF9F6}" destId="{66732301-5E01-4D2E-8D29-5EA430D9DF9D}" srcOrd="6" destOrd="0" parTransId="{637D46E8-2F73-4C40-BBC5-B869C63E6A0A}" sibTransId="{AB3BC250-5061-40B2-B21C-A3993457BAA0}"/>
-    <dgm:cxn modelId="{AE2FEE64-4D5C-427C-AD84-9496415E4C33}" srcId="{E00F0641-6FE9-4B06-A486-203C921AF9F6}" destId="{3BADAD2D-6184-474B-9930-EFCB1B5C7FE0}" srcOrd="4" destOrd="0" parTransId="{D6EF3321-937B-4243-82D0-6A598788BFA0}" sibTransId="{C2BA6549-97A4-4967-B3B4-24F88AFA8C6E}"/>
+    <dgm:cxn modelId="{EFF10F31-9357-4ADC-BE39-8D525F333FBF}" srcId="{E00F0641-6FE9-4B06-A486-203C921AF9F6}" destId="{361F74F0-2D03-474D-B91B-FE875CF5ED9A}" srcOrd="0" destOrd="0" parTransId="{49CFA8C3-8FEF-44E5-9FA4-05F20D07420C}" sibTransId="{C5159945-39D9-477A-9D8E-4FFBE8A467F4}"/>
+    <dgm:cxn modelId="{97CCE23B-71E3-4771-8ED7-29C4DC968376}" type="presOf" srcId="{66732301-5E01-4D2E-8D29-5EA430D9DF9D}" destId="{7086D58B-66BB-48EF-9B71-F024F3911F29}" srcOrd="0" destOrd="0" presId="urn:microsoft.com/office/officeart/2005/8/layout/chevron2"/>
+    <dgm:cxn modelId="{6CE3655F-9A42-496F-8B05-C6C99B200777}" srcId="{E00F0641-6FE9-4B06-A486-203C921AF9F6}" destId="{66732301-5E01-4D2E-8D29-5EA430D9DF9D}" srcOrd="7" destOrd="0" parTransId="{637D46E8-2F73-4C40-BBC5-B869C63E6A0A}" sibTransId="{AB3BC250-5061-40B2-B21C-A3993457BAA0}"/>
+    <dgm:cxn modelId="{AE2FEE64-4D5C-427C-AD84-9496415E4C33}" srcId="{E00F0641-6FE9-4B06-A486-203C921AF9F6}" destId="{3BADAD2D-6184-474B-9930-EFCB1B5C7FE0}" srcOrd="5" destOrd="0" parTransId="{D6EF3321-937B-4243-82D0-6A598788BFA0}" sibTransId="{C2BA6549-97A4-4967-B3B4-24F88AFA8C6E}"/>
+    <dgm:cxn modelId="{4EE63769-1301-457E-B6B0-A39CF74A905D}" type="presOf" srcId="{63D7A911-C7BD-4135-B458-BF039ED3972C}" destId="{71A5F4AA-3510-4A80-95AA-B3CAE0BDA320}" srcOrd="0" destOrd="0" presId="urn:microsoft.com/office/officeart/2005/8/layout/chevron2"/>
     <dgm:cxn modelId="{E89E6177-7CE3-47B2-8484-8B6732BDEECC}" srcId="{3BADAD2D-6184-474B-9930-EFCB1B5C7FE0}" destId="{0586F6F3-F6BC-42C3-A360-AC09FFF4B164}" srcOrd="0" destOrd="0" parTransId="{53715672-8D56-419C-81FB-4CFC02B78AF9}" sibTransId="{9C11CA2E-7C3F-4DFD-9E96-9D8CB2E57155}"/>
     <dgm:cxn modelId="{DE95B757-F4E6-4765-A3B2-B9AA5C177B36}" type="presOf" srcId="{E00F0641-6FE9-4B06-A486-203C921AF9F6}" destId="{B28987B3-919C-45F4-95A1-F0E90EE1BE74}" srcOrd="0" destOrd="0" presId="urn:microsoft.com/office/officeart/2005/8/layout/chevron2"/>
+    <dgm:cxn modelId="{87037B59-7E64-405D-A778-E7A9BA9C00AF}" type="presOf" srcId="{6A5213D9-4189-4405-8486-867A94BFBC61}" destId="{D279EA2D-C7D4-4A2D-B832-CE671E9A5420}" srcOrd="0" destOrd="0" presId="urn:microsoft.com/office/officeart/2005/8/layout/chevron2"/>
     <dgm:cxn modelId="{7E5AD77E-FFA0-477B-9B42-9415C97EE1E7}" srcId="{66732301-5E01-4D2E-8D29-5EA430D9DF9D}" destId="{9FE5993A-D9AF-4AEC-B763-794BAA96F210}" srcOrd="0" destOrd="0" parTransId="{6B701CC5-C354-4BE9-9B70-5BF4D8693D1F}" sibTransId="{802CE2D0-F916-405C-933D-88E22EE99DBD}"/>
-    <dgm:cxn modelId="{BCCC8F8C-D5B6-4C4E-A4E2-B00156461879}" srcId="{E00F0641-6FE9-4B06-A486-203C921AF9F6}" destId="{63D7A911-C7BD-4135-B458-BF039ED3972C}" srcOrd="5" destOrd="0" parTransId="{0DC05151-90C8-4CC0-B3A2-F6A5CC11B753}" sibTransId="{90728051-1B3B-477D-AD1E-63766DCA1D86}"/>
-    <dgm:cxn modelId="{E0A7C38C-8371-4D9B-B0EF-8E384BE8F288}" srcId="{E00F0641-6FE9-4B06-A486-203C921AF9F6}" destId="{D319ED06-36C1-477D-B2C4-14829CE6AED6}" srcOrd="0" destOrd="0" parTransId="{2B2997D2-C3E2-49C2-AFB1-3628A410B9E9}" sibTransId="{650DF0D4-1E0B-468C-9D87-63548C9BB44B}"/>
-    <dgm:cxn modelId="{C828258D-1B94-420E-B849-A6A6349747B0}" type="presOf" srcId="{EA1D8C68-6BDF-434D-9436-952ACA7F23BF}" destId="{DAE9D0B7-60EC-4A80-BFC1-C54B7FDE7B39}" srcOrd="0" destOrd="0" presId="urn:microsoft.com/office/officeart/2005/8/layout/chevron2"/>
+    <dgm:cxn modelId="{BCCC8F8C-D5B6-4C4E-A4E2-B00156461879}" srcId="{E00F0641-6FE9-4B06-A486-203C921AF9F6}" destId="{63D7A911-C7BD-4135-B458-BF039ED3972C}" srcOrd="6" destOrd="0" parTransId="{0DC05151-90C8-4CC0-B3A2-F6A5CC11B753}" sibTransId="{90728051-1B3B-477D-AD1E-63766DCA1D86}"/>
+    <dgm:cxn modelId="{E0A7C38C-8371-4D9B-B0EF-8E384BE8F288}" srcId="{E00F0641-6FE9-4B06-A486-203C921AF9F6}" destId="{D319ED06-36C1-477D-B2C4-14829CE6AED6}" srcOrd="1" destOrd="0" parTransId="{2B2997D2-C3E2-49C2-AFB1-3628A410B9E9}" sibTransId="{650DF0D4-1E0B-468C-9D87-63548C9BB44B}"/>
     <dgm:cxn modelId="{0111AD90-5E23-46AF-BFEF-0C617D72709A}" srcId="{EF5A87F7-9184-4338-B681-103AE7020E8F}" destId="{EA1D8C68-6BDF-434D-9436-952ACA7F23BF}" srcOrd="0" destOrd="0" parTransId="{2337C6F9-F175-44BD-B2A2-13491EE2478B}" sibTransId="{D896291E-03EE-41D3-AE3C-C28B77DCA8A2}"/>
-    <dgm:cxn modelId="{02E95694-258D-4381-8899-EB0828B67DA4}" type="presOf" srcId="{67B851F8-3514-4395-8791-E780F081A898}" destId="{CEEDEFDD-B88A-41A5-BB1B-D61F5FEED36F}" srcOrd="0" destOrd="0" presId="urn:microsoft.com/office/officeart/2005/8/layout/chevron2"/>
+    <dgm:cxn modelId="{067F1698-2FF4-479F-8140-CEDA6FAB0793}" type="presOf" srcId="{7C88B815-0664-4BBE-B655-01EC3A0B432E}" destId="{EAE7CF5D-BE4F-4BB2-821E-27277B2EEBFB}" srcOrd="0" destOrd="0" presId="urn:microsoft.com/office/officeart/2005/8/layout/chevron2"/>
     <dgm:cxn modelId="{50F1EE99-FADD-4D08-8FCF-B8629C5B6877}" srcId="{63D7A911-C7BD-4135-B458-BF039ED3972C}" destId="{67B851F8-3514-4395-8791-E780F081A898}" srcOrd="0" destOrd="0" parTransId="{9598DBF8-D8FC-41FD-A804-6F94BEBC7340}" sibTransId="{7E482457-FE29-490C-86B8-91FF5D25ADB4}"/>
-    <dgm:cxn modelId="{92C01AB1-C5D3-472C-A8F1-D9841AF51CAF}" srcId="{E00F0641-6FE9-4B06-A486-203C921AF9F6}" destId="{003C26E8-68FD-4340-B203-8836F4FAE147}" srcOrd="2" destOrd="0" parTransId="{198A8EA5-D80D-4F3C-AF74-4B0A97A589E4}" sibTransId="{0E09E75A-FC67-4B75-AA88-36A7FA5E8FC9}"/>
-    <dgm:cxn modelId="{B401D1B9-4C70-40F1-A467-32054DB38F22}" type="presOf" srcId="{2CF8132D-0BBD-4431-A3B3-7DAC277FCC4E}" destId="{2749BC35-B99E-4AF8-B81F-FC9C89E9AB83}" srcOrd="0" destOrd="0" presId="urn:microsoft.com/office/officeart/2005/8/layout/chevron2"/>
+    <dgm:cxn modelId="{2E8A0B9A-437B-42FD-B32D-638943457946}" type="presOf" srcId="{EA1D8C68-6BDF-434D-9436-952ACA7F23BF}" destId="{DAE9D0B7-60EC-4A80-BFC1-C54B7FDE7B39}" srcOrd="0" destOrd="0" presId="urn:microsoft.com/office/officeart/2005/8/layout/chevron2"/>
+    <dgm:cxn modelId="{6915F89F-5863-4900-A1AE-3150933E998F}" srcId="{361F74F0-2D03-474D-B91B-FE875CF5ED9A}" destId="{66B85507-ED1F-4365-B000-A5A8BDF9129B}" srcOrd="0" destOrd="0" parTransId="{45ABD367-49DE-4E22-8284-E58AFC079920}" sibTransId="{0796BBC6-76EA-474B-A4FB-0B20CBFC4AA1}"/>
+    <dgm:cxn modelId="{92C01AB1-C5D3-472C-A8F1-D9841AF51CAF}" srcId="{E00F0641-6FE9-4B06-A486-203C921AF9F6}" destId="{003C26E8-68FD-4340-B203-8836F4FAE147}" srcOrd="3" destOrd="0" parTransId="{198A8EA5-D80D-4F3C-AF74-4B0A97A589E4}" sibTransId="{0E09E75A-FC67-4B75-AA88-36A7FA5E8FC9}"/>
+    <dgm:cxn modelId="{1CDAE5B2-F58C-4698-86E7-E2C86EF5F69E}" type="presOf" srcId="{361F74F0-2D03-474D-B91B-FE875CF5ED9A}" destId="{B754CC4D-D8D5-45C0-B29A-A53032317F91}" srcOrd="0" destOrd="0" presId="urn:microsoft.com/office/officeart/2005/8/layout/chevron2"/>
+    <dgm:cxn modelId="{5E86B4B7-76C3-4160-92F2-D4E759224E88}" type="presOf" srcId="{3BADAD2D-6184-474B-9930-EFCB1B5C7FE0}" destId="{87BEBA03-C076-4656-9A59-6931769357D3}" srcOrd="0" destOrd="0" presId="urn:microsoft.com/office/officeart/2005/8/layout/chevron2"/>
+    <dgm:cxn modelId="{AAC892C0-AF66-4B42-A250-6782B17367D0}" type="presOf" srcId="{66B85507-ED1F-4365-B000-A5A8BDF9129B}" destId="{6D6E2A0C-1BA7-4A63-84A2-5A5FF93E87A8}" srcOrd="0" destOrd="0" presId="urn:microsoft.com/office/officeart/2005/8/layout/chevron2"/>
     <dgm:cxn modelId="{68AAC3C9-981D-44C6-A21D-7A549EC897DD}" srcId="{003C26E8-68FD-4340-B203-8836F4FAE147}" destId="{7C88B815-0664-4BBE-B655-01EC3A0B432E}" srcOrd="0" destOrd="0" parTransId="{8CE89CC4-6CCA-4E0C-9112-CF4D19E7071A}" sibTransId="{EF9B6500-142F-47F1-9096-4E269271988A}"/>
-    <dgm:cxn modelId="{E7FC8FE0-9272-4B6F-BBE1-856CD4BEBD55}" type="presOf" srcId="{3BADAD2D-6184-474B-9930-EFCB1B5C7FE0}" destId="{87BEBA03-C076-4656-9A59-6931769357D3}" srcOrd="0" destOrd="0" presId="urn:microsoft.com/office/officeart/2005/8/layout/chevron2"/>
-    <dgm:cxn modelId="{4DBC5DE9-BB63-47BA-AE01-55125D27D921}" type="presOf" srcId="{003C26E8-68FD-4340-B203-8836F4FAE147}" destId="{E1632E70-2FF3-409A-B038-7AEB0326704A}" srcOrd="0" destOrd="0" presId="urn:microsoft.com/office/officeart/2005/8/layout/chevron2"/>
-    <dgm:cxn modelId="{15DA93E8-9262-49BB-917F-7B5E2ECB0D09}" type="presParOf" srcId="{B28987B3-919C-45F4-95A1-F0E90EE1BE74}" destId="{7DAF7208-6CFC-499C-B241-6F6850B44715}" srcOrd="0" destOrd="0" presId="urn:microsoft.com/office/officeart/2005/8/layout/chevron2"/>
-    <dgm:cxn modelId="{8125402D-296D-47E4-B354-D8F1E576A4C9}" type="presParOf" srcId="{7DAF7208-6CFC-499C-B241-6F6850B44715}" destId="{B95750CF-B3B9-4E5B-9E01-CAE67414321B}" srcOrd="0" destOrd="0" presId="urn:microsoft.com/office/officeart/2005/8/layout/chevron2"/>
-    <dgm:cxn modelId="{D6CA74E8-BC2D-4793-8AF8-21431AE8AEB1}" type="presParOf" srcId="{7DAF7208-6CFC-499C-B241-6F6850B44715}" destId="{2749BC35-B99E-4AF8-B81F-FC9C89E9AB83}" srcOrd="1" destOrd="0" presId="urn:microsoft.com/office/officeart/2005/8/layout/chevron2"/>
-    <dgm:cxn modelId="{A1DA065B-E1B5-4592-8501-4A1F80B789D4}" type="presParOf" srcId="{B28987B3-919C-45F4-95A1-F0E90EE1BE74}" destId="{8838469F-8A58-400D-96A0-206970F57BFE}" srcOrd="1" destOrd="0" presId="urn:microsoft.com/office/officeart/2005/8/layout/chevron2"/>
-    <dgm:cxn modelId="{4911F63E-F9EF-4AEE-B469-8BCA580EFB17}" type="presParOf" srcId="{B28987B3-919C-45F4-95A1-F0E90EE1BE74}" destId="{B5B048BA-DB10-452F-B74A-13944E75C1EF}" srcOrd="2" destOrd="0" presId="urn:microsoft.com/office/officeart/2005/8/layout/chevron2"/>
-    <dgm:cxn modelId="{C4CAD166-3888-4D28-845B-BDA317AA6215}" type="presParOf" srcId="{B5B048BA-DB10-452F-B74A-13944E75C1EF}" destId="{89BAFE56-39DE-40A4-B59E-AF9C5C343566}" srcOrd="0" destOrd="0" presId="urn:microsoft.com/office/officeart/2005/8/layout/chevron2"/>
-    <dgm:cxn modelId="{47E3289B-9BF2-44A6-B9E4-A8A33706F540}" type="presParOf" srcId="{B5B048BA-DB10-452F-B74A-13944E75C1EF}" destId="{D279EA2D-C7D4-4A2D-B832-CE671E9A5420}" srcOrd="1" destOrd="0" presId="urn:microsoft.com/office/officeart/2005/8/layout/chevron2"/>
-    <dgm:cxn modelId="{34A8D6D4-5834-4F5D-8865-F435330FA4FC}" type="presParOf" srcId="{B28987B3-919C-45F4-95A1-F0E90EE1BE74}" destId="{8D133DEE-951D-4B48-AAEE-B3D5B58CA56E}" srcOrd="3" destOrd="0" presId="urn:microsoft.com/office/officeart/2005/8/layout/chevron2"/>
-    <dgm:cxn modelId="{332DF84A-784B-4A53-A563-6FED19018E31}" type="presParOf" srcId="{B28987B3-919C-45F4-95A1-F0E90EE1BE74}" destId="{81A5B30C-8061-4A02-A985-249375B9855D}" srcOrd="4" destOrd="0" presId="urn:microsoft.com/office/officeart/2005/8/layout/chevron2"/>
-    <dgm:cxn modelId="{48952167-B5A6-44E5-9550-47F6F0B399C9}" type="presParOf" srcId="{81A5B30C-8061-4A02-A985-249375B9855D}" destId="{E1632E70-2FF3-409A-B038-7AEB0326704A}" srcOrd="0" destOrd="0" presId="urn:microsoft.com/office/officeart/2005/8/layout/chevron2"/>
-    <dgm:cxn modelId="{494282AA-1169-44AB-AB6E-55F47EC6F38C}" type="presParOf" srcId="{81A5B30C-8061-4A02-A985-249375B9855D}" destId="{EAE7CF5D-BE4F-4BB2-821E-27277B2EEBFB}" srcOrd="1" destOrd="0" presId="urn:microsoft.com/office/officeart/2005/8/layout/chevron2"/>
-    <dgm:cxn modelId="{B3B2773C-530F-4530-BF1F-6646A9E2EC55}" type="presParOf" srcId="{B28987B3-919C-45F4-95A1-F0E90EE1BE74}" destId="{3CBF3577-2569-47F4-B3D8-7CD558CA837D}" srcOrd="5" destOrd="0" presId="urn:microsoft.com/office/officeart/2005/8/layout/chevron2"/>
-    <dgm:cxn modelId="{35C2FAE8-86C2-4E7E-95D9-FA3DF92E4472}" type="presParOf" srcId="{B28987B3-919C-45F4-95A1-F0E90EE1BE74}" destId="{7A193688-B83E-46A4-9E22-2906D5695288}" srcOrd="6" destOrd="0" presId="urn:microsoft.com/office/officeart/2005/8/layout/chevron2"/>
-    <dgm:cxn modelId="{D1BB6D89-9073-4FE0-A192-EA59B7EB76B7}" type="presParOf" srcId="{7A193688-B83E-46A4-9E22-2906D5695288}" destId="{600F4A9E-2A62-476E-9727-BFFBBFC2BF53}" srcOrd="0" destOrd="0" presId="urn:microsoft.com/office/officeart/2005/8/layout/chevron2"/>
-    <dgm:cxn modelId="{93B6F31A-B4DD-4A8B-AB5E-E4D6CB487331}" type="presParOf" srcId="{7A193688-B83E-46A4-9E22-2906D5695288}" destId="{DAE9D0B7-60EC-4A80-BFC1-C54B7FDE7B39}" srcOrd="1" destOrd="0" presId="urn:microsoft.com/office/officeart/2005/8/layout/chevron2"/>
-    <dgm:cxn modelId="{631D7BD3-5C47-4A35-BC1C-36C802E8A561}" type="presParOf" srcId="{B28987B3-919C-45F4-95A1-F0E90EE1BE74}" destId="{CEAF9465-59E2-4ACF-85C6-7947AF0A899C}" srcOrd="7" destOrd="0" presId="urn:microsoft.com/office/officeart/2005/8/layout/chevron2"/>
-    <dgm:cxn modelId="{99D41F48-B4E2-4787-A4E3-1694B9792607}" type="presParOf" srcId="{B28987B3-919C-45F4-95A1-F0E90EE1BE74}" destId="{E3A258C4-B3A6-4DA3-82BE-2E707DA5BE27}" srcOrd="8" destOrd="0" presId="urn:microsoft.com/office/officeart/2005/8/layout/chevron2"/>
-    <dgm:cxn modelId="{93A266C9-5DDB-4091-89D0-9027943AE24D}" type="presParOf" srcId="{E3A258C4-B3A6-4DA3-82BE-2E707DA5BE27}" destId="{87BEBA03-C076-4656-9A59-6931769357D3}" srcOrd="0" destOrd="0" presId="urn:microsoft.com/office/officeart/2005/8/layout/chevron2"/>
-    <dgm:cxn modelId="{BC098177-74A9-484C-9C22-B1C539F1AE8F}" type="presParOf" srcId="{E3A258C4-B3A6-4DA3-82BE-2E707DA5BE27}" destId="{E914C9C4-1E45-4BE2-B20B-6FFE9FEF7EBC}" srcOrd="1" destOrd="0" presId="urn:microsoft.com/office/officeart/2005/8/layout/chevron2"/>
-    <dgm:cxn modelId="{E5D5B48A-9168-4BBE-9062-9A23D93C9CE4}" type="presParOf" srcId="{B28987B3-919C-45F4-95A1-F0E90EE1BE74}" destId="{F6DC4926-054B-416A-8733-0F533C144A55}" srcOrd="9" destOrd="0" presId="urn:microsoft.com/office/officeart/2005/8/layout/chevron2"/>
-    <dgm:cxn modelId="{B9AB4E5E-91A9-4930-9308-950347C71CE2}" type="presParOf" srcId="{B28987B3-919C-45F4-95A1-F0E90EE1BE74}" destId="{19A10A6E-31B9-4435-95B0-6831F76FB26E}" srcOrd="10" destOrd="0" presId="urn:microsoft.com/office/officeart/2005/8/layout/chevron2"/>
-    <dgm:cxn modelId="{6825A401-18BB-4BFC-A9B9-23277F23734D}" type="presParOf" srcId="{19A10A6E-31B9-4435-95B0-6831F76FB26E}" destId="{71A5F4AA-3510-4A80-95AA-B3CAE0BDA320}" srcOrd="0" destOrd="0" presId="urn:microsoft.com/office/officeart/2005/8/layout/chevron2"/>
-    <dgm:cxn modelId="{779B4FE5-B2CB-41C7-BA76-F61E3B4B3B71}" type="presParOf" srcId="{19A10A6E-31B9-4435-95B0-6831F76FB26E}" destId="{CEEDEFDD-B88A-41A5-BB1B-D61F5FEED36F}" srcOrd="1" destOrd="0" presId="urn:microsoft.com/office/officeart/2005/8/layout/chevron2"/>
-    <dgm:cxn modelId="{D4D9A970-1828-4835-9353-5824B3253BC6}" type="presParOf" srcId="{B28987B3-919C-45F4-95A1-F0E90EE1BE74}" destId="{3CCF01AA-A07D-41DA-AEC4-99C040515B4D}" srcOrd="11" destOrd="0" presId="urn:microsoft.com/office/officeart/2005/8/layout/chevron2"/>
-    <dgm:cxn modelId="{00F229D9-40C5-42E1-970E-A12F65189405}" type="presParOf" srcId="{B28987B3-919C-45F4-95A1-F0E90EE1BE74}" destId="{4C5AABE1-14B5-4E00-8A09-2622A5AF9465}" srcOrd="12" destOrd="0" presId="urn:microsoft.com/office/officeart/2005/8/layout/chevron2"/>
-    <dgm:cxn modelId="{7027B1E7-9458-442E-8E79-6DE0316F27D4}" type="presParOf" srcId="{4C5AABE1-14B5-4E00-8A09-2622A5AF9465}" destId="{7086D58B-66BB-48EF-9B71-F024F3911F29}" srcOrd="0" destOrd="0" presId="urn:microsoft.com/office/officeart/2005/8/layout/chevron2"/>
-    <dgm:cxn modelId="{D1195186-22DE-462C-9253-D3A71EAEAEDF}" type="presParOf" srcId="{4C5AABE1-14B5-4E00-8A09-2622A5AF9465}" destId="{9831EBFE-52E3-4421-8DB6-43CE44ABBB9E}" srcOrd="1" destOrd="0" presId="urn:microsoft.com/office/officeart/2005/8/layout/chevron2"/>
+    <dgm:cxn modelId="{362285CD-FA20-4DEF-ABAE-49381FFE9A5B}" type="presOf" srcId="{D319ED06-36C1-477D-B2C4-14829CE6AED6}" destId="{B95750CF-B3B9-4E5B-9E01-CAE67414321B}" srcOrd="0" destOrd="0" presId="urn:microsoft.com/office/officeart/2005/8/layout/chevron2"/>
+    <dgm:cxn modelId="{47E5AED4-6B6B-4480-A051-61FD02C63FC6}" type="presOf" srcId="{0586F6F3-F6BC-42C3-A360-AC09FFF4B164}" destId="{E914C9C4-1E45-4BE2-B20B-6FFE9FEF7EBC}" srcOrd="0" destOrd="0" presId="urn:microsoft.com/office/officeart/2005/8/layout/chevron2"/>
+    <dgm:cxn modelId="{D4826ADE-DF25-4135-89B1-61F5E113A54B}" type="presOf" srcId="{FD175BB3-DE6D-4A45-BDA6-9A6682EA910D}" destId="{89BAFE56-39DE-40A4-B59E-AF9C5C343566}" srcOrd="0" destOrd="0" presId="urn:microsoft.com/office/officeart/2005/8/layout/chevron2"/>
+    <dgm:cxn modelId="{2C7F85EF-77B9-4D7A-B2EA-63EC59E63F1C}" type="presOf" srcId="{9FE5993A-D9AF-4AEC-B763-794BAA96F210}" destId="{9831EBFE-52E3-4421-8DB6-43CE44ABBB9E}" srcOrd="0" destOrd="0" presId="urn:microsoft.com/office/officeart/2005/8/layout/chevron2"/>
+    <dgm:cxn modelId="{5C1963F3-38B9-410D-B002-2D099576114C}" type="presOf" srcId="{2CF8132D-0BBD-4431-A3B3-7DAC277FCC4E}" destId="{2749BC35-B99E-4AF8-B81F-FC9C89E9AB83}" srcOrd="0" destOrd="0" presId="urn:microsoft.com/office/officeart/2005/8/layout/chevron2"/>
+    <dgm:cxn modelId="{153CBFE2-46CF-43FE-A9A7-5E11DF279D2E}" type="presParOf" srcId="{B28987B3-919C-45F4-95A1-F0E90EE1BE74}" destId="{E4FAB94E-C29E-4AC6-8631-D35743AEFFF4}" srcOrd="0" destOrd="0" presId="urn:microsoft.com/office/officeart/2005/8/layout/chevron2"/>
+    <dgm:cxn modelId="{8B0B9108-B01F-4EF4-93AC-57D49D10EDC2}" type="presParOf" srcId="{E4FAB94E-C29E-4AC6-8631-D35743AEFFF4}" destId="{B754CC4D-D8D5-45C0-B29A-A53032317F91}" srcOrd="0" destOrd="0" presId="urn:microsoft.com/office/officeart/2005/8/layout/chevron2"/>
+    <dgm:cxn modelId="{B3F1A462-D08E-4B1A-8721-4CA032DD49A0}" type="presParOf" srcId="{E4FAB94E-C29E-4AC6-8631-D35743AEFFF4}" destId="{6D6E2A0C-1BA7-4A63-84A2-5A5FF93E87A8}" srcOrd="1" destOrd="0" presId="urn:microsoft.com/office/officeart/2005/8/layout/chevron2"/>
+    <dgm:cxn modelId="{28CC20BB-4143-4277-9C65-CAE96EBEA65D}" type="presParOf" srcId="{B28987B3-919C-45F4-95A1-F0E90EE1BE74}" destId="{BCD80044-DE74-4C0E-853E-59AB6D2B6096}" srcOrd="1" destOrd="0" presId="urn:microsoft.com/office/officeart/2005/8/layout/chevron2"/>
+    <dgm:cxn modelId="{FD262B99-D9BC-4816-963A-77F069553B89}" type="presParOf" srcId="{B28987B3-919C-45F4-95A1-F0E90EE1BE74}" destId="{7DAF7208-6CFC-499C-B241-6F6850B44715}" srcOrd="2" destOrd="0" presId="urn:microsoft.com/office/officeart/2005/8/layout/chevron2"/>
+    <dgm:cxn modelId="{F2F6A394-E13E-49DA-9F40-EEB0D71B43D8}" type="presParOf" srcId="{7DAF7208-6CFC-499C-B241-6F6850B44715}" destId="{B95750CF-B3B9-4E5B-9E01-CAE67414321B}" srcOrd="0" destOrd="0" presId="urn:microsoft.com/office/officeart/2005/8/layout/chevron2"/>
+    <dgm:cxn modelId="{8B06BFD8-09AA-42CD-9772-D97E97AA7E35}" type="presParOf" srcId="{7DAF7208-6CFC-499C-B241-6F6850B44715}" destId="{2749BC35-B99E-4AF8-B81F-FC9C89E9AB83}" srcOrd="1" destOrd="0" presId="urn:microsoft.com/office/officeart/2005/8/layout/chevron2"/>
+    <dgm:cxn modelId="{AC49B6C6-6E85-4E44-83A0-42108590707E}" type="presParOf" srcId="{B28987B3-919C-45F4-95A1-F0E90EE1BE74}" destId="{8838469F-8A58-400D-96A0-206970F57BFE}" srcOrd="3" destOrd="0" presId="urn:microsoft.com/office/officeart/2005/8/layout/chevron2"/>
+    <dgm:cxn modelId="{951A7EBA-B614-42DB-B7ED-CFD3F2102999}" type="presParOf" srcId="{B28987B3-919C-45F4-95A1-F0E90EE1BE74}" destId="{B5B048BA-DB10-452F-B74A-13944E75C1EF}" srcOrd="4" destOrd="0" presId="urn:microsoft.com/office/officeart/2005/8/layout/chevron2"/>
+    <dgm:cxn modelId="{341FB5A4-1147-4904-8671-24A9C6F9E4AA}" type="presParOf" srcId="{B5B048BA-DB10-452F-B74A-13944E75C1EF}" destId="{89BAFE56-39DE-40A4-B59E-AF9C5C343566}" srcOrd="0" destOrd="0" presId="urn:microsoft.com/office/officeart/2005/8/layout/chevron2"/>
+    <dgm:cxn modelId="{F8E8F531-B4E2-43EF-96B4-1CEA85B1F6FB}" type="presParOf" srcId="{B5B048BA-DB10-452F-B74A-13944E75C1EF}" destId="{D279EA2D-C7D4-4A2D-B832-CE671E9A5420}" srcOrd="1" destOrd="0" presId="urn:microsoft.com/office/officeart/2005/8/layout/chevron2"/>
+    <dgm:cxn modelId="{B4F295E4-66D2-4E0B-95BC-787551C5B3EA}" type="presParOf" srcId="{B28987B3-919C-45F4-95A1-F0E90EE1BE74}" destId="{8D133DEE-951D-4B48-AAEE-B3D5B58CA56E}" srcOrd="5" destOrd="0" presId="urn:microsoft.com/office/officeart/2005/8/layout/chevron2"/>
+    <dgm:cxn modelId="{EC3D6E5F-67A1-4AA7-853B-E46E9D66E4B4}" type="presParOf" srcId="{B28987B3-919C-45F4-95A1-F0E90EE1BE74}" destId="{81A5B30C-8061-4A02-A985-249375B9855D}" srcOrd="6" destOrd="0" presId="urn:microsoft.com/office/officeart/2005/8/layout/chevron2"/>
+    <dgm:cxn modelId="{DB931137-E3CC-4B06-96C6-3157413D620D}" type="presParOf" srcId="{81A5B30C-8061-4A02-A985-249375B9855D}" destId="{E1632E70-2FF3-409A-B038-7AEB0326704A}" srcOrd="0" destOrd="0" presId="urn:microsoft.com/office/officeart/2005/8/layout/chevron2"/>
+    <dgm:cxn modelId="{DA1958F8-632A-49DC-8180-20B26A458EA9}" type="presParOf" srcId="{81A5B30C-8061-4A02-A985-249375B9855D}" destId="{EAE7CF5D-BE4F-4BB2-821E-27277B2EEBFB}" srcOrd="1" destOrd="0" presId="urn:microsoft.com/office/officeart/2005/8/layout/chevron2"/>
+    <dgm:cxn modelId="{013D25FD-2970-4BA1-9ACA-43D5FFCF1A2C}" type="presParOf" srcId="{B28987B3-919C-45F4-95A1-F0E90EE1BE74}" destId="{3CBF3577-2569-47F4-B3D8-7CD558CA837D}" srcOrd="7" destOrd="0" presId="urn:microsoft.com/office/officeart/2005/8/layout/chevron2"/>
+    <dgm:cxn modelId="{7616954A-6552-42B6-A3E0-F0584D72B406}" type="presParOf" srcId="{B28987B3-919C-45F4-95A1-F0E90EE1BE74}" destId="{7A193688-B83E-46A4-9E22-2906D5695288}" srcOrd="8" destOrd="0" presId="urn:microsoft.com/office/officeart/2005/8/layout/chevron2"/>
+    <dgm:cxn modelId="{A1CB90B0-598C-4716-A564-E2435356B50A}" type="presParOf" srcId="{7A193688-B83E-46A4-9E22-2906D5695288}" destId="{600F4A9E-2A62-476E-9727-BFFBBFC2BF53}" srcOrd="0" destOrd="0" presId="urn:microsoft.com/office/officeart/2005/8/layout/chevron2"/>
+    <dgm:cxn modelId="{3CFCBC71-B9D9-488D-85C2-252FD8E52D7C}" type="presParOf" srcId="{7A193688-B83E-46A4-9E22-2906D5695288}" destId="{DAE9D0B7-60EC-4A80-BFC1-C54B7FDE7B39}" srcOrd="1" destOrd="0" presId="urn:microsoft.com/office/officeart/2005/8/layout/chevron2"/>
+    <dgm:cxn modelId="{CB34ABE4-A8AF-4B43-A408-71673621581B}" type="presParOf" srcId="{B28987B3-919C-45F4-95A1-F0E90EE1BE74}" destId="{CEAF9465-59E2-4ACF-85C6-7947AF0A899C}" srcOrd="9" destOrd="0" presId="urn:microsoft.com/office/officeart/2005/8/layout/chevron2"/>
+    <dgm:cxn modelId="{5AF05666-CF96-4CB6-B36D-5A5AF6B5A2B3}" type="presParOf" srcId="{B28987B3-919C-45F4-95A1-F0E90EE1BE74}" destId="{E3A258C4-B3A6-4DA3-82BE-2E707DA5BE27}" srcOrd="10" destOrd="0" presId="urn:microsoft.com/office/officeart/2005/8/layout/chevron2"/>
+    <dgm:cxn modelId="{9C02E608-3E44-4ACA-AADD-9D1A2161BFD7}" type="presParOf" srcId="{E3A258C4-B3A6-4DA3-82BE-2E707DA5BE27}" destId="{87BEBA03-C076-4656-9A59-6931769357D3}" srcOrd="0" destOrd="0" presId="urn:microsoft.com/office/officeart/2005/8/layout/chevron2"/>
+    <dgm:cxn modelId="{1D2DF422-A45A-46FC-A4CA-B994BEAD3E0A}" type="presParOf" srcId="{E3A258C4-B3A6-4DA3-82BE-2E707DA5BE27}" destId="{E914C9C4-1E45-4BE2-B20B-6FFE9FEF7EBC}" srcOrd="1" destOrd="0" presId="urn:microsoft.com/office/officeart/2005/8/layout/chevron2"/>
+    <dgm:cxn modelId="{E3601573-1D56-4B89-90BB-0B6DCC21208E}" type="presParOf" srcId="{B28987B3-919C-45F4-95A1-F0E90EE1BE74}" destId="{F6DC4926-054B-416A-8733-0F533C144A55}" srcOrd="11" destOrd="0" presId="urn:microsoft.com/office/officeart/2005/8/layout/chevron2"/>
+    <dgm:cxn modelId="{1F215419-6A94-48B2-B747-3A1C3C2F3F06}" type="presParOf" srcId="{B28987B3-919C-45F4-95A1-F0E90EE1BE74}" destId="{19A10A6E-31B9-4435-95B0-6831F76FB26E}" srcOrd="12" destOrd="0" presId="urn:microsoft.com/office/officeart/2005/8/layout/chevron2"/>
+    <dgm:cxn modelId="{0E81F4F9-7793-48FC-A14E-37A680B57E92}" type="presParOf" srcId="{19A10A6E-31B9-4435-95B0-6831F76FB26E}" destId="{71A5F4AA-3510-4A80-95AA-B3CAE0BDA320}" srcOrd="0" destOrd="0" presId="urn:microsoft.com/office/officeart/2005/8/layout/chevron2"/>
+    <dgm:cxn modelId="{4266E65D-C626-4999-B55B-9943F394B097}" type="presParOf" srcId="{19A10A6E-31B9-4435-95B0-6831F76FB26E}" destId="{CEEDEFDD-B88A-41A5-BB1B-D61F5FEED36F}" srcOrd="1" destOrd="0" presId="urn:microsoft.com/office/officeart/2005/8/layout/chevron2"/>
+    <dgm:cxn modelId="{7BE8D63A-C9B8-4877-BD4C-65C9591CD703}" type="presParOf" srcId="{B28987B3-919C-45F4-95A1-F0E90EE1BE74}" destId="{3CCF01AA-A07D-41DA-AEC4-99C040515B4D}" srcOrd="13" destOrd="0" presId="urn:microsoft.com/office/officeart/2005/8/layout/chevron2"/>
+    <dgm:cxn modelId="{863B03EC-799A-4A42-8EE6-2971C5D0FA6A}" type="presParOf" srcId="{B28987B3-919C-45F4-95A1-F0E90EE1BE74}" destId="{4C5AABE1-14B5-4E00-8A09-2622A5AF9465}" srcOrd="14" destOrd="0" presId="urn:microsoft.com/office/officeart/2005/8/layout/chevron2"/>
+    <dgm:cxn modelId="{47DDD756-1BE4-43B8-9E24-EF0370E2235A}" type="presParOf" srcId="{4C5AABE1-14B5-4E00-8A09-2622A5AF9465}" destId="{7086D58B-66BB-48EF-9B71-F024F3911F29}" srcOrd="0" destOrd="0" presId="urn:microsoft.com/office/officeart/2005/8/layout/chevron2"/>
+    <dgm:cxn modelId="{DA6364E7-9B51-4EC0-A290-6DB2950BAAA4}" type="presParOf" srcId="{4C5AABE1-14B5-4E00-8A09-2622A5AF9465}" destId="{9831EBFE-52E3-4421-8DB6-43CE44ABBB9E}" srcOrd="1" destOrd="0" presId="urn:microsoft.com/office/officeart/2005/8/layout/chevron2"/>
   </dgm:cxnLst>
   <dgm:bg/>
   <dgm:whole/>
@@ -1681,15 +1811,15 @@
       <dsp:cNvGrpSpPr/>
     </dsp:nvGrpSpPr>
     <dsp:grpSpPr/>
-    <dsp:sp modelId="{B95750CF-B3B9-4E5B-9E01-CAE67414321B}">
+    <dsp:sp modelId="{B754CC4D-D8D5-45C0-B29A-A53032317F91}">
       <dsp:nvSpPr>
         <dsp:cNvPr id="0" name=""/>
         <dsp:cNvSpPr/>
       </dsp:nvSpPr>
       <dsp:spPr>
         <a:xfrm rot="5400000">
-          <a:off x="-73291" y="75039"/>
-          <a:ext cx="488609" cy="342026"/>
+          <a:off x="-64887" y="67263"/>
+          <a:ext cx="432585" cy="302809"/>
         </a:xfrm>
         <a:prstGeom prst="chevron">
           <a:avLst/>
@@ -1730,12 +1860,12 @@
         </a:fontRef>
       </dsp:style>
       <dsp:txBody>
-        <a:bodyPr spcFirstLastPara="0" vert="horz" wrap="square" lIns="5715" tIns="5715" rIns="5715" bIns="5715" numCol="1" spcCol="1270" anchor="ctr" anchorCtr="0">
+        <a:bodyPr spcFirstLastPara="0" vert="horz" wrap="square" lIns="5080" tIns="5080" rIns="5080" bIns="5080" numCol="1" spcCol="1270" anchor="ctr" anchorCtr="0">
           <a:noAutofit/>
         </a:bodyPr>
         <a:lstStyle/>
         <a:p>
-          <a:pPr marL="0" lvl="0" indent="0" algn="ctr" defTabSz="400050">
+          <a:pPr marL="0" lvl="0" indent="0" algn="ctr" defTabSz="355600">
             <a:lnSpc>
               <a:spcPct val="90000"/>
             </a:lnSpc>
@@ -1747,27 +1877,23 @@
             </a:spcAft>
             <a:buNone/>
           </a:pPr>
-          <a:r>
-            <a:rPr lang="en-US" sz="900" b="1" kern="1200" dirty="0"/>
-            <a:t>STEP 1</a:t>
-          </a:r>
-          <a:endParaRPr lang="en-GY" sz="900" b="1" kern="1200" dirty="0"/>
+          <a:endParaRPr lang="en-GY" sz="800" kern="1200"/>
         </a:p>
       </dsp:txBody>
       <dsp:txXfrm rot="-5400000">
-        <a:off x="1" y="172760"/>
-        <a:ext cx="342026" cy="146583"/>
+        <a:off x="2" y="153780"/>
+        <a:ext cx="302809" cy="129776"/>
       </dsp:txXfrm>
     </dsp:sp>
-    <dsp:sp modelId="{2749BC35-B99E-4AF8-B81F-FC9C89E9AB83}">
+    <dsp:sp modelId="{6D6E2A0C-1BA7-4A63-84A2-5A5FF93E87A8}">
       <dsp:nvSpPr>
         <dsp:cNvPr id="0" name=""/>
         <dsp:cNvSpPr/>
       </dsp:nvSpPr>
       <dsp:spPr>
         <a:xfrm rot="5400000">
-          <a:off x="2145414" y="-1801640"/>
-          <a:ext cx="317595" cy="3924372"/>
+          <a:off x="2410953" y="-2105767"/>
+          <a:ext cx="281180" cy="4497467"/>
         </a:xfrm>
         <a:prstGeom prst="round2SameRect">
           <a:avLst/>
@@ -1826,25 +1952,29 @@
           </a:pPr>
           <a:r>
             <a:rPr lang="en-US" sz="2000" kern="1200" dirty="0"/>
-            <a:t>01_ingest.R</a:t>
+            <a:t>00_config.R –</a:t>
           </a:r>
-          <a:endParaRPr lang="en-GY" sz="2000" kern="1200" dirty="0"/>
+          <a:r>
+            <a:rPr lang="en-US" sz="1400" kern="1200" dirty="0"/>
+            <a:t> global paths and settings</a:t>
+          </a:r>
+          <a:endParaRPr lang="en-GY" sz="1400" kern="1200" dirty="0"/>
         </a:p>
       </dsp:txBody>
       <dsp:txXfrm rot="-5400000">
-        <a:off x="342026" y="17252"/>
-        <a:ext cx="3908868" cy="286587"/>
+        <a:off x="302810" y="16102"/>
+        <a:ext cx="4483741" cy="253728"/>
       </dsp:txXfrm>
     </dsp:sp>
-    <dsp:sp modelId="{89BAFE56-39DE-40A4-B59E-AF9C5C343566}">
+    <dsp:sp modelId="{B95750CF-B3B9-4E5B-9E01-CAE67414321B}">
       <dsp:nvSpPr>
         <dsp:cNvPr id="0" name=""/>
         <dsp:cNvSpPr/>
       </dsp:nvSpPr>
       <dsp:spPr>
         <a:xfrm rot="5400000">
-          <a:off x="-73291" y="477612"/>
-          <a:ext cx="488609" cy="342026"/>
+          <a:off x="-64887" y="420150"/>
+          <a:ext cx="432585" cy="302809"/>
         </a:xfrm>
         <a:prstGeom prst="chevron">
           <a:avLst/>
@@ -1885,12 +2015,12 @@
         </a:fontRef>
       </dsp:style>
       <dsp:txBody>
-        <a:bodyPr spcFirstLastPara="0" vert="horz" wrap="square" lIns="5715" tIns="5715" rIns="5715" bIns="5715" numCol="1" spcCol="1270" anchor="ctr" anchorCtr="0">
+        <a:bodyPr spcFirstLastPara="0" vert="horz" wrap="square" lIns="5080" tIns="5080" rIns="5080" bIns="5080" numCol="1" spcCol="1270" anchor="ctr" anchorCtr="0">
           <a:noAutofit/>
         </a:bodyPr>
         <a:lstStyle/>
         <a:p>
-          <a:pPr marL="0" lvl="0" indent="0" algn="ctr" defTabSz="400050">
+          <a:pPr marL="0" lvl="0" indent="0" algn="ctr" defTabSz="355600">
             <a:lnSpc>
               <a:spcPct val="90000"/>
             </a:lnSpc>
@@ -1903,26 +2033,26 @@
             <a:buNone/>
           </a:pPr>
           <a:r>
-            <a:rPr lang="en-US" sz="900" b="1" kern="1200" dirty="0"/>
-            <a:t>STEP 2</a:t>
+            <a:rPr lang="en-US" sz="800" b="1" kern="1200" dirty="0"/>
+            <a:t>STEP 1</a:t>
           </a:r>
-          <a:endParaRPr lang="en-GY" sz="900" b="1" kern="1200" dirty="0"/>
+          <a:endParaRPr lang="en-GY" sz="800" b="1" kern="1200" dirty="0"/>
         </a:p>
       </dsp:txBody>
       <dsp:txXfrm rot="-5400000">
-        <a:off x="1" y="575333"/>
-        <a:ext cx="342026" cy="146583"/>
+        <a:off x="2" y="506667"/>
+        <a:ext cx="302809" cy="129776"/>
       </dsp:txXfrm>
     </dsp:sp>
-    <dsp:sp modelId="{D279EA2D-C7D4-4A2D-B832-CE671E9A5420}">
+    <dsp:sp modelId="{2749BC35-B99E-4AF8-B81F-FC9C89E9AB83}">
       <dsp:nvSpPr>
         <dsp:cNvPr id="0" name=""/>
         <dsp:cNvSpPr/>
       </dsp:nvSpPr>
       <dsp:spPr>
         <a:xfrm rot="5400000">
-          <a:off x="2145414" y="-1399067"/>
-          <a:ext cx="317595" cy="3924372"/>
+          <a:off x="2410953" y="-1752880"/>
+          <a:ext cx="281180" cy="4497467"/>
         </a:xfrm>
         <a:prstGeom prst="round2SameRect">
           <a:avLst/>
@@ -1981,25 +2111,29 @@
           </a:pPr>
           <a:r>
             <a:rPr lang="en-US" sz="2000" kern="1200" dirty="0"/>
-            <a:t>02_diagnose.R </a:t>
+            <a:t>01_ingest.R – </a:t>
+          </a:r>
+          <a:r>
+            <a:rPr lang="en-US" sz="1400" kern="1200" dirty="0"/>
+            <a:t>data ingestion &amp; validation</a:t>
           </a:r>
           <a:endParaRPr lang="en-GY" sz="2000" kern="1200" dirty="0"/>
         </a:p>
       </dsp:txBody>
       <dsp:txXfrm rot="-5400000">
-        <a:off x="342026" y="419825"/>
-        <a:ext cx="3908868" cy="286587"/>
+        <a:off x="302810" y="368989"/>
+        <a:ext cx="4483741" cy="253728"/>
       </dsp:txXfrm>
     </dsp:sp>
-    <dsp:sp modelId="{E1632E70-2FF3-409A-B038-7AEB0326704A}">
+    <dsp:sp modelId="{89BAFE56-39DE-40A4-B59E-AF9C5C343566}">
       <dsp:nvSpPr>
         <dsp:cNvPr id="0" name=""/>
         <dsp:cNvSpPr/>
       </dsp:nvSpPr>
       <dsp:spPr>
         <a:xfrm rot="5400000">
-          <a:off x="-73291" y="880186"/>
-          <a:ext cx="488609" cy="342026"/>
+          <a:off x="-64887" y="773037"/>
+          <a:ext cx="432585" cy="302809"/>
         </a:xfrm>
         <a:prstGeom prst="chevron">
           <a:avLst/>
@@ -2040,12 +2174,12 @@
         </a:fontRef>
       </dsp:style>
       <dsp:txBody>
-        <a:bodyPr spcFirstLastPara="0" vert="horz" wrap="square" lIns="5715" tIns="5715" rIns="5715" bIns="5715" numCol="1" spcCol="1270" anchor="ctr" anchorCtr="0">
+        <a:bodyPr spcFirstLastPara="0" vert="horz" wrap="square" lIns="5080" tIns="5080" rIns="5080" bIns="5080" numCol="1" spcCol="1270" anchor="ctr" anchorCtr="0">
           <a:noAutofit/>
         </a:bodyPr>
         <a:lstStyle/>
         <a:p>
-          <a:pPr marL="0" lvl="0" indent="0" algn="ctr" defTabSz="400050">
+          <a:pPr marL="0" lvl="0" indent="0" algn="ctr" defTabSz="355600">
             <a:lnSpc>
               <a:spcPct val="90000"/>
             </a:lnSpc>
@@ -2058,26 +2192,26 @@
             <a:buNone/>
           </a:pPr>
           <a:r>
-            <a:rPr lang="en-US" sz="900" b="1" kern="1200" dirty="0"/>
-            <a:t>STEP 3</a:t>
+            <a:rPr lang="en-US" sz="800" b="1" kern="1200" dirty="0"/>
+            <a:t>STEP 2</a:t>
           </a:r>
-          <a:endParaRPr lang="en-GY" sz="900" b="1" kern="1200" dirty="0"/>
+          <a:endParaRPr lang="en-GY" sz="800" b="1" kern="1200" dirty="0"/>
         </a:p>
       </dsp:txBody>
       <dsp:txXfrm rot="-5400000">
-        <a:off x="1" y="977907"/>
-        <a:ext cx="342026" cy="146583"/>
+        <a:off x="2" y="859554"/>
+        <a:ext cx="302809" cy="129776"/>
       </dsp:txXfrm>
     </dsp:sp>
-    <dsp:sp modelId="{EAE7CF5D-BE4F-4BB2-821E-27277B2EEBFB}">
+    <dsp:sp modelId="{D279EA2D-C7D4-4A2D-B832-CE671E9A5420}">
       <dsp:nvSpPr>
         <dsp:cNvPr id="0" name=""/>
         <dsp:cNvSpPr/>
       </dsp:nvSpPr>
       <dsp:spPr>
         <a:xfrm rot="5400000">
-          <a:off x="2145414" y="-996493"/>
-          <a:ext cx="317595" cy="3924372"/>
+          <a:off x="2410953" y="-1399993"/>
+          <a:ext cx="281180" cy="4497467"/>
         </a:xfrm>
         <a:prstGeom prst="round2SameRect">
           <a:avLst/>
@@ -2136,25 +2270,29 @@
           </a:pPr>
           <a:r>
             <a:rPr lang="en-US" sz="2000" kern="1200" dirty="0"/>
-            <a:t>03_clean.R</a:t>
+            <a:t>02_diagnose.R- </a:t>
+          </a:r>
+          <a:r>
+            <a:rPr lang="en-US" sz="1400" kern="1200" dirty="0"/>
+            <a:t>diagnostics &amp; logging</a:t>
           </a:r>
           <a:endParaRPr lang="en-GY" sz="2000" kern="1200" dirty="0"/>
         </a:p>
       </dsp:txBody>
       <dsp:txXfrm rot="-5400000">
-        <a:off x="342026" y="822399"/>
-        <a:ext cx="3908868" cy="286587"/>
+        <a:off x="302810" y="721876"/>
+        <a:ext cx="4483741" cy="253728"/>
       </dsp:txXfrm>
     </dsp:sp>
-    <dsp:sp modelId="{600F4A9E-2A62-476E-9727-BFFBBFC2BF53}">
+    <dsp:sp modelId="{E1632E70-2FF3-409A-B038-7AEB0326704A}">
       <dsp:nvSpPr>
         <dsp:cNvPr id="0" name=""/>
         <dsp:cNvSpPr/>
       </dsp:nvSpPr>
       <dsp:spPr>
         <a:xfrm rot="5400000">
-          <a:off x="-73291" y="1282759"/>
-          <a:ext cx="488609" cy="342026"/>
+          <a:off x="-64887" y="1125924"/>
+          <a:ext cx="432585" cy="302809"/>
         </a:xfrm>
         <a:prstGeom prst="chevron">
           <a:avLst/>
@@ -2195,12 +2333,12 @@
         </a:fontRef>
       </dsp:style>
       <dsp:txBody>
-        <a:bodyPr spcFirstLastPara="0" vert="horz" wrap="square" lIns="5715" tIns="5715" rIns="5715" bIns="5715" numCol="1" spcCol="1270" anchor="ctr" anchorCtr="0">
+        <a:bodyPr spcFirstLastPara="0" vert="horz" wrap="square" lIns="5080" tIns="5080" rIns="5080" bIns="5080" numCol="1" spcCol="1270" anchor="ctr" anchorCtr="0">
           <a:noAutofit/>
         </a:bodyPr>
         <a:lstStyle/>
         <a:p>
-          <a:pPr marL="0" lvl="0" indent="0" algn="ctr" defTabSz="400050">
+          <a:pPr marL="0" lvl="0" indent="0" algn="ctr" defTabSz="355600">
             <a:lnSpc>
               <a:spcPct val="90000"/>
             </a:lnSpc>
@@ -2213,26 +2351,26 @@
             <a:buNone/>
           </a:pPr>
           <a:r>
-            <a:rPr lang="en-US" sz="900" b="1" kern="1200" dirty="0"/>
-            <a:t>STEP 4</a:t>
+            <a:rPr lang="en-US" sz="800" b="1" kern="1200" dirty="0"/>
+            <a:t>STEP 3</a:t>
           </a:r>
-          <a:endParaRPr lang="en-GY" sz="900" b="1" kern="1200" dirty="0"/>
+          <a:endParaRPr lang="en-GY" sz="800" b="1" kern="1200" dirty="0"/>
         </a:p>
       </dsp:txBody>
       <dsp:txXfrm rot="-5400000">
-        <a:off x="1" y="1380480"/>
-        <a:ext cx="342026" cy="146583"/>
+        <a:off x="2" y="1212441"/>
+        <a:ext cx="302809" cy="129776"/>
       </dsp:txXfrm>
     </dsp:sp>
-    <dsp:sp modelId="{DAE9D0B7-60EC-4A80-BFC1-C54B7FDE7B39}">
+    <dsp:sp modelId="{EAE7CF5D-BE4F-4BB2-821E-27277B2EEBFB}">
       <dsp:nvSpPr>
         <dsp:cNvPr id="0" name=""/>
         <dsp:cNvSpPr/>
       </dsp:nvSpPr>
       <dsp:spPr>
         <a:xfrm rot="5400000">
-          <a:off x="2145414" y="-593919"/>
-          <a:ext cx="317595" cy="3924372"/>
+          <a:off x="2410953" y="-1047106"/>
+          <a:ext cx="281180" cy="4497467"/>
         </a:xfrm>
         <a:prstGeom prst="round2SameRect">
           <a:avLst/>
@@ -2291,25 +2429,29 @@
           </a:pPr>
           <a:r>
             <a:rPr lang="en-US" sz="2000" kern="1200" dirty="0"/>
-            <a:t>04_impute.R</a:t>
+            <a:t>03_clean.R – </a:t>
+          </a:r>
+          <a:r>
+            <a:rPr lang="en-US" sz="1400" kern="1200" dirty="0"/>
+            <a:t>cleaning &amp; duplicate handling</a:t>
           </a:r>
           <a:endParaRPr lang="en-GY" sz="2000" kern="1200" dirty="0"/>
         </a:p>
       </dsp:txBody>
       <dsp:txXfrm rot="-5400000">
-        <a:off x="342026" y="1224973"/>
-        <a:ext cx="3908868" cy="286587"/>
+        <a:off x="302810" y="1074763"/>
+        <a:ext cx="4483741" cy="253728"/>
       </dsp:txXfrm>
     </dsp:sp>
-    <dsp:sp modelId="{87BEBA03-C076-4656-9A59-6931769357D3}">
+    <dsp:sp modelId="{600F4A9E-2A62-476E-9727-BFFBBFC2BF53}">
       <dsp:nvSpPr>
         <dsp:cNvPr id="0" name=""/>
         <dsp:cNvSpPr/>
       </dsp:nvSpPr>
       <dsp:spPr>
         <a:xfrm rot="5400000">
-          <a:off x="-73291" y="1685333"/>
-          <a:ext cx="488609" cy="342026"/>
+          <a:off x="-64887" y="1478811"/>
+          <a:ext cx="432585" cy="302809"/>
         </a:xfrm>
         <a:prstGeom prst="chevron">
           <a:avLst/>
@@ -2350,12 +2492,12 @@
         </a:fontRef>
       </dsp:style>
       <dsp:txBody>
-        <a:bodyPr spcFirstLastPara="0" vert="horz" wrap="square" lIns="5715" tIns="5715" rIns="5715" bIns="5715" numCol="1" spcCol="1270" anchor="ctr" anchorCtr="0">
+        <a:bodyPr spcFirstLastPara="0" vert="horz" wrap="square" lIns="5080" tIns="5080" rIns="5080" bIns="5080" numCol="1" spcCol="1270" anchor="ctr" anchorCtr="0">
           <a:noAutofit/>
         </a:bodyPr>
         <a:lstStyle/>
         <a:p>
-          <a:pPr marL="0" lvl="0" indent="0" algn="ctr" defTabSz="400050">
+          <a:pPr marL="0" lvl="0" indent="0" algn="ctr" defTabSz="355600">
             <a:lnSpc>
               <a:spcPct val="90000"/>
             </a:lnSpc>
@@ -2368,26 +2510,26 @@
             <a:buNone/>
           </a:pPr>
           <a:r>
-            <a:rPr lang="en-US" sz="900" b="1" kern="1200" dirty="0"/>
-            <a:t>STEP 5</a:t>
+            <a:rPr lang="en-US" sz="800" b="1" kern="1200" dirty="0"/>
+            <a:t>STEP 4</a:t>
           </a:r>
-          <a:endParaRPr lang="en-GY" sz="900" b="1" kern="1200" dirty="0"/>
+          <a:endParaRPr lang="en-GY" sz="800" b="1" kern="1200" dirty="0"/>
         </a:p>
       </dsp:txBody>
       <dsp:txXfrm rot="-5400000">
-        <a:off x="1" y="1783054"/>
-        <a:ext cx="342026" cy="146583"/>
+        <a:off x="2" y="1565328"/>
+        <a:ext cx="302809" cy="129776"/>
       </dsp:txXfrm>
     </dsp:sp>
-    <dsp:sp modelId="{E914C9C4-1E45-4BE2-B20B-6FFE9FEF7EBC}">
+    <dsp:sp modelId="{DAE9D0B7-60EC-4A80-BFC1-C54B7FDE7B39}">
       <dsp:nvSpPr>
         <dsp:cNvPr id="0" name=""/>
         <dsp:cNvSpPr/>
       </dsp:nvSpPr>
       <dsp:spPr>
         <a:xfrm rot="5400000">
-          <a:off x="2145414" y="-191346"/>
-          <a:ext cx="317595" cy="3924372"/>
+          <a:off x="2410953" y="-694219"/>
+          <a:ext cx="281180" cy="4497467"/>
         </a:xfrm>
         <a:prstGeom prst="round2SameRect">
           <a:avLst/>
@@ -2446,25 +2588,29 @@
           </a:pPr>
           <a:r>
             <a:rPr lang="en-US" sz="2000" kern="1200" dirty="0"/>
-            <a:t>05_dictionary.R</a:t>
+            <a:t>04_impute.R - </a:t>
+          </a:r>
+          <a:r>
+            <a:rPr lang="en-US" sz="1400" kern="1200" dirty="0"/>
+            <a:t>imputation</a:t>
           </a:r>
           <a:endParaRPr lang="en-GY" sz="2000" kern="1200" dirty="0"/>
         </a:p>
       </dsp:txBody>
       <dsp:txXfrm rot="-5400000">
-        <a:off x="342026" y="1627546"/>
-        <a:ext cx="3908868" cy="286587"/>
+        <a:off x="302810" y="1427650"/>
+        <a:ext cx="4483741" cy="253728"/>
       </dsp:txXfrm>
     </dsp:sp>
-    <dsp:sp modelId="{71A5F4AA-3510-4A80-95AA-B3CAE0BDA320}">
+    <dsp:sp modelId="{87BEBA03-C076-4656-9A59-6931769357D3}">
       <dsp:nvSpPr>
         <dsp:cNvPr id="0" name=""/>
         <dsp:cNvSpPr/>
       </dsp:nvSpPr>
       <dsp:spPr>
         <a:xfrm rot="5400000">
-          <a:off x="-73291" y="2087907"/>
-          <a:ext cx="488609" cy="342026"/>
+          <a:off x="-64887" y="1831698"/>
+          <a:ext cx="432585" cy="302809"/>
         </a:xfrm>
         <a:prstGeom prst="chevron">
           <a:avLst/>
@@ -2505,12 +2651,12 @@
         </a:fontRef>
       </dsp:style>
       <dsp:txBody>
-        <a:bodyPr spcFirstLastPara="0" vert="horz" wrap="square" lIns="5715" tIns="5715" rIns="5715" bIns="5715" numCol="1" spcCol="1270" anchor="ctr" anchorCtr="0">
+        <a:bodyPr spcFirstLastPara="0" vert="horz" wrap="square" lIns="5080" tIns="5080" rIns="5080" bIns="5080" numCol="1" spcCol="1270" anchor="ctr" anchorCtr="0">
           <a:noAutofit/>
         </a:bodyPr>
         <a:lstStyle/>
         <a:p>
-          <a:pPr marL="0" lvl="0" indent="0" algn="ctr" defTabSz="400050">
+          <a:pPr marL="0" lvl="0" indent="0" algn="ctr" defTabSz="355600">
             <a:lnSpc>
               <a:spcPct val="90000"/>
             </a:lnSpc>
@@ -2523,26 +2669,26 @@
             <a:buNone/>
           </a:pPr>
           <a:r>
-            <a:rPr lang="en-US" sz="900" b="1" kern="1200" dirty="0"/>
-            <a:t>STEP 6</a:t>
+            <a:rPr lang="en-US" sz="800" b="1" kern="1200" dirty="0"/>
+            <a:t>STEP 5</a:t>
           </a:r>
-          <a:endParaRPr lang="en-GY" sz="900" b="1" kern="1200" dirty="0"/>
+          <a:endParaRPr lang="en-GY" sz="800" b="1" kern="1200" dirty="0"/>
         </a:p>
       </dsp:txBody>
       <dsp:txXfrm rot="-5400000">
-        <a:off x="1" y="2185628"/>
-        <a:ext cx="342026" cy="146583"/>
+        <a:off x="2" y="1918215"/>
+        <a:ext cx="302809" cy="129776"/>
       </dsp:txXfrm>
     </dsp:sp>
-    <dsp:sp modelId="{CEEDEFDD-B88A-41A5-BB1B-D61F5FEED36F}">
+    <dsp:sp modelId="{E914C9C4-1E45-4BE2-B20B-6FFE9FEF7EBC}">
       <dsp:nvSpPr>
         <dsp:cNvPr id="0" name=""/>
         <dsp:cNvSpPr/>
       </dsp:nvSpPr>
       <dsp:spPr>
         <a:xfrm rot="5400000">
-          <a:off x="2145414" y="211227"/>
-          <a:ext cx="317595" cy="3924372"/>
+          <a:off x="2410953" y="-341332"/>
+          <a:ext cx="281180" cy="4497467"/>
         </a:xfrm>
         <a:prstGeom prst="round2SameRect">
           <a:avLst/>
@@ -2601,25 +2747,29 @@
           </a:pPr>
           <a:r>
             <a:rPr lang="en-US" sz="2000" kern="1200" dirty="0"/>
-            <a:t>06_export.R</a:t>
+            <a:t>05_dictionary.R – </a:t>
+          </a:r>
+          <a:r>
+            <a:rPr lang="en-US" sz="1400" kern="1200" dirty="0"/>
+            <a:t>data dictionary generation</a:t>
           </a:r>
           <a:endParaRPr lang="en-GY" sz="2000" kern="1200" dirty="0"/>
         </a:p>
       </dsp:txBody>
       <dsp:txXfrm rot="-5400000">
-        <a:off x="342026" y="2030119"/>
-        <a:ext cx="3908868" cy="286587"/>
+        <a:off x="302810" y="1780537"/>
+        <a:ext cx="4483741" cy="253728"/>
       </dsp:txXfrm>
     </dsp:sp>
-    <dsp:sp modelId="{7086D58B-66BB-48EF-9B71-F024F3911F29}">
+    <dsp:sp modelId="{71A5F4AA-3510-4A80-95AA-B3CAE0BDA320}">
       <dsp:nvSpPr>
         <dsp:cNvPr id="0" name=""/>
         <dsp:cNvSpPr/>
       </dsp:nvSpPr>
       <dsp:spPr>
         <a:xfrm rot="5400000">
-          <a:off x="-73291" y="2490480"/>
-          <a:ext cx="488609" cy="342026"/>
+          <a:off x="-64887" y="2184585"/>
+          <a:ext cx="432585" cy="302809"/>
         </a:xfrm>
         <a:prstGeom prst="chevron">
           <a:avLst/>
@@ -2660,12 +2810,12 @@
         </a:fontRef>
       </dsp:style>
       <dsp:txBody>
-        <a:bodyPr spcFirstLastPara="0" vert="horz" wrap="square" lIns="5715" tIns="5715" rIns="5715" bIns="5715" numCol="1" spcCol="1270" anchor="ctr" anchorCtr="0">
+        <a:bodyPr spcFirstLastPara="0" vert="horz" wrap="square" lIns="5080" tIns="5080" rIns="5080" bIns="5080" numCol="1" spcCol="1270" anchor="ctr" anchorCtr="0">
           <a:noAutofit/>
         </a:bodyPr>
         <a:lstStyle/>
         <a:p>
-          <a:pPr marL="0" lvl="0" indent="0" algn="ctr" defTabSz="400050">
+          <a:pPr marL="0" lvl="0" indent="0" algn="ctr" defTabSz="355600">
             <a:lnSpc>
               <a:spcPct val="90000"/>
             </a:lnSpc>
@@ -2678,26 +2828,26 @@
             <a:buNone/>
           </a:pPr>
           <a:r>
-            <a:rPr lang="en-US" sz="900" b="1" kern="1200" dirty="0"/>
-            <a:t>STEP 7</a:t>
+            <a:rPr lang="en-US" sz="800" b="1" kern="1200" dirty="0"/>
+            <a:t>STEP 6</a:t>
           </a:r>
-          <a:endParaRPr lang="en-GY" sz="900" b="1" kern="1200" dirty="0"/>
+          <a:endParaRPr lang="en-GY" sz="800" b="1" kern="1200" dirty="0"/>
         </a:p>
       </dsp:txBody>
       <dsp:txXfrm rot="-5400000">
-        <a:off x="1" y="2588201"/>
-        <a:ext cx="342026" cy="146583"/>
+        <a:off x="2" y="2271102"/>
+        <a:ext cx="302809" cy="129776"/>
       </dsp:txXfrm>
     </dsp:sp>
-    <dsp:sp modelId="{9831EBFE-52E3-4421-8DB6-43CE44ABBB9E}">
+    <dsp:sp modelId="{CEEDEFDD-B88A-41A5-BB1B-D61F5FEED36F}">
       <dsp:nvSpPr>
         <dsp:cNvPr id="0" name=""/>
         <dsp:cNvSpPr/>
       </dsp:nvSpPr>
       <dsp:spPr>
         <a:xfrm rot="5400000">
-          <a:off x="2145414" y="613800"/>
-          <a:ext cx="317595" cy="3924372"/>
+          <a:off x="2410953" y="11554"/>
+          <a:ext cx="281180" cy="4497467"/>
         </a:xfrm>
         <a:prstGeom prst="round2SameRect">
           <a:avLst/>
@@ -2756,14 +2906,177 @@
           </a:pPr>
           <a:r>
             <a:rPr lang="en-US" sz="2000" kern="1200" dirty="0"/>
-            <a:t>07_report.Rmd</a:t>
+            <a:t>06_export.R – </a:t>
+          </a:r>
+          <a:r>
+            <a:rPr lang="en-US" sz="1400" kern="1200" dirty="0"/>
+            <a:t>export outputs</a:t>
           </a:r>
           <a:endParaRPr lang="en-GY" sz="2000" kern="1200" dirty="0"/>
         </a:p>
       </dsp:txBody>
       <dsp:txXfrm rot="-5400000">
-        <a:off x="342026" y="2432692"/>
-        <a:ext cx="3908868" cy="286587"/>
+        <a:off x="302810" y="2133423"/>
+        <a:ext cx="4483741" cy="253728"/>
+      </dsp:txXfrm>
+    </dsp:sp>
+    <dsp:sp modelId="{7086D58B-66BB-48EF-9B71-F024F3911F29}">
+      <dsp:nvSpPr>
+        <dsp:cNvPr id="0" name=""/>
+        <dsp:cNvSpPr/>
+      </dsp:nvSpPr>
+      <dsp:spPr>
+        <a:xfrm rot="5400000">
+          <a:off x="-64887" y="2537472"/>
+          <a:ext cx="432585" cy="302809"/>
+        </a:xfrm>
+        <a:prstGeom prst="chevron">
+          <a:avLst/>
+        </a:prstGeom>
+        <a:solidFill>
+          <a:schemeClr val="accent1">
+            <a:hueOff val="0"/>
+            <a:satOff val="0"/>
+            <a:lumOff val="0"/>
+            <a:alphaOff val="0"/>
+          </a:schemeClr>
+        </a:solidFill>
+        <a:ln w="15875" cap="flat" cmpd="sng" algn="ctr">
+          <a:solidFill>
+            <a:schemeClr val="accent1">
+              <a:hueOff val="0"/>
+              <a:satOff val="0"/>
+              <a:lumOff val="0"/>
+              <a:alphaOff val="0"/>
+            </a:schemeClr>
+          </a:solidFill>
+          <a:prstDash val="solid"/>
+        </a:ln>
+        <a:effectLst/>
+      </dsp:spPr>
+      <dsp:style>
+        <a:lnRef idx="2">
+          <a:scrgbClr r="0" g="0" b="0"/>
+        </a:lnRef>
+        <a:fillRef idx="1">
+          <a:scrgbClr r="0" g="0" b="0"/>
+        </a:fillRef>
+        <a:effectRef idx="0">
+          <a:scrgbClr r="0" g="0" b="0"/>
+        </a:effectRef>
+        <a:fontRef idx="minor">
+          <a:schemeClr val="lt1"/>
+        </a:fontRef>
+      </dsp:style>
+      <dsp:txBody>
+        <a:bodyPr spcFirstLastPara="0" vert="horz" wrap="square" lIns="5080" tIns="5080" rIns="5080" bIns="5080" numCol="1" spcCol="1270" anchor="ctr" anchorCtr="0">
+          <a:noAutofit/>
+        </a:bodyPr>
+        <a:lstStyle/>
+        <a:p>
+          <a:pPr marL="0" lvl="0" indent="0" algn="ctr" defTabSz="355600">
+            <a:lnSpc>
+              <a:spcPct val="90000"/>
+            </a:lnSpc>
+            <a:spcBef>
+              <a:spcPct val="0"/>
+            </a:spcBef>
+            <a:spcAft>
+              <a:spcPct val="35000"/>
+            </a:spcAft>
+            <a:buNone/>
+          </a:pPr>
+          <a:r>
+            <a:rPr lang="en-US" sz="800" b="1" kern="1200" dirty="0"/>
+            <a:t>STEP 7</a:t>
+          </a:r>
+          <a:endParaRPr lang="en-GY" sz="800" b="1" kern="1200" dirty="0"/>
+        </a:p>
+      </dsp:txBody>
+      <dsp:txXfrm rot="-5400000">
+        <a:off x="2" y="2623989"/>
+        <a:ext cx="302809" cy="129776"/>
+      </dsp:txXfrm>
+    </dsp:sp>
+    <dsp:sp modelId="{9831EBFE-52E3-4421-8DB6-43CE44ABBB9E}">
+      <dsp:nvSpPr>
+        <dsp:cNvPr id="0" name=""/>
+        <dsp:cNvSpPr/>
+      </dsp:nvSpPr>
+      <dsp:spPr>
+        <a:xfrm rot="5400000">
+          <a:off x="2410953" y="364441"/>
+          <a:ext cx="281180" cy="4497467"/>
+        </a:xfrm>
+        <a:prstGeom prst="round2SameRect">
+          <a:avLst/>
+        </a:prstGeom>
+        <a:solidFill>
+          <a:schemeClr val="lt1">
+            <a:alpha val="90000"/>
+            <a:hueOff val="0"/>
+            <a:satOff val="0"/>
+            <a:lumOff val="0"/>
+            <a:alphaOff val="0"/>
+          </a:schemeClr>
+        </a:solidFill>
+        <a:ln w="15875" cap="flat" cmpd="sng" algn="ctr">
+          <a:solidFill>
+            <a:schemeClr val="accent1">
+              <a:hueOff val="0"/>
+              <a:satOff val="0"/>
+              <a:lumOff val="0"/>
+              <a:alphaOff val="0"/>
+            </a:schemeClr>
+          </a:solidFill>
+          <a:prstDash val="solid"/>
+        </a:ln>
+        <a:effectLst/>
+      </dsp:spPr>
+      <dsp:style>
+        <a:lnRef idx="2">
+          <a:scrgbClr r="0" g="0" b="0"/>
+        </a:lnRef>
+        <a:fillRef idx="1">
+          <a:scrgbClr r="0" g="0" b="0"/>
+        </a:fillRef>
+        <a:effectRef idx="0">
+          <a:scrgbClr r="0" g="0" b="0"/>
+        </a:effectRef>
+        <a:fontRef idx="minor"/>
+      </dsp:style>
+      <dsp:txBody>
+        <a:bodyPr spcFirstLastPara="0" vert="horz" wrap="square" lIns="142240" tIns="12700" rIns="12700" bIns="12700" numCol="1" spcCol="1270" anchor="ctr" anchorCtr="0">
+          <a:noAutofit/>
+        </a:bodyPr>
+        <a:lstStyle/>
+        <a:p>
+          <a:pPr marL="228600" lvl="1" indent="-228600" algn="l" defTabSz="889000">
+            <a:lnSpc>
+              <a:spcPct val="90000"/>
+            </a:lnSpc>
+            <a:spcBef>
+              <a:spcPct val="0"/>
+            </a:spcBef>
+            <a:spcAft>
+              <a:spcPct val="15000"/>
+            </a:spcAft>
+            <a:buChar char="•"/>
+          </a:pPr>
+          <a:r>
+            <a:rPr lang="en-US" sz="2000" kern="1200" dirty="0"/>
+            <a:t>07_report.Rmd – </a:t>
+          </a:r>
+          <a:r>
+            <a:rPr lang="en-US" sz="1400" kern="1200" dirty="0"/>
+            <a:t>automated word report</a:t>
+          </a:r>
+          <a:endParaRPr lang="en-GY" sz="2000" kern="1200" dirty="0"/>
+        </a:p>
+      </dsp:txBody>
+      <dsp:txXfrm rot="-5400000">
+        <a:off x="302810" y="2486310"/>
+        <a:ext cx="4483741" cy="253728"/>
       </dsp:txXfrm>
     </dsp:sp>
   </dsp:spTree>
@@ -4142,7 +4455,7 @@
           <a:p>
             <a:fld id="{A56A649F-0235-4F80-836D-BD90284FBBC5}" type="datetimeFigureOut">
               <a:rPr lang="en-GY" smtClean="0"/>
-              <a:t>07/05/2026</a:t>
+              <a:t>19/05/2026</a:t>
             </a:fld>
             <a:endParaRPr lang="en-GY"/>
           </a:p>
@@ -4518,13 +4831,7 @@
   <p:cSld>
     <p:spTree>
       <p:nvGrpSpPr>
-        <p:cNvPr id="1" name="">
-          <a:extLst>
-            <a:ext uri="{FF2B5EF4-FFF2-40B4-BE49-F238E27FC236}">
-              <a16:creationId xmlns:a16="http://schemas.microsoft.com/office/drawing/2014/main" id="{F3B72B3E-6B81-63C7-4085-EFC8A7AE09B1}"/>
-            </a:ext>
-          </a:extLst>
-        </p:cNvPr>
+        <p:cNvPr id="1" name=""/>
         <p:cNvGrpSpPr/>
         <p:nvPr/>
       </p:nvGrpSpPr>
@@ -4538,13 +4845,7 @@
       </p:grpSpPr>
       <p:sp>
         <p:nvSpPr>
-          <p:cNvPr id="2" name="Slide Image Placeholder 1">
-            <a:extLst>
-              <a:ext uri="{FF2B5EF4-FFF2-40B4-BE49-F238E27FC236}">
-                <a16:creationId xmlns:a16="http://schemas.microsoft.com/office/drawing/2014/main" id="{F1D21F10-7EB9-A908-0577-4B7072F27BB6}"/>
-              </a:ext>
-            </a:extLst>
-          </p:cNvPr>
+          <p:cNvPr id="2" name="Slide Image Placeholder 1"/>
           <p:cNvSpPr>
             <a:spLocks noGrp="1" noRot="1" noChangeAspect="1"/>
           </p:cNvSpPr>
@@ -4556,13 +4857,7 @@
       </p:sp>
       <p:sp>
         <p:nvSpPr>
-          <p:cNvPr id="3" name="Notes Placeholder 2">
-            <a:extLst>
-              <a:ext uri="{FF2B5EF4-FFF2-40B4-BE49-F238E27FC236}">
-                <a16:creationId xmlns:a16="http://schemas.microsoft.com/office/drawing/2014/main" id="{6BC53F5F-CB18-80CF-1E3A-E3707F81490B}"/>
-              </a:ext>
-            </a:extLst>
-          </p:cNvPr>
+          <p:cNvPr id="3" name="Notes Placeholder 2"/>
           <p:cNvSpPr>
             <a:spLocks noGrp="1"/>
           </p:cNvSpPr>
@@ -4574,6 +4869,17 @@
         <p:txBody>
           <a:bodyPr/>
           <a:lstStyle/>
+          <a:p>
+            <a:endParaRPr lang="en-GY" sz="1200" kern="1200" dirty="0">
+              <a:solidFill>
+                <a:schemeClr val="tx1"/>
+              </a:solidFill>
+              <a:effectLst/>
+              <a:latin typeface="+mn-lt"/>
+              <a:ea typeface="+mn-ea"/>
+              <a:cs typeface="+mn-cs"/>
+            </a:endParaRPr>
+          </a:p>
           <a:p>
             <a:r>
               <a:rPr lang="en-GY" sz="1200" kern="1200" dirty="0">
@@ -4585,55 +4891,7 @@
                 <a:ea typeface="+mn-ea"/>
                 <a:cs typeface="+mn-cs"/>
               </a:rPr>
-              <a:t>Multi-format export capability</a:t>
-            </a:r>
-          </a:p>
-          <a:p>
-            <a:r>
-              <a:rPr lang="en-GY" sz="1200" kern="1200" dirty="0">
-                <a:solidFill>
-                  <a:schemeClr val="tx1"/>
-                </a:solidFill>
-                <a:effectLst/>
-                <a:latin typeface="+mn-lt"/>
-                <a:ea typeface="+mn-ea"/>
-                <a:cs typeface="+mn-cs"/>
-              </a:rPr>
-              <a:t>Automated reporting</a:t>
-            </a:r>
-            <a:endParaRPr lang="en-US" sz="1200" kern="1200" dirty="0">
-              <a:solidFill>
-                <a:schemeClr val="tx1"/>
-              </a:solidFill>
-              <a:effectLst/>
-              <a:latin typeface="+mn-lt"/>
-              <a:ea typeface="+mn-ea"/>
-              <a:cs typeface="+mn-cs"/>
-            </a:endParaRPr>
-          </a:p>
-          <a:p>
-            <a:endParaRPr lang="en-GY" sz="1200" kern="1200" dirty="0">
-              <a:solidFill>
-                <a:schemeClr val="tx1"/>
-              </a:solidFill>
-              <a:effectLst/>
-              <a:latin typeface="+mn-lt"/>
-              <a:ea typeface="+mn-ea"/>
-              <a:cs typeface="+mn-cs"/>
-            </a:endParaRPr>
-          </a:p>
-          <a:p>
-            <a:r>
-              <a:rPr lang="en-GY" sz="1200" kern="1200" dirty="0">
-                <a:solidFill>
-                  <a:schemeClr val="tx1"/>
-                </a:solidFill>
-                <a:effectLst/>
-                <a:latin typeface="+mn-lt"/>
-                <a:ea typeface="+mn-ea"/>
-                <a:cs typeface="+mn-cs"/>
-              </a:rPr>
-              <a:t>“The cleaned dataset was exported into multiple formats to support different analytical environments.”</a:t>
+              <a:t>“One major success was achieving a complete automated workflow from ingestion to reporting.”</a:t>
             </a:r>
           </a:p>
           <a:p>
@@ -4643,13 +4901,7 @@
       </p:sp>
       <p:sp>
         <p:nvSpPr>
-          <p:cNvPr id="4" name="Slide Number Placeholder 3">
-            <a:extLst>
-              <a:ext uri="{FF2B5EF4-FFF2-40B4-BE49-F238E27FC236}">
-                <a16:creationId xmlns:a16="http://schemas.microsoft.com/office/drawing/2014/main" id="{0B058A03-9139-AB90-9ED3-4202E358D2EC}"/>
-              </a:ext>
-            </a:extLst>
-          </p:cNvPr>
+          <p:cNvPr id="4" name="Slide Number Placeholder 3"/>
           <p:cNvSpPr>
             <a:spLocks noGrp="1"/>
           </p:cNvSpPr>
@@ -4664,7 +4916,7 @@
           <a:p>
             <a:fld id="{0C5B4401-7920-4864-9216-E6B6B878A0D8}" type="slidenum">
               <a:rPr lang="en-GY" smtClean="0"/>
-              <a:t>11</a:t>
+              <a:t>10</a:t>
             </a:fld>
             <a:endParaRPr lang="en-GY"/>
           </a:p>
@@ -4673,7 +4925,7 @@
     </p:spTree>
     <p:extLst>
       <p:ext uri="{BB962C8B-B14F-4D97-AF65-F5344CB8AC3E}">
-        <p14:creationId xmlns:p14="http://schemas.microsoft.com/office/powerpoint/2010/main" val="3198824491"/>
+        <p14:creationId xmlns:p14="http://schemas.microsoft.com/office/powerpoint/2010/main" val="942569959"/>
       </p:ext>
     </p:extLst>
   </p:cSld>
@@ -4688,13 +4940,7 @@
   <p:cSld>
     <p:spTree>
       <p:nvGrpSpPr>
-        <p:cNvPr id="1" name="">
-          <a:extLst>
-            <a:ext uri="{FF2B5EF4-FFF2-40B4-BE49-F238E27FC236}">
-              <a16:creationId xmlns:a16="http://schemas.microsoft.com/office/drawing/2014/main" id="{903D5280-5D66-D392-CD0C-9C20D5D4A6D4}"/>
-            </a:ext>
-          </a:extLst>
-        </p:cNvPr>
+        <p:cNvPr id="1" name=""/>
         <p:cNvGrpSpPr/>
         <p:nvPr/>
       </p:nvGrpSpPr>
@@ -4708,13 +4954,7 @@
       </p:grpSpPr>
       <p:sp>
         <p:nvSpPr>
-          <p:cNvPr id="2" name="Slide Image Placeholder 1">
-            <a:extLst>
-              <a:ext uri="{FF2B5EF4-FFF2-40B4-BE49-F238E27FC236}">
-                <a16:creationId xmlns:a16="http://schemas.microsoft.com/office/drawing/2014/main" id="{B8E15D32-5ED9-669C-56A6-B1E800C1B2B6}"/>
-              </a:ext>
-            </a:extLst>
-          </p:cNvPr>
+          <p:cNvPr id="2" name="Slide Image Placeholder 1"/>
           <p:cNvSpPr>
             <a:spLocks noGrp="1" noRot="1" noChangeAspect="1"/>
           </p:cNvSpPr>
@@ -4726,13 +4966,7 @@
       </p:sp>
       <p:sp>
         <p:nvSpPr>
-          <p:cNvPr id="3" name="Notes Placeholder 2">
-            <a:extLst>
-              <a:ext uri="{FF2B5EF4-FFF2-40B4-BE49-F238E27FC236}">
-                <a16:creationId xmlns:a16="http://schemas.microsoft.com/office/drawing/2014/main" id="{D3429A04-EA2E-EB85-CF23-6CBD207C6FC9}"/>
-              </a:ext>
-            </a:extLst>
-          </p:cNvPr>
+          <p:cNvPr id="3" name="Notes Placeholder 2"/>
           <p:cNvSpPr>
             <a:spLocks noGrp="1"/>
           </p:cNvSpPr>
@@ -4745,6 +4979,97 @@
           <a:bodyPr/>
           <a:lstStyle/>
           <a:p>
+            <a:r>
+              <a:rPr lang="en-US" dirty="0"/>
+              <a:t>Handling duplicate patient identities</a:t>
+            </a:r>
+          </a:p>
+          <a:p>
+            <a:r>
+              <a:rPr lang="en-US" dirty="0"/>
+              <a:t>- Deciding which records to retain</a:t>
+            </a:r>
+          </a:p>
+          <a:p>
+            <a:r>
+              <a:rPr lang="en-US" dirty="0"/>
+              <a:t>- Structuring pipeline stages correctly</a:t>
+            </a:r>
+          </a:p>
+          <a:p>
+            <a:pPr marL="0" marR="0" lvl="0" indent="0" algn="l" defTabSz="914400" rtl="0" eaLnBrk="1" fontAlgn="auto" latinLnBrk="0" hangingPunct="1">
+              <a:lnSpc>
+                <a:spcPct val="100000"/>
+              </a:lnSpc>
+              <a:spcBef>
+                <a:spcPts val="0"/>
+              </a:spcBef>
+              <a:spcAft>
+                <a:spcPts val="0"/>
+              </a:spcAft>
+              <a:buClrTx/>
+              <a:buSzTx/>
+              <a:buFontTx/>
+              <a:buNone/>
+              <a:tabLst/>
+              <a:defRPr/>
+            </a:pPr>
+            <a:endParaRPr lang="en-US" sz="1200" kern="1200" dirty="0">
+              <a:solidFill>
+                <a:schemeClr val="tx1"/>
+              </a:solidFill>
+              <a:effectLst/>
+              <a:latin typeface="+mn-lt"/>
+              <a:ea typeface="+mn-ea"/>
+              <a:cs typeface="+mn-cs"/>
+            </a:endParaRPr>
+          </a:p>
+          <a:p>
+            <a:pPr marL="0" marR="0" lvl="0" indent="0" algn="l" defTabSz="914400" rtl="0" eaLnBrk="1" fontAlgn="auto" latinLnBrk="0" hangingPunct="1">
+              <a:lnSpc>
+                <a:spcPct val="100000"/>
+              </a:lnSpc>
+              <a:spcBef>
+                <a:spcPts val="0"/>
+              </a:spcBef>
+              <a:spcAft>
+                <a:spcPts val="0"/>
+              </a:spcAft>
+              <a:buClrTx/>
+              <a:buSzTx/>
+              <a:buFontTx/>
+              <a:buNone/>
+              <a:tabLst/>
+              <a:defRPr/>
+            </a:pPr>
+            <a:endParaRPr lang="en-US" sz="1200" kern="1200" dirty="0">
+              <a:solidFill>
+                <a:schemeClr val="tx1"/>
+              </a:solidFill>
+              <a:effectLst/>
+              <a:latin typeface="+mn-lt"/>
+              <a:ea typeface="+mn-ea"/>
+              <a:cs typeface="+mn-cs"/>
+            </a:endParaRPr>
+          </a:p>
+          <a:p>
+            <a:pPr marL="0" marR="0" lvl="0" indent="0" algn="l" defTabSz="914400" rtl="0" eaLnBrk="1" fontAlgn="auto" latinLnBrk="0" hangingPunct="1">
+              <a:lnSpc>
+                <a:spcPct val="100000"/>
+              </a:lnSpc>
+              <a:spcBef>
+                <a:spcPts val="0"/>
+              </a:spcBef>
+              <a:spcAft>
+                <a:spcPts val="0"/>
+              </a:spcAft>
+              <a:buClrTx/>
+              <a:buSzTx/>
+              <a:buFontTx/>
+              <a:buNone/>
+              <a:tabLst/>
+              <a:defRPr/>
+            </a:pPr>
             <a:r>
               <a:rPr lang="en-GY" sz="1200" kern="1200" dirty="0">
                 <a:solidFill>
@@ -4755,55 +5080,7 @@
                 <a:ea typeface="+mn-ea"/>
                 <a:cs typeface="+mn-cs"/>
               </a:rPr>
-              <a:t>Multi-format export capability</a:t>
-            </a:r>
-          </a:p>
-          <a:p>
-            <a:r>
-              <a:rPr lang="en-GY" sz="1200" kern="1200" dirty="0">
-                <a:solidFill>
-                  <a:schemeClr val="tx1"/>
-                </a:solidFill>
-                <a:effectLst/>
-                <a:latin typeface="+mn-lt"/>
-                <a:ea typeface="+mn-ea"/>
-                <a:cs typeface="+mn-cs"/>
-              </a:rPr>
-              <a:t>Automated reporting</a:t>
-            </a:r>
-            <a:endParaRPr lang="en-US" sz="1200" kern="1200" dirty="0">
-              <a:solidFill>
-                <a:schemeClr val="tx1"/>
-              </a:solidFill>
-              <a:effectLst/>
-              <a:latin typeface="+mn-lt"/>
-              <a:ea typeface="+mn-ea"/>
-              <a:cs typeface="+mn-cs"/>
-            </a:endParaRPr>
-          </a:p>
-          <a:p>
-            <a:endParaRPr lang="en-GY" sz="1200" kern="1200" dirty="0">
-              <a:solidFill>
-                <a:schemeClr val="tx1"/>
-              </a:solidFill>
-              <a:effectLst/>
-              <a:latin typeface="+mn-lt"/>
-              <a:ea typeface="+mn-ea"/>
-              <a:cs typeface="+mn-cs"/>
-            </a:endParaRPr>
-          </a:p>
-          <a:p>
-            <a:r>
-              <a:rPr lang="en-GY" sz="1200" kern="1200" dirty="0">
-                <a:solidFill>
-                  <a:schemeClr val="tx1"/>
-                </a:solidFill>
-                <a:effectLst/>
-                <a:latin typeface="+mn-lt"/>
-                <a:ea typeface="+mn-ea"/>
-                <a:cs typeface="+mn-cs"/>
-              </a:rPr>
-              <a:t>“The cleaned dataset was exported into multiple formats to support different analytical environments.”</a:t>
+              <a:t>This stage required the most critical decision-making because duplicate records did not always contain matching supporting information.”</a:t>
             </a:r>
           </a:p>
           <a:p>
@@ -4813,13 +5090,7 @@
       </p:sp>
       <p:sp>
         <p:nvSpPr>
-          <p:cNvPr id="4" name="Slide Number Placeholder 3">
-            <a:extLst>
-              <a:ext uri="{FF2B5EF4-FFF2-40B4-BE49-F238E27FC236}">
-                <a16:creationId xmlns:a16="http://schemas.microsoft.com/office/drawing/2014/main" id="{53F4F6D1-1D31-674E-3252-88C9037D7828}"/>
-              </a:ext>
-            </a:extLst>
-          </p:cNvPr>
+          <p:cNvPr id="4" name="Slide Number Placeholder 3"/>
           <p:cNvSpPr>
             <a:spLocks noGrp="1"/>
           </p:cNvSpPr>
@@ -4834,7 +5105,7 @@
           <a:p>
             <a:fld id="{0C5B4401-7920-4864-9216-E6B6B878A0D8}" type="slidenum">
               <a:rPr lang="en-GY" smtClean="0"/>
-              <a:t>12</a:t>
+              <a:t>11</a:t>
             </a:fld>
             <a:endParaRPr lang="en-GY"/>
           </a:p>
@@ -4843,7 +5114,7 @@
     </p:spTree>
     <p:extLst>
       <p:ext uri="{BB962C8B-B14F-4D97-AF65-F5344CB8AC3E}">
-        <p14:creationId xmlns:p14="http://schemas.microsoft.com/office/powerpoint/2010/main" val="3902701808"/>
+        <p14:creationId xmlns:p14="http://schemas.microsoft.com/office/powerpoint/2010/main" val="416214199"/>
       </p:ext>
     </p:extLst>
   </p:cSld>
@@ -4858,13 +5129,7 @@
   <p:cSld>
     <p:spTree>
       <p:nvGrpSpPr>
-        <p:cNvPr id="1" name="">
-          <a:extLst>
-            <a:ext uri="{FF2B5EF4-FFF2-40B4-BE49-F238E27FC236}">
-              <a16:creationId xmlns:a16="http://schemas.microsoft.com/office/drawing/2014/main" id="{367CA7C9-B38A-23B8-4827-1A9FD6CC1B5D}"/>
-            </a:ext>
-          </a:extLst>
-        </p:cNvPr>
+        <p:cNvPr id="1" name=""/>
         <p:cNvGrpSpPr/>
         <p:nvPr/>
       </p:nvGrpSpPr>
@@ -4878,13 +5143,7 @@
       </p:grpSpPr>
       <p:sp>
         <p:nvSpPr>
-          <p:cNvPr id="2" name="Slide Image Placeholder 1">
-            <a:extLst>
-              <a:ext uri="{FF2B5EF4-FFF2-40B4-BE49-F238E27FC236}">
-                <a16:creationId xmlns:a16="http://schemas.microsoft.com/office/drawing/2014/main" id="{0DBC68F8-2F2C-F461-E2C6-7D966F527E7B}"/>
-              </a:ext>
-            </a:extLst>
-          </p:cNvPr>
+          <p:cNvPr id="2" name="Slide Image Placeholder 1"/>
           <p:cNvSpPr>
             <a:spLocks noGrp="1" noRot="1" noChangeAspect="1"/>
           </p:cNvSpPr>
@@ -4896,13 +5155,7 @@
       </p:sp>
       <p:sp>
         <p:nvSpPr>
-          <p:cNvPr id="3" name="Notes Placeholder 2">
-            <a:extLst>
-              <a:ext uri="{FF2B5EF4-FFF2-40B4-BE49-F238E27FC236}">
-                <a16:creationId xmlns:a16="http://schemas.microsoft.com/office/drawing/2014/main" id="{03DF7ABD-A659-9A17-06ED-68C1732CB316}"/>
-              </a:ext>
-            </a:extLst>
-          </p:cNvPr>
+          <p:cNvPr id="3" name="Notes Placeholder 2"/>
           <p:cNvSpPr>
             <a:spLocks noGrp="1"/>
           </p:cNvSpPr>
@@ -4925,71 +5178,15 @@
                 <a:ea typeface="+mn-ea"/>
                 <a:cs typeface="+mn-cs"/>
               </a:rPr>
-              <a:t>Multi-format export capability</a:t>
-            </a:r>
-          </a:p>
-          <a:p>
-            <a:r>
-              <a:rPr lang="en-GY" sz="1200" kern="1200" dirty="0">
-                <a:solidFill>
-                  <a:schemeClr val="tx1"/>
-                </a:solidFill>
-                <a:effectLst/>
-                <a:latin typeface="+mn-lt"/>
-                <a:ea typeface="+mn-ea"/>
-                <a:cs typeface="+mn-cs"/>
-              </a:rPr>
-              <a:t>Automated reporting</a:t>
-            </a:r>
-            <a:endParaRPr lang="en-US" sz="1200" kern="1200" dirty="0">
-              <a:solidFill>
-                <a:schemeClr val="tx1"/>
-              </a:solidFill>
-              <a:effectLst/>
-              <a:latin typeface="+mn-lt"/>
-              <a:ea typeface="+mn-ea"/>
-              <a:cs typeface="+mn-cs"/>
-            </a:endParaRPr>
-          </a:p>
-          <a:p>
-            <a:endParaRPr lang="en-GY" sz="1200" kern="1200" dirty="0">
-              <a:solidFill>
-                <a:schemeClr val="tx1"/>
-              </a:solidFill>
-              <a:effectLst/>
-              <a:latin typeface="+mn-lt"/>
-              <a:ea typeface="+mn-ea"/>
-              <a:cs typeface="+mn-cs"/>
-            </a:endParaRPr>
-          </a:p>
-          <a:p>
-            <a:r>
-              <a:rPr lang="en-GY" sz="1200" kern="1200" dirty="0">
-                <a:solidFill>
-                  <a:schemeClr val="tx1"/>
-                </a:solidFill>
-                <a:effectLst/>
-                <a:latin typeface="+mn-lt"/>
-                <a:ea typeface="+mn-ea"/>
-                <a:cs typeface="+mn-cs"/>
-              </a:rPr>
-              <a:t>“The cleaned dataset was exported into multiple formats to support different analytical environments.”</a:t>
-            </a:r>
-          </a:p>
-          <a:p>
+              <a:t>Most of the project time was spent resolving data quality and structural pipeline issues.”</a:t>
+            </a:r>
             <a:endParaRPr lang="en-GY" dirty="0"/>
           </a:p>
         </p:txBody>
       </p:sp>
       <p:sp>
         <p:nvSpPr>
-          <p:cNvPr id="4" name="Slide Number Placeholder 3">
-            <a:extLst>
-              <a:ext uri="{FF2B5EF4-FFF2-40B4-BE49-F238E27FC236}">
-                <a16:creationId xmlns:a16="http://schemas.microsoft.com/office/drawing/2014/main" id="{FB46AB7D-3FCF-7CFB-0D0F-F4150B761BF7}"/>
-              </a:ext>
-            </a:extLst>
-          </p:cNvPr>
+          <p:cNvPr id="4" name="Slide Number Placeholder 3"/>
           <p:cNvSpPr>
             <a:spLocks noGrp="1"/>
           </p:cNvSpPr>
@@ -5004,7 +5201,7 @@
           <a:p>
             <a:fld id="{0C5B4401-7920-4864-9216-E6B6B878A0D8}" type="slidenum">
               <a:rPr lang="en-GY" smtClean="0"/>
-              <a:t>13</a:t>
+              <a:t>12</a:t>
             </a:fld>
             <a:endParaRPr lang="en-GY"/>
           </a:p>
@@ -5013,7 +5210,7 @@
     </p:spTree>
     <p:extLst>
       <p:ext uri="{BB962C8B-B14F-4D97-AF65-F5344CB8AC3E}">
-        <p14:creationId xmlns:p14="http://schemas.microsoft.com/office/powerpoint/2010/main" val="1796579337"/>
+        <p14:creationId xmlns:p14="http://schemas.microsoft.com/office/powerpoint/2010/main" val="4207687014"/>
       </p:ext>
     </p:extLst>
   </p:cSld>
@@ -5028,13 +5225,7 @@
   <p:cSld>
     <p:spTree>
       <p:nvGrpSpPr>
-        <p:cNvPr id="1" name="">
-          <a:extLst>
-            <a:ext uri="{FF2B5EF4-FFF2-40B4-BE49-F238E27FC236}">
-              <a16:creationId xmlns:a16="http://schemas.microsoft.com/office/drawing/2014/main" id="{50B3F3E5-6001-3382-8C0B-A7B4B61119E8}"/>
-            </a:ext>
-          </a:extLst>
-        </p:cNvPr>
+        <p:cNvPr id="1" name=""/>
         <p:cNvGrpSpPr/>
         <p:nvPr/>
       </p:nvGrpSpPr>
@@ -5048,13 +5239,7 @@
       </p:grpSpPr>
       <p:sp>
         <p:nvSpPr>
-          <p:cNvPr id="2" name="Slide Image Placeholder 1">
-            <a:extLst>
-              <a:ext uri="{FF2B5EF4-FFF2-40B4-BE49-F238E27FC236}">
-                <a16:creationId xmlns:a16="http://schemas.microsoft.com/office/drawing/2014/main" id="{247B3A7B-4FF9-BF5E-60EA-0DE1157C3DC1}"/>
-              </a:ext>
-            </a:extLst>
-          </p:cNvPr>
+          <p:cNvPr id="2" name="Slide Image Placeholder 1"/>
           <p:cNvSpPr>
             <a:spLocks noGrp="1" noRot="1" noChangeAspect="1"/>
           </p:cNvSpPr>
@@ -5066,13 +5251,7 @@
       </p:sp>
       <p:sp>
         <p:nvSpPr>
-          <p:cNvPr id="3" name="Notes Placeholder 2">
-            <a:extLst>
-              <a:ext uri="{FF2B5EF4-FFF2-40B4-BE49-F238E27FC236}">
-                <a16:creationId xmlns:a16="http://schemas.microsoft.com/office/drawing/2014/main" id="{2B4DBC15-C79A-9118-6888-30F21D7616D4}"/>
-              </a:ext>
-            </a:extLst>
-          </p:cNvPr>
+          <p:cNvPr id="3" name="Notes Placeholder 2"/>
           <p:cNvSpPr>
             <a:spLocks noGrp="1"/>
           </p:cNvSpPr>
@@ -5095,71 +5274,15 @@
                 <a:ea typeface="+mn-ea"/>
                 <a:cs typeface="+mn-cs"/>
               </a:rPr>
-              <a:t>Multi-format export capability</a:t>
-            </a:r>
-          </a:p>
-          <a:p>
-            <a:r>
-              <a:rPr lang="en-GY" sz="1200" kern="1200" dirty="0">
-                <a:solidFill>
-                  <a:schemeClr val="tx1"/>
-                </a:solidFill>
-                <a:effectLst/>
-                <a:latin typeface="+mn-lt"/>
-                <a:ea typeface="+mn-ea"/>
-                <a:cs typeface="+mn-cs"/>
-              </a:rPr>
-              <a:t>Automated reporting</a:t>
-            </a:r>
-            <a:endParaRPr lang="en-US" sz="1200" kern="1200" dirty="0">
-              <a:solidFill>
-                <a:schemeClr val="tx1"/>
-              </a:solidFill>
-              <a:effectLst/>
-              <a:latin typeface="+mn-lt"/>
-              <a:ea typeface="+mn-ea"/>
-              <a:cs typeface="+mn-cs"/>
-            </a:endParaRPr>
-          </a:p>
-          <a:p>
-            <a:endParaRPr lang="en-GY" sz="1200" kern="1200" dirty="0">
-              <a:solidFill>
-                <a:schemeClr val="tx1"/>
-              </a:solidFill>
-              <a:effectLst/>
-              <a:latin typeface="+mn-lt"/>
-              <a:ea typeface="+mn-ea"/>
-              <a:cs typeface="+mn-cs"/>
-            </a:endParaRPr>
-          </a:p>
-          <a:p>
-            <a:r>
-              <a:rPr lang="en-GY" sz="1200" kern="1200" dirty="0">
-                <a:solidFill>
-                  <a:schemeClr val="tx1"/>
-                </a:solidFill>
-                <a:effectLst/>
-                <a:latin typeface="+mn-lt"/>
-                <a:ea typeface="+mn-ea"/>
-                <a:cs typeface="+mn-cs"/>
-              </a:rPr>
-              <a:t>“The cleaned dataset was exported into multiple formats to support different analytical environments.”</a:t>
-            </a:r>
-          </a:p>
-          <a:p>
+              <a:t>With more time, I would focus on improving identity resolution accuracy and expanding downstream analysis</a:t>
+            </a:r>
             <a:endParaRPr lang="en-GY" dirty="0"/>
           </a:p>
         </p:txBody>
       </p:sp>
       <p:sp>
         <p:nvSpPr>
-          <p:cNvPr id="4" name="Slide Number Placeholder 3">
-            <a:extLst>
-              <a:ext uri="{FF2B5EF4-FFF2-40B4-BE49-F238E27FC236}">
-                <a16:creationId xmlns:a16="http://schemas.microsoft.com/office/drawing/2014/main" id="{FDF46CC8-218C-CD44-BE97-EF825DDD7265}"/>
-              </a:ext>
-            </a:extLst>
-          </p:cNvPr>
+          <p:cNvPr id="4" name="Slide Number Placeholder 3"/>
           <p:cNvSpPr>
             <a:spLocks noGrp="1"/>
           </p:cNvSpPr>
@@ -5174,7 +5297,7 @@
           <a:p>
             <a:fld id="{0C5B4401-7920-4864-9216-E6B6B878A0D8}" type="slidenum">
               <a:rPr lang="en-GY" smtClean="0"/>
-              <a:t>14</a:t>
+              <a:t>13</a:t>
             </a:fld>
             <a:endParaRPr lang="en-GY"/>
           </a:p>
@@ -5183,7 +5306,7 @@
     </p:spTree>
     <p:extLst>
       <p:ext uri="{BB962C8B-B14F-4D97-AF65-F5344CB8AC3E}">
-        <p14:creationId xmlns:p14="http://schemas.microsoft.com/office/powerpoint/2010/main" val="1445123426"/>
+        <p14:creationId xmlns:p14="http://schemas.microsoft.com/office/powerpoint/2010/main" val="548203994"/>
       </p:ext>
     </p:extLst>
   </p:cSld>
@@ -5237,496 +5360,6 @@
           <a:bodyPr/>
           <a:lstStyle/>
           <a:p>
-            <a:endParaRPr lang="en-GY" sz="1200" kern="1200" dirty="0">
-              <a:solidFill>
-                <a:schemeClr val="tx1"/>
-              </a:solidFill>
-              <a:effectLst/>
-              <a:latin typeface="+mn-lt"/>
-              <a:ea typeface="+mn-ea"/>
-              <a:cs typeface="+mn-cs"/>
-            </a:endParaRPr>
-          </a:p>
-          <a:p>
-            <a:r>
-              <a:rPr lang="en-GY" sz="1200" kern="1200" dirty="0">
-                <a:solidFill>
-                  <a:schemeClr val="tx1"/>
-                </a:solidFill>
-                <a:effectLst/>
-                <a:latin typeface="+mn-lt"/>
-                <a:ea typeface="+mn-ea"/>
-                <a:cs typeface="+mn-cs"/>
-              </a:rPr>
-              <a:t>“One major success was achieving a complete automated workflow from ingestion to reporting.”</a:t>
-            </a:r>
-          </a:p>
-          <a:p>
-            <a:endParaRPr lang="en-GY" dirty="0"/>
-          </a:p>
-        </p:txBody>
-      </p:sp>
-      <p:sp>
-        <p:nvSpPr>
-          <p:cNvPr id="4" name="Slide Number Placeholder 3"/>
-          <p:cNvSpPr>
-            <a:spLocks noGrp="1"/>
-          </p:cNvSpPr>
-          <p:nvPr>
-            <p:ph type="sldNum" sz="quarter" idx="5"/>
-          </p:nvPr>
-        </p:nvSpPr>
-        <p:spPr/>
-        <p:txBody>
-          <a:bodyPr/>
-          <a:lstStyle/>
-          <a:p>
-            <a:fld id="{0C5B4401-7920-4864-9216-E6B6B878A0D8}" type="slidenum">
-              <a:rPr lang="en-GY" smtClean="0"/>
-              <a:t>15</a:t>
-            </a:fld>
-            <a:endParaRPr lang="en-GY"/>
-          </a:p>
-        </p:txBody>
-      </p:sp>
-    </p:spTree>
-    <p:extLst>
-      <p:ext uri="{BB962C8B-B14F-4D97-AF65-F5344CB8AC3E}">
-        <p14:creationId xmlns:p14="http://schemas.microsoft.com/office/powerpoint/2010/main" val="942569959"/>
-      </p:ext>
-    </p:extLst>
-  </p:cSld>
-  <p:clrMapOvr>
-    <a:masterClrMapping/>
-  </p:clrMapOvr>
-</p:notes>
-</file>
-
-<file path=ppt/notesSlides/notesSlide15.xml><?xml version="1.0" encoding="utf-8"?>
-<p:notes xmlns:a="http://schemas.openxmlformats.org/drawingml/2006/main" xmlns:r="http://schemas.openxmlformats.org/officeDocument/2006/relationships" xmlns:p="http://schemas.openxmlformats.org/presentationml/2006/main">
-  <p:cSld>
-    <p:spTree>
-      <p:nvGrpSpPr>
-        <p:cNvPr id="1" name=""/>
-        <p:cNvGrpSpPr/>
-        <p:nvPr/>
-      </p:nvGrpSpPr>
-      <p:grpSpPr>
-        <a:xfrm>
-          <a:off x="0" y="0"/>
-          <a:ext cx="0" cy="0"/>
-          <a:chOff x="0" y="0"/>
-          <a:chExt cx="0" cy="0"/>
-        </a:xfrm>
-      </p:grpSpPr>
-      <p:sp>
-        <p:nvSpPr>
-          <p:cNvPr id="2" name="Slide Image Placeholder 1"/>
-          <p:cNvSpPr>
-            <a:spLocks noGrp="1" noRot="1" noChangeAspect="1"/>
-          </p:cNvSpPr>
-          <p:nvPr>
-            <p:ph type="sldImg"/>
-          </p:nvPr>
-        </p:nvSpPr>
-        <p:spPr/>
-      </p:sp>
-      <p:sp>
-        <p:nvSpPr>
-          <p:cNvPr id="3" name="Notes Placeholder 2"/>
-          <p:cNvSpPr>
-            <a:spLocks noGrp="1"/>
-          </p:cNvSpPr>
-          <p:nvPr>
-            <p:ph type="body" idx="1"/>
-          </p:nvPr>
-        </p:nvSpPr>
-        <p:spPr/>
-        <p:txBody>
-          <a:bodyPr/>
-          <a:lstStyle/>
-          <a:p>
-            <a:r>
-              <a:rPr lang="en-US" dirty="0"/>
-              <a:t>Handling duplicate patient identities</a:t>
-            </a:r>
-          </a:p>
-          <a:p>
-            <a:r>
-              <a:rPr lang="en-US" dirty="0"/>
-              <a:t>- Deciding which records to retain</a:t>
-            </a:r>
-          </a:p>
-          <a:p>
-            <a:r>
-              <a:rPr lang="en-US" dirty="0"/>
-              <a:t>- Structuring pipeline stages correctly</a:t>
-            </a:r>
-          </a:p>
-          <a:p>
-            <a:pPr marL="0" marR="0" lvl="0" indent="0" algn="l" defTabSz="914400" rtl="0" eaLnBrk="1" fontAlgn="auto" latinLnBrk="0" hangingPunct="1">
-              <a:lnSpc>
-                <a:spcPct val="100000"/>
-              </a:lnSpc>
-              <a:spcBef>
-                <a:spcPts val="0"/>
-              </a:spcBef>
-              <a:spcAft>
-                <a:spcPts val="0"/>
-              </a:spcAft>
-              <a:buClrTx/>
-              <a:buSzTx/>
-              <a:buFontTx/>
-              <a:buNone/>
-              <a:tabLst/>
-              <a:defRPr/>
-            </a:pPr>
-            <a:endParaRPr lang="en-US" sz="1200" kern="1200" dirty="0">
-              <a:solidFill>
-                <a:schemeClr val="tx1"/>
-              </a:solidFill>
-              <a:effectLst/>
-              <a:latin typeface="+mn-lt"/>
-              <a:ea typeface="+mn-ea"/>
-              <a:cs typeface="+mn-cs"/>
-            </a:endParaRPr>
-          </a:p>
-          <a:p>
-            <a:pPr marL="0" marR="0" lvl="0" indent="0" algn="l" defTabSz="914400" rtl="0" eaLnBrk="1" fontAlgn="auto" latinLnBrk="0" hangingPunct="1">
-              <a:lnSpc>
-                <a:spcPct val="100000"/>
-              </a:lnSpc>
-              <a:spcBef>
-                <a:spcPts val="0"/>
-              </a:spcBef>
-              <a:spcAft>
-                <a:spcPts val="0"/>
-              </a:spcAft>
-              <a:buClrTx/>
-              <a:buSzTx/>
-              <a:buFontTx/>
-              <a:buNone/>
-              <a:tabLst/>
-              <a:defRPr/>
-            </a:pPr>
-            <a:endParaRPr lang="en-US" sz="1200" kern="1200" dirty="0">
-              <a:solidFill>
-                <a:schemeClr val="tx1"/>
-              </a:solidFill>
-              <a:effectLst/>
-              <a:latin typeface="+mn-lt"/>
-              <a:ea typeface="+mn-ea"/>
-              <a:cs typeface="+mn-cs"/>
-            </a:endParaRPr>
-          </a:p>
-          <a:p>
-            <a:pPr marL="0" marR="0" lvl="0" indent="0" algn="l" defTabSz="914400" rtl="0" eaLnBrk="1" fontAlgn="auto" latinLnBrk="0" hangingPunct="1">
-              <a:lnSpc>
-                <a:spcPct val="100000"/>
-              </a:lnSpc>
-              <a:spcBef>
-                <a:spcPts val="0"/>
-              </a:spcBef>
-              <a:spcAft>
-                <a:spcPts val="0"/>
-              </a:spcAft>
-              <a:buClrTx/>
-              <a:buSzTx/>
-              <a:buFontTx/>
-              <a:buNone/>
-              <a:tabLst/>
-              <a:defRPr/>
-            </a:pPr>
-            <a:r>
-              <a:rPr lang="en-GY" sz="1200" kern="1200" dirty="0">
-                <a:solidFill>
-                  <a:schemeClr val="tx1"/>
-                </a:solidFill>
-                <a:effectLst/>
-                <a:latin typeface="+mn-lt"/>
-                <a:ea typeface="+mn-ea"/>
-                <a:cs typeface="+mn-cs"/>
-              </a:rPr>
-              <a:t>This stage required the most critical decision-making because duplicate records did not always contain matching supporting information.”</a:t>
-            </a:r>
-          </a:p>
-          <a:p>
-            <a:endParaRPr lang="en-GY" dirty="0"/>
-          </a:p>
-        </p:txBody>
-      </p:sp>
-      <p:sp>
-        <p:nvSpPr>
-          <p:cNvPr id="4" name="Slide Number Placeholder 3"/>
-          <p:cNvSpPr>
-            <a:spLocks noGrp="1"/>
-          </p:cNvSpPr>
-          <p:nvPr>
-            <p:ph type="sldNum" sz="quarter" idx="5"/>
-          </p:nvPr>
-        </p:nvSpPr>
-        <p:spPr/>
-        <p:txBody>
-          <a:bodyPr/>
-          <a:lstStyle/>
-          <a:p>
-            <a:fld id="{0C5B4401-7920-4864-9216-E6B6B878A0D8}" type="slidenum">
-              <a:rPr lang="en-GY" smtClean="0"/>
-              <a:t>16</a:t>
-            </a:fld>
-            <a:endParaRPr lang="en-GY"/>
-          </a:p>
-        </p:txBody>
-      </p:sp>
-    </p:spTree>
-    <p:extLst>
-      <p:ext uri="{BB962C8B-B14F-4D97-AF65-F5344CB8AC3E}">
-        <p14:creationId xmlns:p14="http://schemas.microsoft.com/office/powerpoint/2010/main" val="416214199"/>
-      </p:ext>
-    </p:extLst>
-  </p:cSld>
-  <p:clrMapOvr>
-    <a:masterClrMapping/>
-  </p:clrMapOvr>
-</p:notes>
-</file>
-
-<file path=ppt/notesSlides/notesSlide16.xml><?xml version="1.0" encoding="utf-8"?>
-<p:notes xmlns:a="http://schemas.openxmlformats.org/drawingml/2006/main" xmlns:r="http://schemas.openxmlformats.org/officeDocument/2006/relationships" xmlns:p="http://schemas.openxmlformats.org/presentationml/2006/main">
-  <p:cSld>
-    <p:spTree>
-      <p:nvGrpSpPr>
-        <p:cNvPr id="1" name=""/>
-        <p:cNvGrpSpPr/>
-        <p:nvPr/>
-      </p:nvGrpSpPr>
-      <p:grpSpPr>
-        <a:xfrm>
-          <a:off x="0" y="0"/>
-          <a:ext cx="0" cy="0"/>
-          <a:chOff x="0" y="0"/>
-          <a:chExt cx="0" cy="0"/>
-        </a:xfrm>
-      </p:grpSpPr>
-      <p:sp>
-        <p:nvSpPr>
-          <p:cNvPr id="2" name="Slide Image Placeholder 1"/>
-          <p:cNvSpPr>
-            <a:spLocks noGrp="1" noRot="1" noChangeAspect="1"/>
-          </p:cNvSpPr>
-          <p:nvPr>
-            <p:ph type="sldImg"/>
-          </p:nvPr>
-        </p:nvSpPr>
-        <p:spPr/>
-      </p:sp>
-      <p:sp>
-        <p:nvSpPr>
-          <p:cNvPr id="3" name="Notes Placeholder 2"/>
-          <p:cNvSpPr>
-            <a:spLocks noGrp="1"/>
-          </p:cNvSpPr>
-          <p:nvPr>
-            <p:ph type="body" idx="1"/>
-          </p:nvPr>
-        </p:nvSpPr>
-        <p:spPr/>
-        <p:txBody>
-          <a:bodyPr/>
-          <a:lstStyle/>
-          <a:p>
-            <a:r>
-              <a:rPr lang="en-GY" sz="1200" kern="1200" dirty="0">
-                <a:solidFill>
-                  <a:schemeClr val="tx1"/>
-                </a:solidFill>
-                <a:effectLst/>
-                <a:latin typeface="+mn-lt"/>
-                <a:ea typeface="+mn-ea"/>
-                <a:cs typeface="+mn-cs"/>
-              </a:rPr>
-              <a:t>Most of the project time was spent resolving data quality and structural pipeline issues.”</a:t>
-            </a:r>
-            <a:endParaRPr lang="en-GY" dirty="0"/>
-          </a:p>
-        </p:txBody>
-      </p:sp>
-      <p:sp>
-        <p:nvSpPr>
-          <p:cNvPr id="4" name="Slide Number Placeholder 3"/>
-          <p:cNvSpPr>
-            <a:spLocks noGrp="1"/>
-          </p:cNvSpPr>
-          <p:nvPr>
-            <p:ph type="sldNum" sz="quarter" idx="5"/>
-          </p:nvPr>
-        </p:nvSpPr>
-        <p:spPr/>
-        <p:txBody>
-          <a:bodyPr/>
-          <a:lstStyle/>
-          <a:p>
-            <a:fld id="{0C5B4401-7920-4864-9216-E6B6B878A0D8}" type="slidenum">
-              <a:rPr lang="en-GY" smtClean="0"/>
-              <a:t>17</a:t>
-            </a:fld>
-            <a:endParaRPr lang="en-GY"/>
-          </a:p>
-        </p:txBody>
-      </p:sp>
-    </p:spTree>
-    <p:extLst>
-      <p:ext uri="{BB962C8B-B14F-4D97-AF65-F5344CB8AC3E}">
-        <p14:creationId xmlns:p14="http://schemas.microsoft.com/office/powerpoint/2010/main" val="4207687014"/>
-      </p:ext>
-    </p:extLst>
-  </p:cSld>
-  <p:clrMapOvr>
-    <a:masterClrMapping/>
-  </p:clrMapOvr>
-</p:notes>
-</file>
-
-<file path=ppt/notesSlides/notesSlide17.xml><?xml version="1.0" encoding="utf-8"?>
-<p:notes xmlns:a="http://schemas.openxmlformats.org/drawingml/2006/main" xmlns:r="http://schemas.openxmlformats.org/officeDocument/2006/relationships" xmlns:p="http://schemas.openxmlformats.org/presentationml/2006/main">
-  <p:cSld>
-    <p:spTree>
-      <p:nvGrpSpPr>
-        <p:cNvPr id="1" name=""/>
-        <p:cNvGrpSpPr/>
-        <p:nvPr/>
-      </p:nvGrpSpPr>
-      <p:grpSpPr>
-        <a:xfrm>
-          <a:off x="0" y="0"/>
-          <a:ext cx="0" cy="0"/>
-          <a:chOff x="0" y="0"/>
-          <a:chExt cx="0" cy="0"/>
-        </a:xfrm>
-      </p:grpSpPr>
-      <p:sp>
-        <p:nvSpPr>
-          <p:cNvPr id="2" name="Slide Image Placeholder 1"/>
-          <p:cNvSpPr>
-            <a:spLocks noGrp="1" noRot="1" noChangeAspect="1"/>
-          </p:cNvSpPr>
-          <p:nvPr>
-            <p:ph type="sldImg"/>
-          </p:nvPr>
-        </p:nvSpPr>
-        <p:spPr/>
-      </p:sp>
-      <p:sp>
-        <p:nvSpPr>
-          <p:cNvPr id="3" name="Notes Placeholder 2"/>
-          <p:cNvSpPr>
-            <a:spLocks noGrp="1"/>
-          </p:cNvSpPr>
-          <p:nvPr>
-            <p:ph type="body" idx="1"/>
-          </p:nvPr>
-        </p:nvSpPr>
-        <p:spPr/>
-        <p:txBody>
-          <a:bodyPr/>
-          <a:lstStyle/>
-          <a:p>
-            <a:r>
-              <a:rPr lang="en-GY" sz="1200" kern="1200" dirty="0">
-                <a:solidFill>
-                  <a:schemeClr val="tx1"/>
-                </a:solidFill>
-                <a:effectLst/>
-                <a:latin typeface="+mn-lt"/>
-                <a:ea typeface="+mn-ea"/>
-                <a:cs typeface="+mn-cs"/>
-              </a:rPr>
-              <a:t>With more time, I would focus on improving identity resolution accuracy and expanding downstream analysis</a:t>
-            </a:r>
-            <a:endParaRPr lang="en-GY" dirty="0"/>
-          </a:p>
-        </p:txBody>
-      </p:sp>
-      <p:sp>
-        <p:nvSpPr>
-          <p:cNvPr id="4" name="Slide Number Placeholder 3"/>
-          <p:cNvSpPr>
-            <a:spLocks noGrp="1"/>
-          </p:cNvSpPr>
-          <p:nvPr>
-            <p:ph type="sldNum" sz="quarter" idx="5"/>
-          </p:nvPr>
-        </p:nvSpPr>
-        <p:spPr/>
-        <p:txBody>
-          <a:bodyPr/>
-          <a:lstStyle/>
-          <a:p>
-            <a:fld id="{0C5B4401-7920-4864-9216-E6B6B878A0D8}" type="slidenum">
-              <a:rPr lang="en-GY" smtClean="0"/>
-              <a:t>18</a:t>
-            </a:fld>
-            <a:endParaRPr lang="en-GY"/>
-          </a:p>
-        </p:txBody>
-      </p:sp>
-    </p:spTree>
-    <p:extLst>
-      <p:ext uri="{BB962C8B-B14F-4D97-AF65-F5344CB8AC3E}">
-        <p14:creationId xmlns:p14="http://schemas.microsoft.com/office/powerpoint/2010/main" val="548203994"/>
-      </p:ext>
-    </p:extLst>
-  </p:cSld>
-  <p:clrMapOvr>
-    <a:masterClrMapping/>
-  </p:clrMapOvr>
-</p:notes>
-</file>
-
-<file path=ppt/notesSlides/notesSlide18.xml><?xml version="1.0" encoding="utf-8"?>
-<p:notes xmlns:a="http://schemas.openxmlformats.org/drawingml/2006/main" xmlns:r="http://schemas.openxmlformats.org/officeDocument/2006/relationships" xmlns:p="http://schemas.openxmlformats.org/presentationml/2006/main">
-  <p:cSld>
-    <p:spTree>
-      <p:nvGrpSpPr>
-        <p:cNvPr id="1" name=""/>
-        <p:cNvGrpSpPr/>
-        <p:nvPr/>
-      </p:nvGrpSpPr>
-      <p:grpSpPr>
-        <a:xfrm>
-          <a:off x="0" y="0"/>
-          <a:ext cx="0" cy="0"/>
-          <a:chOff x="0" y="0"/>
-          <a:chExt cx="0" cy="0"/>
-        </a:xfrm>
-      </p:grpSpPr>
-      <p:sp>
-        <p:nvSpPr>
-          <p:cNvPr id="2" name="Slide Image Placeholder 1"/>
-          <p:cNvSpPr>
-            <a:spLocks noGrp="1" noRot="1" noChangeAspect="1"/>
-          </p:cNvSpPr>
-          <p:nvPr>
-            <p:ph type="sldImg"/>
-          </p:nvPr>
-        </p:nvSpPr>
-        <p:spPr/>
-      </p:sp>
-      <p:sp>
-        <p:nvSpPr>
-          <p:cNvPr id="3" name="Notes Placeholder 2"/>
-          <p:cNvSpPr>
-            <a:spLocks noGrp="1"/>
-          </p:cNvSpPr>
-          <p:nvPr>
-            <p:ph type="body" idx="1"/>
-          </p:nvPr>
-        </p:nvSpPr>
-        <p:spPr/>
-        <p:txBody>
-          <a:bodyPr/>
-          <a:lstStyle/>
-          <a:p>
             <a:r>
               <a:rPr lang="en-GY" sz="1200" kern="1200" dirty="0">
                 <a:solidFill>
@@ -5760,7 +5393,7 @@
           <a:p>
             <a:fld id="{0C5B4401-7920-4864-9216-E6B6B878A0D8}" type="slidenum">
               <a:rPr lang="en-GY" smtClean="0"/>
-              <a:t>19</a:t>
+              <a:t>14</a:t>
             </a:fld>
             <a:endParaRPr lang="en-GY"/>
           </a:p>
@@ -5962,8 +5595,67 @@
                 <a:ea typeface="+mn-ea"/>
                 <a:cs typeface="+mn-cs"/>
               </a:rPr>
-              <a:t>The goal was not only to clean the data, but to create a reproducible pipeline that could run end-to-end.</a:t>
-            </a:r>
+              <a:t>The goal was not only to clean the data, but to create a </a:t>
+            </a:r>
+            <a:r>
+              <a:rPr lang="en-US" sz="1200" kern="1200" dirty="0">
+                <a:solidFill>
+                  <a:schemeClr val="tx1"/>
+                </a:solidFill>
+                <a:effectLst/>
+                <a:latin typeface="+mn-lt"/>
+                <a:ea typeface="+mn-ea"/>
+                <a:cs typeface="+mn-cs"/>
+              </a:rPr>
+              <a:t>modular </a:t>
+            </a:r>
+            <a:r>
+              <a:rPr lang="en-GY" sz="1200" kern="1200" dirty="0">
+                <a:solidFill>
+                  <a:schemeClr val="tx1"/>
+                </a:solidFill>
+                <a:effectLst/>
+                <a:latin typeface="+mn-lt"/>
+                <a:ea typeface="+mn-ea"/>
+                <a:cs typeface="+mn-cs"/>
+              </a:rPr>
+              <a:t>reproducible pipeline that could run end-to-end.</a:t>
+            </a:r>
+            <a:endParaRPr lang="en-US" sz="1200" kern="1200" dirty="0">
+              <a:solidFill>
+                <a:schemeClr val="tx1"/>
+              </a:solidFill>
+              <a:effectLst/>
+              <a:latin typeface="+mn-lt"/>
+              <a:ea typeface="+mn-ea"/>
+              <a:cs typeface="+mn-cs"/>
+            </a:endParaRPr>
+          </a:p>
+          <a:p>
+            <a:r>
+              <a:rPr lang="en-US" dirty="0"/>
+              <a:t>Generate analysis-ready datasets and automated reporting outputs.</a:t>
+            </a:r>
+          </a:p>
+          <a:p>
+            <a:endParaRPr lang="en-US" dirty="0"/>
+          </a:p>
+          <a:p>
+            <a:r>
+              <a:rPr lang="en-US" dirty="0"/>
+              <a:t>Additional supporting validation and auditability steps were implemented to improve reproducibility and transparency of the pipeline.”</a:t>
+            </a:r>
+          </a:p>
+          <a:p>
+            <a:endParaRPr lang="en-US" dirty="0"/>
+          </a:p>
+          <a:p>
+            <a:r>
+              <a:rPr lang="en-US" dirty="0"/>
+              <a:t>Support reproducibility, auditability, and multi-format exports.</a:t>
+            </a:r>
+          </a:p>
+          <a:p>
             <a:endParaRPr lang="en-GY" dirty="0"/>
           </a:p>
         </p:txBody>
@@ -6055,17 +5747,6 @@
           <a:bodyPr/>
           <a:lstStyle/>
           <a:p>
-            <a:endParaRPr lang="en-GY" sz="1200" kern="1200" dirty="0">
-              <a:solidFill>
-                <a:schemeClr val="tx1"/>
-              </a:solidFill>
-              <a:effectLst/>
-              <a:latin typeface="+mn-lt"/>
-              <a:ea typeface="+mn-ea"/>
-              <a:cs typeface="+mn-cs"/>
-            </a:endParaRPr>
-          </a:p>
-          <a:p>
             <a:r>
               <a:rPr lang="en-GY" sz="1200" kern="1200" dirty="0">
                 <a:solidFill>
@@ -6149,7 +5830,7 @@
     </p:spTree>
     <p:extLst>
       <p:ext uri="{BB962C8B-B14F-4D97-AF65-F5344CB8AC3E}">
-        <p14:creationId xmlns:p14="http://schemas.microsoft.com/office/powerpoint/2010/main" val="1105184965"/>
+        <p14:creationId xmlns:p14="http://schemas.microsoft.com/office/powerpoint/2010/main" val="3836750050"/>
       </p:ext>
     </p:extLst>
   </p:cSld>
@@ -6220,25 +5901,9 @@
                 <a:ea typeface="+mn-ea"/>
                 <a:cs typeface="+mn-cs"/>
               </a:rPr>
-              <a:t>Modular pipeline structure</a:t>
-            </a:r>
-          </a:p>
-          <a:p>
-            <a:r>
-              <a:rPr lang="en-GY" sz="1200" kern="1200" dirty="0">
-                <a:solidFill>
-                  <a:schemeClr val="tx1"/>
-                </a:solidFill>
-                <a:effectLst/>
-                <a:latin typeface="+mn-lt"/>
-                <a:ea typeface="+mn-ea"/>
-                <a:cs typeface="+mn-cs"/>
-              </a:rPr>
-              <a:t>Each script performs one responsibility</a:t>
-            </a:r>
-          </a:p>
-          <a:p>
-            <a:endParaRPr lang="en-GY" sz="1200" kern="1200" dirty="0">
+              <a:t>These issues prevented reliable analysis and required structured cleaning and standardisation</a:t>
+            </a:r>
+            <a:endParaRPr lang="en-US" sz="1200" kern="1200" dirty="0">
               <a:solidFill>
                 <a:schemeClr val="tx1"/>
               </a:solidFill>
@@ -6249,20 +5914,42 @@
             </a:endParaRPr>
           </a:p>
           <a:p>
-            <a:r>
-              <a:rPr lang="en-GY" sz="1200" kern="1200" dirty="0">
-                <a:solidFill>
-                  <a:schemeClr val="tx1"/>
-                </a:solidFill>
-                <a:effectLst/>
-                <a:latin typeface="+mn-lt"/>
-                <a:ea typeface="+mn-ea"/>
-                <a:cs typeface="+mn-cs"/>
-              </a:rPr>
-              <a:t>“The project was divided into separate stages to improve readability, maintenance, and reproducibility.”</a:t>
-            </a:r>
-          </a:p>
-          <a:p>
+            <a:endParaRPr lang="en-US" sz="1200" kern="1200" dirty="0">
+              <a:solidFill>
+                <a:schemeClr val="tx1"/>
+              </a:solidFill>
+              <a:effectLst/>
+              <a:latin typeface="+mn-lt"/>
+              <a:ea typeface="+mn-ea"/>
+              <a:cs typeface="+mn-cs"/>
+            </a:endParaRPr>
+          </a:p>
+          <a:p>
+            <a:r>
+              <a:rPr lang="en-US" dirty="0"/>
+              <a:t>Missing Age values</a:t>
+            </a:r>
+          </a:p>
+          <a:p>
+            <a:r>
+              <a:rPr lang="en-US" dirty="0"/>
+              <a:t>Inconsistent Age format</a:t>
+            </a:r>
+          </a:p>
+          <a:p>
+            <a:r>
+              <a:rPr lang="en-US" dirty="0"/>
+              <a:t>Phone number formatting inconsistencies</a:t>
+            </a:r>
+          </a:p>
+          <a:p>
+            <a:endParaRPr lang="en-US" dirty="0"/>
+          </a:p>
+          <a:p>
+            <a:r>
+              <a:rPr lang="en-US" dirty="0"/>
+              <a:t>Were additional issue found in the data set</a:t>
+            </a:r>
             <a:endParaRPr lang="en-GY" dirty="0"/>
           </a:p>
         </p:txBody>
@@ -6293,7 +5980,7 @@
     </p:spTree>
     <p:extLst>
       <p:ext uri="{BB962C8B-B14F-4D97-AF65-F5344CB8AC3E}">
-        <p14:creationId xmlns:p14="http://schemas.microsoft.com/office/powerpoint/2010/main" val="3836750050"/>
+        <p14:creationId xmlns:p14="http://schemas.microsoft.com/office/powerpoint/2010/main" val="3803467270"/>
       </p:ext>
     </p:extLst>
   </p:cSld>
@@ -6331,13 +6018,6 @@
           </p:nvPr>
         </p:nvSpPr>
         <p:spPr/>
-        <p:txBody>
-          <a:bodyPr/>
-          <a:lstStyle/>
-          <a:p>
-            <a:endParaRPr lang="en-GY"/>
-          </a:p>
-        </p:txBody>
       </p:sp>
       <p:sp>
         <p:nvSpPr>
@@ -6355,17 +6035,66 @@
           <a:lstStyle/>
           <a:p>
             <a:r>
-              <a:rPr lang="en-GY" sz="1200" kern="1200" dirty="0">
-                <a:solidFill>
-                  <a:schemeClr val="tx1"/>
-                </a:solidFill>
-                <a:effectLst/>
-                <a:latin typeface="+mn-lt"/>
-                <a:ea typeface="+mn-ea"/>
-                <a:cs typeface="+mn-cs"/>
-              </a:rPr>
-              <a:t>These issues prevented reliable analysis and required structured cleaning and standardisation</a:t>
-            </a:r>
+              <a:rPr lang="en-US" dirty="0"/>
+              <a:t>Patient names </a:t>
+            </a:r>
+            <a:r>
+              <a:rPr lang="en-US" dirty="0" err="1"/>
+              <a:t>standardised</a:t>
+            </a:r>
+            <a:endParaRPr lang="en-US" dirty="0"/>
+          </a:p>
+          <a:p>
+            <a:r>
+              <a:rPr lang="en-US" dirty="0"/>
+              <a:t>Gender, Condition, Medication </a:t>
+            </a:r>
+            <a:r>
+              <a:rPr lang="en-US" dirty="0" err="1"/>
+              <a:t>normalised</a:t>
+            </a:r>
+            <a:endParaRPr lang="en-US" dirty="0"/>
+          </a:p>
+          <a:p>
+            <a:r>
+              <a:rPr lang="en-US" dirty="0"/>
+              <a:t>Dates parsed into standard formats</a:t>
+            </a:r>
+          </a:p>
+          <a:p>
+            <a:endParaRPr lang="en-US" dirty="0"/>
+          </a:p>
+          <a:p>
+            <a:r>
+              <a:rPr lang="en-US" dirty="0"/>
+              <a:t>Additionally </a:t>
+            </a:r>
+          </a:p>
+          <a:p>
+            <a:r>
+              <a:rPr lang="en-US" dirty="0"/>
+              <a:t>Age was cleaned </a:t>
+            </a:r>
+          </a:p>
+          <a:p>
+            <a:r>
+              <a:rPr lang="en-US" dirty="0"/>
+              <a:t>Phone numbers cleaned to digits-only</a:t>
+            </a:r>
+          </a:p>
+          <a:p>
+            <a:r>
+              <a:rPr lang="en-US" dirty="0"/>
+              <a:t>Duplicate visits resolved using Patient Name + Visit Date</a:t>
+            </a:r>
+          </a:p>
+          <a:p>
+            <a:r>
+              <a:rPr lang="en-US" dirty="0"/>
+              <a:t>Cleaning audit logs and duplicate summaries generated</a:t>
+            </a:r>
+          </a:p>
+          <a:p>
             <a:endParaRPr lang="en-GY" dirty="0"/>
           </a:p>
         </p:txBody>
@@ -6396,7 +6125,7 @@
     </p:spTree>
     <p:extLst>
       <p:ext uri="{BB962C8B-B14F-4D97-AF65-F5344CB8AC3E}">
-        <p14:creationId xmlns:p14="http://schemas.microsoft.com/office/powerpoint/2010/main" val="3803467270"/>
+        <p14:creationId xmlns:p14="http://schemas.microsoft.com/office/powerpoint/2010/main" val="2936557387"/>
       </p:ext>
     </p:extLst>
   </p:cSld>
@@ -6483,7 +6212,7 @@
           <a:p>
             <a:fld id="{0C5B4401-7920-4864-9216-E6B6B878A0D8}" type="slidenum">
               <a:rPr lang="en-GY" smtClean="0"/>
-              <a:t>8</a:t>
+              <a:t>7</a:t>
             </a:fld>
             <a:endParaRPr lang="en-GY"/>
           </a:p>
@@ -6608,7 +6337,7 @@
             </a:pPr>
             <a:r>
               <a:rPr lang="en-US" dirty="0"/>
-              <a:t>Before cleaning, several variables contained high levels of missingness. Email had the largest number of missing values, followed by Cholesterol, Phone Number, Blood Pressure, and Age. These missing values reduced the reliability and completeness of the dataset for analysis.</a:t>
+              <a:t>Before cleaning, several variables contained high levels of missingness. Email had the largest number of missing values, followed by Cholesterol, Phone Number, Blood Pressure, and Age. Whilst the variables leading were not the scoped variables, these missing values reduced the reliability and completeness of the dataset for analysis.</a:t>
             </a:r>
           </a:p>
           <a:p>
@@ -6725,7 +6454,7 @@
           <a:p>
             <a:fld id="{0C5B4401-7920-4864-9216-E6B6B878A0D8}" type="slidenum">
               <a:rPr lang="en-GY" smtClean="0"/>
-              <a:t>9</a:t>
+              <a:t>8</a:t>
             </a:fld>
             <a:endParaRPr lang="en-GY"/>
           </a:p>
@@ -6749,7 +6478,13 @@
   <p:cSld>
     <p:spTree>
       <p:nvGrpSpPr>
-        <p:cNvPr id="1" name=""/>
+        <p:cNvPr id="1" name="">
+          <a:extLst>
+            <a:ext uri="{FF2B5EF4-FFF2-40B4-BE49-F238E27FC236}">
+              <a16:creationId xmlns:a16="http://schemas.microsoft.com/office/drawing/2014/main" id="{98EC6154-635E-3915-9BC8-051A8641C483}"/>
+            </a:ext>
+          </a:extLst>
+        </p:cNvPr>
         <p:cNvGrpSpPr/>
         <p:nvPr/>
       </p:nvGrpSpPr>
@@ -6763,7 +6498,13 @@
       </p:grpSpPr>
       <p:sp>
         <p:nvSpPr>
-          <p:cNvPr id="2" name="Slide Image Placeholder 1"/>
+          <p:cNvPr id="2" name="Slide Image Placeholder 1">
+            <a:extLst>
+              <a:ext uri="{FF2B5EF4-FFF2-40B4-BE49-F238E27FC236}">
+                <a16:creationId xmlns:a16="http://schemas.microsoft.com/office/drawing/2014/main" id="{49D26794-5C34-C2A5-96E3-16B2D771D0F4}"/>
+              </a:ext>
+            </a:extLst>
+          </p:cNvPr>
           <p:cNvSpPr>
             <a:spLocks noGrp="1" noRot="1" noChangeAspect="1"/>
           </p:cNvSpPr>
@@ -6775,7 +6516,13 @@
       </p:sp>
       <p:sp>
         <p:nvSpPr>
-          <p:cNvPr id="3" name="Notes Placeholder 2"/>
+          <p:cNvPr id="3" name="Notes Placeholder 2">
+            <a:extLst>
+              <a:ext uri="{FF2B5EF4-FFF2-40B4-BE49-F238E27FC236}">
+                <a16:creationId xmlns:a16="http://schemas.microsoft.com/office/drawing/2014/main" id="{D2D7E4EF-76B9-AAA3-9F63-64BE38D7945B}"/>
+              </a:ext>
+            </a:extLst>
+          </p:cNvPr>
           <p:cNvSpPr>
             <a:spLocks noGrp="1"/>
           </p:cNvSpPr>
@@ -6856,7 +6603,13 @@
       </p:sp>
       <p:sp>
         <p:nvSpPr>
-          <p:cNvPr id="4" name="Slide Number Placeholder 3"/>
+          <p:cNvPr id="4" name="Slide Number Placeholder 3">
+            <a:extLst>
+              <a:ext uri="{FF2B5EF4-FFF2-40B4-BE49-F238E27FC236}">
+                <a16:creationId xmlns:a16="http://schemas.microsoft.com/office/drawing/2014/main" id="{B4D0EA87-1780-179C-1955-8793DA89847B}"/>
+              </a:ext>
+            </a:extLst>
+          </p:cNvPr>
           <p:cNvSpPr>
             <a:spLocks noGrp="1"/>
           </p:cNvSpPr>
@@ -6871,7 +6624,7 @@
           <a:p>
             <a:fld id="{0C5B4401-7920-4864-9216-E6B6B878A0D8}" type="slidenum">
               <a:rPr lang="en-GY" smtClean="0"/>
-              <a:t>10</a:t>
+              <a:t>9</a:t>
             </a:fld>
             <a:endParaRPr lang="en-GY"/>
           </a:p>
@@ -6880,7 +6633,7 @@
     </p:spTree>
     <p:extLst>
       <p:ext uri="{BB962C8B-B14F-4D97-AF65-F5344CB8AC3E}">
-        <p14:creationId xmlns:p14="http://schemas.microsoft.com/office/powerpoint/2010/main" val="53755327"/>
+        <p14:creationId xmlns:p14="http://schemas.microsoft.com/office/powerpoint/2010/main" val="2086864947"/>
       </p:ext>
     </p:extLst>
   </p:cSld>
@@ -7130,7 +6883,7 @@
           <a:p>
             <a:fld id="{5BCAD085-E8A6-8845-BD4E-CB4CCA059FC4}" type="datetimeFigureOut">
               <a:rPr lang="en-US" smtClean="0"/>
-              <a:t>5/7/2026</a:t>
+              <a:t>5/19/2026</a:t>
             </a:fld>
             <a:endParaRPr lang="en-US"/>
           </a:p>
@@ -7338,7 +7091,7 @@
           <a:p>
             <a:fld id="{5BCAD085-E8A6-8845-BD4E-CB4CCA059FC4}" type="datetimeFigureOut">
               <a:rPr lang="en-US" smtClean="0"/>
-              <a:t>5/7/2026</a:t>
+              <a:t>5/19/2026</a:t>
             </a:fld>
             <a:endParaRPr lang="en-US"/>
           </a:p>
@@ -7608,7 +7361,7 @@
           <a:p>
             <a:fld id="{5BCAD085-E8A6-8845-BD4E-CB4CCA059FC4}" type="datetimeFigureOut">
               <a:rPr lang="en-US" smtClean="0"/>
-              <a:t>5/7/2026</a:t>
+              <a:t>5/19/2026</a:t>
             </a:fld>
             <a:endParaRPr lang="en-US"/>
           </a:p>
@@ -7778,7 +7531,7 @@
           <a:p>
             <a:fld id="{5BCAD085-E8A6-8845-BD4E-CB4CCA059FC4}" type="datetimeFigureOut">
               <a:rPr lang="en-US" smtClean="0"/>
-              <a:t>5/7/2026</a:t>
+              <a:t>5/19/2026</a:t>
             </a:fld>
             <a:endParaRPr lang="en-US"/>
           </a:p>
@@ -8135,7 +7888,7 @@
           <a:p>
             <a:fld id="{5BCAD085-E8A6-8845-BD4E-CB4CCA059FC4}" type="datetimeFigureOut">
               <a:rPr lang="en-US" smtClean="0"/>
-              <a:t>5/7/2026</a:t>
+              <a:t>5/19/2026</a:t>
             </a:fld>
             <a:endParaRPr lang="en-US"/>
           </a:p>
@@ -8410,7 +8163,7 @@
           <a:p>
             <a:fld id="{5BCAD085-E8A6-8845-BD4E-CB4CCA059FC4}" type="datetimeFigureOut">
               <a:rPr lang="en-US" smtClean="0"/>
-              <a:t>5/7/2026</a:t>
+              <a:t>5/19/2026</a:t>
             </a:fld>
             <a:endParaRPr lang="en-US"/>
           </a:p>
@@ -8789,7 +8542,7 @@
           <a:p>
             <a:fld id="{5BCAD085-E8A6-8845-BD4E-CB4CCA059FC4}" type="datetimeFigureOut">
               <a:rPr lang="en-US" smtClean="0"/>
-              <a:t>5/7/2026</a:t>
+              <a:t>5/19/2026</a:t>
             </a:fld>
             <a:endParaRPr lang="en-US"/>
           </a:p>
@@ -8907,7 +8660,7 @@
           <a:p>
             <a:fld id="{5BCAD085-E8A6-8845-BD4E-CB4CCA059FC4}" type="datetimeFigureOut">
               <a:rPr lang="en-US" smtClean="0"/>
-              <a:t>5/7/2026</a:t>
+              <a:t>5/19/2026</a:t>
             </a:fld>
             <a:endParaRPr lang="en-US"/>
           </a:p>
@@ -9092,7 +8845,7 @@
           <a:p>
             <a:fld id="{5BCAD085-E8A6-8845-BD4E-CB4CCA059FC4}" type="datetimeFigureOut">
               <a:rPr lang="en-US" smtClean="0"/>
-              <a:t>5/7/2026</a:t>
+              <a:t>5/19/2026</a:t>
             </a:fld>
             <a:endParaRPr lang="en-US"/>
           </a:p>
@@ -9460,7 +9213,7 @@
           <a:p>
             <a:fld id="{5BCAD085-E8A6-8845-BD4E-CB4CCA059FC4}" type="datetimeFigureOut">
               <a:rPr lang="en-US" smtClean="0"/>
-              <a:t>5/7/2026</a:t>
+              <a:t>5/19/2026</a:t>
             </a:fld>
             <a:endParaRPr lang="en-US"/>
           </a:p>
@@ -9856,7 +9609,7 @@
           <a:p>
             <a:fld id="{5BCAD085-E8A6-8845-BD4E-CB4CCA059FC4}" type="datetimeFigureOut">
               <a:rPr lang="en-US" smtClean="0"/>
-              <a:t>5/7/2026</a:t>
+              <a:t>5/19/2026</a:t>
             </a:fld>
             <a:endParaRPr lang="en-US"/>
           </a:p>
@@ -10157,7 +9910,7 @@
           <a:p>
             <a:fld id="{5BCAD085-E8A6-8845-BD4E-CB4CCA059FC4}" type="datetimeFigureOut">
               <a:rPr lang="en-US" smtClean="0"/>
-              <a:t>5/7/2026</a:t>
+              <a:t>5/19/2026</a:t>
             </a:fld>
             <a:endParaRPr lang="en-US"/>
           </a:p>
@@ -10763,7 +10516,7 @@
           <a:p>
             <a:r>
               <a:rPr lang="en-US" sz="1800" dirty="0"/>
-              <a:t>Date: May 8, 2026</a:t>
+              <a:t>Date: May 15, 2026</a:t>
             </a:r>
             <a:endParaRPr lang="en-GY" sz="1800" dirty="0"/>
           </a:p>
@@ -10815,7 +10568,7 @@
           <a:lstStyle/>
           <a:p>
             <a:r>
-              <a:t>Outputs</a:t>
+              <a:t>What Went Well</a:t>
             </a:r>
           </a:p>
         </p:txBody>
@@ -10835,54 +10588,96 @@
           <a:bodyPr/>
           <a:lstStyle/>
           <a:p>
+            <a:pPr>
+              <a:buFont typeface="Arial" panose="020B0604020202020204" pitchFamily="34" charset="0"/>
+              <a:buChar char="•"/>
+            </a:pPr>
             <a:r>
               <a:rPr dirty="0"/>
-              <a:t>- </a:t>
-            </a:r>
-            <a:r>
-              <a:rPr dirty="0" err="1"/>
-              <a:t>data_cleaned.rds</a:t>
-            </a:r>
-            <a:endParaRPr dirty="0"/>
-          </a:p>
-          <a:p>
-            <a:pPr marL="0" indent="0">
-              <a:buNone/>
+              <a:t> </a:t>
+            </a:r>
+            <a:r>
+              <a:rPr lang="en-US" dirty="0"/>
+              <a:t>  </a:t>
+            </a:r>
+            <a:r>
+              <a:rPr dirty="0"/>
+              <a:t>Successfully built a modular</a:t>
+            </a:r>
+            <a:r>
+              <a:rPr lang="en-US" dirty="0"/>
+              <a:t> and reproducible</a:t>
+            </a:r>
+            <a:r>
+              <a:rPr dirty="0"/>
+              <a:t> pipeline</a:t>
+            </a:r>
+          </a:p>
+          <a:p>
+            <a:pPr>
+              <a:buFont typeface="Arial" panose="020B0604020202020204" pitchFamily="34" charset="0"/>
+              <a:buChar char="•"/>
+            </a:pPr>
+            <a:r>
+              <a:rPr dirty="0"/>
+              <a:t> </a:t>
+            </a:r>
+            <a:r>
+              <a:rPr lang="en-US" dirty="0"/>
+              <a:t>  </a:t>
+            </a:r>
+            <a:r>
+              <a:rPr dirty="0"/>
+              <a:t>Resolved duplicate identity issues</a:t>
+            </a:r>
+          </a:p>
+          <a:p>
+            <a:pPr>
+              <a:buFont typeface="Arial" panose="020B0604020202020204" pitchFamily="34" charset="0"/>
+              <a:buChar char="•"/>
+            </a:pPr>
+            <a:r>
+              <a:rPr dirty="0"/>
+              <a:t> </a:t>
+            </a:r>
+            <a:r>
+              <a:rPr lang="en-US" dirty="0"/>
+              <a:t>  </a:t>
+            </a:r>
+            <a:r>
+              <a:rPr dirty="0"/>
+              <a:t>Automated reporting with R Markdown</a:t>
+            </a:r>
+          </a:p>
+          <a:p>
+            <a:pPr>
+              <a:buFont typeface="Arial" panose="020B0604020202020204" pitchFamily="34" charset="0"/>
+              <a:buChar char="•"/>
+            </a:pPr>
+            <a:r>
+              <a:rPr lang="en-US" dirty="0"/>
+              <a:t>   GitHub version control maintained throughout project</a:t>
+            </a:r>
+          </a:p>
+          <a:p>
+            <a:pPr>
+              <a:buFont typeface="Arial" panose="020B0604020202020204" pitchFamily="34" charset="0"/>
+              <a:buChar char="•"/>
+            </a:pPr>
+            <a:r>
+              <a:rPr lang="en-US" dirty="0"/>
+              <a:t>   Improved documentation and auditability after interim feedback</a:t>
+            </a:r>
+          </a:p>
+          <a:p>
+            <a:pPr>
+              <a:buFont typeface="Arial" panose="020B0604020202020204" pitchFamily="34" charset="0"/>
+              <a:buChar char="•"/>
             </a:pPr>
             <a:endParaRPr dirty="0"/>
           </a:p>
         </p:txBody>
       </p:sp>
-      <p:pic>
-        <p:nvPicPr>
-          <p:cNvPr id="5" name="Picture 4">
-            <a:extLst>
-              <a:ext uri="{FF2B5EF4-FFF2-40B4-BE49-F238E27FC236}">
-                <a16:creationId xmlns:a16="http://schemas.microsoft.com/office/drawing/2014/main" id="{5CA42107-59F6-DD2B-7981-32F50DDEC650}"/>
-              </a:ext>
-            </a:extLst>
-          </p:cNvPr>
-          <p:cNvPicPr>
-            <a:picLocks noChangeAspect="1"/>
-          </p:cNvPicPr>
-          <p:nvPr/>
-        </p:nvPicPr>
-        <p:blipFill>
-          <a:blip r:embed="rId3"/>
-          <a:stretch>
-            <a:fillRect/>
-          </a:stretch>
-        </p:blipFill>
-        <p:spPr>
-          <a:xfrm>
-            <a:off x="1219200" y="2296525"/>
-            <a:ext cx="5933122" cy="3776192"/>
-          </a:xfrm>
-          <a:prstGeom prst="rect">
-            <a:avLst/>
-          </a:prstGeom>
-        </p:spPr>
-      </p:pic>
     </p:spTree>
   </p:cSld>
   <p:clrMapOvr>
@@ -10892,701 +10687,6 @@
 </file>
 
 <file path=ppt/slides/slide11.xml><?xml version="1.0" encoding="utf-8"?>
-<p:sld xmlns:a="http://schemas.openxmlformats.org/drawingml/2006/main" xmlns:r="http://schemas.openxmlformats.org/officeDocument/2006/relationships" xmlns:p="http://schemas.openxmlformats.org/presentationml/2006/main">
-  <p:cSld>
-    <p:spTree>
-      <p:nvGrpSpPr>
-        <p:cNvPr id="1" name="">
-          <a:extLst>
-            <a:ext uri="{FF2B5EF4-FFF2-40B4-BE49-F238E27FC236}">
-              <a16:creationId xmlns:a16="http://schemas.microsoft.com/office/drawing/2014/main" id="{36A45970-2032-DCD3-6781-9915D354D81B}"/>
-            </a:ext>
-          </a:extLst>
-        </p:cNvPr>
-        <p:cNvGrpSpPr/>
-        <p:nvPr/>
-      </p:nvGrpSpPr>
-      <p:grpSpPr>
-        <a:xfrm>
-          <a:off x="0" y="0"/>
-          <a:ext cx="0" cy="0"/>
-          <a:chOff x="0" y="0"/>
-          <a:chExt cx="0" cy="0"/>
-        </a:xfrm>
-      </p:grpSpPr>
-      <p:sp>
-        <p:nvSpPr>
-          <p:cNvPr id="2" name="Title 1">
-            <a:extLst>
-              <a:ext uri="{FF2B5EF4-FFF2-40B4-BE49-F238E27FC236}">
-                <a16:creationId xmlns:a16="http://schemas.microsoft.com/office/drawing/2014/main" id="{ECCA169B-CE49-4A9E-1372-B0B7E15EECAE}"/>
-              </a:ext>
-            </a:extLst>
-          </p:cNvPr>
-          <p:cNvSpPr>
-            <a:spLocks noGrp="1"/>
-          </p:cNvSpPr>
-          <p:nvPr>
-            <p:ph type="title"/>
-          </p:nvPr>
-        </p:nvSpPr>
-        <p:spPr/>
-        <p:txBody>
-          <a:bodyPr/>
-          <a:lstStyle/>
-          <a:p>
-            <a:r>
-              <a:t>Outputs</a:t>
-            </a:r>
-          </a:p>
-        </p:txBody>
-      </p:sp>
-      <p:sp>
-        <p:nvSpPr>
-          <p:cNvPr id="3" name="Content Placeholder 2">
-            <a:extLst>
-              <a:ext uri="{FF2B5EF4-FFF2-40B4-BE49-F238E27FC236}">
-                <a16:creationId xmlns:a16="http://schemas.microsoft.com/office/drawing/2014/main" id="{02E4B3D5-4DE7-B712-7F1D-9780F397FE1E}"/>
-              </a:ext>
-            </a:extLst>
-          </p:cNvPr>
-          <p:cNvSpPr>
-            <a:spLocks noGrp="1"/>
-          </p:cNvSpPr>
-          <p:nvPr>
-            <p:ph idx="1"/>
-          </p:nvPr>
-        </p:nvSpPr>
-        <p:spPr/>
-        <p:txBody>
-          <a:bodyPr/>
-          <a:lstStyle/>
-          <a:p>
-            <a:r>
-              <a:rPr dirty="0"/>
-              <a:t>- data_cleaned.xlsx</a:t>
-            </a:r>
-          </a:p>
-          <a:p>
-            <a:endParaRPr dirty="0"/>
-          </a:p>
-        </p:txBody>
-      </p:sp>
-      <p:pic>
-        <p:nvPicPr>
-          <p:cNvPr id="5" name="Picture 4">
-            <a:extLst>
-              <a:ext uri="{FF2B5EF4-FFF2-40B4-BE49-F238E27FC236}">
-                <a16:creationId xmlns:a16="http://schemas.microsoft.com/office/drawing/2014/main" id="{761093E2-50C9-C0FE-9961-FF50A5DA902B}"/>
-              </a:ext>
-            </a:extLst>
-          </p:cNvPr>
-          <p:cNvPicPr>
-            <a:picLocks noChangeAspect="1"/>
-          </p:cNvPicPr>
-          <p:nvPr/>
-        </p:nvPicPr>
-        <p:blipFill>
-          <a:blip r:embed="rId3"/>
-          <a:srcRect t="13692"/>
-          <a:stretch>
-            <a:fillRect/>
-          </a:stretch>
-        </p:blipFill>
-        <p:spPr>
-          <a:xfrm>
-            <a:off x="426762" y="2141856"/>
-            <a:ext cx="8336194" cy="3431116"/>
-          </a:xfrm>
-          <a:prstGeom prst="rect">
-            <a:avLst/>
-          </a:prstGeom>
-        </p:spPr>
-      </p:pic>
-    </p:spTree>
-    <p:extLst>
-      <p:ext uri="{BB962C8B-B14F-4D97-AF65-F5344CB8AC3E}">
-        <p14:creationId xmlns:p14="http://schemas.microsoft.com/office/powerpoint/2010/main" val="289227449"/>
-      </p:ext>
-    </p:extLst>
-  </p:cSld>
-  <p:clrMapOvr>
-    <a:masterClrMapping/>
-  </p:clrMapOvr>
-</p:sld>
-</file>
-
-<file path=ppt/slides/slide12.xml><?xml version="1.0" encoding="utf-8"?>
-<p:sld xmlns:a="http://schemas.openxmlformats.org/drawingml/2006/main" xmlns:r="http://schemas.openxmlformats.org/officeDocument/2006/relationships" xmlns:p="http://schemas.openxmlformats.org/presentationml/2006/main">
-  <p:cSld>
-    <p:spTree>
-      <p:nvGrpSpPr>
-        <p:cNvPr id="1" name="">
-          <a:extLst>
-            <a:ext uri="{FF2B5EF4-FFF2-40B4-BE49-F238E27FC236}">
-              <a16:creationId xmlns:a16="http://schemas.microsoft.com/office/drawing/2014/main" id="{EED50148-2EBB-3382-49CF-9D4F1467053C}"/>
-            </a:ext>
-          </a:extLst>
-        </p:cNvPr>
-        <p:cNvGrpSpPr/>
-        <p:nvPr/>
-      </p:nvGrpSpPr>
-      <p:grpSpPr>
-        <a:xfrm>
-          <a:off x="0" y="0"/>
-          <a:ext cx="0" cy="0"/>
-          <a:chOff x="0" y="0"/>
-          <a:chExt cx="0" cy="0"/>
-        </a:xfrm>
-      </p:grpSpPr>
-      <p:sp>
-        <p:nvSpPr>
-          <p:cNvPr id="2" name="Title 1">
-            <a:extLst>
-              <a:ext uri="{FF2B5EF4-FFF2-40B4-BE49-F238E27FC236}">
-                <a16:creationId xmlns:a16="http://schemas.microsoft.com/office/drawing/2014/main" id="{71A9BF47-479D-30D4-1F6E-63C5BCEA9BBA}"/>
-              </a:ext>
-            </a:extLst>
-          </p:cNvPr>
-          <p:cNvSpPr>
-            <a:spLocks noGrp="1"/>
-          </p:cNvSpPr>
-          <p:nvPr>
-            <p:ph type="title"/>
-          </p:nvPr>
-        </p:nvSpPr>
-        <p:spPr/>
-        <p:txBody>
-          <a:bodyPr/>
-          <a:lstStyle/>
-          <a:p>
-            <a:r>
-              <a:t>Outputs</a:t>
-            </a:r>
-          </a:p>
-        </p:txBody>
-      </p:sp>
-      <p:sp>
-        <p:nvSpPr>
-          <p:cNvPr id="3" name="Content Placeholder 2">
-            <a:extLst>
-              <a:ext uri="{FF2B5EF4-FFF2-40B4-BE49-F238E27FC236}">
-                <a16:creationId xmlns:a16="http://schemas.microsoft.com/office/drawing/2014/main" id="{FE634DF8-9EC1-5ECC-F151-98C60F4C70CE}"/>
-              </a:ext>
-            </a:extLst>
-          </p:cNvPr>
-          <p:cNvSpPr>
-            <a:spLocks noGrp="1"/>
-          </p:cNvSpPr>
-          <p:nvPr>
-            <p:ph idx="1"/>
-          </p:nvPr>
-        </p:nvSpPr>
-        <p:spPr/>
-        <p:txBody>
-          <a:bodyPr/>
-          <a:lstStyle/>
-          <a:p>
-            <a:r>
-              <a:rPr dirty="0"/>
-              <a:t>- </a:t>
-            </a:r>
-            <a:r>
-              <a:rPr dirty="0" err="1"/>
-              <a:t>data_cleaned.sav</a:t>
-            </a:r>
-            <a:endParaRPr dirty="0"/>
-          </a:p>
-        </p:txBody>
-      </p:sp>
-      <p:pic>
-        <p:nvPicPr>
-          <p:cNvPr id="5" name="Picture 4">
-            <a:extLst>
-              <a:ext uri="{FF2B5EF4-FFF2-40B4-BE49-F238E27FC236}">
-                <a16:creationId xmlns:a16="http://schemas.microsoft.com/office/drawing/2014/main" id="{84A05007-5A8A-16F1-DEF7-2ED2129CC624}"/>
-              </a:ext>
-            </a:extLst>
-          </p:cNvPr>
-          <p:cNvPicPr>
-            <a:picLocks noChangeAspect="1"/>
-          </p:cNvPicPr>
-          <p:nvPr/>
-        </p:nvPicPr>
-        <p:blipFill>
-          <a:blip r:embed="rId3"/>
-          <a:stretch>
-            <a:fillRect/>
-          </a:stretch>
-        </p:blipFill>
-        <p:spPr>
-          <a:xfrm>
-            <a:off x="609600" y="2310875"/>
-            <a:ext cx="3160418" cy="3290159"/>
-          </a:xfrm>
-          <a:prstGeom prst="rect">
-            <a:avLst/>
-          </a:prstGeom>
-        </p:spPr>
-      </p:pic>
-      <p:pic>
-        <p:nvPicPr>
-          <p:cNvPr id="7" name="Picture 6">
-            <a:extLst>
-              <a:ext uri="{FF2B5EF4-FFF2-40B4-BE49-F238E27FC236}">
-                <a16:creationId xmlns:a16="http://schemas.microsoft.com/office/drawing/2014/main" id="{8E5565BF-716A-609F-C5C3-64FCD4246006}"/>
-              </a:ext>
-            </a:extLst>
-          </p:cNvPr>
-          <p:cNvPicPr>
-            <a:picLocks noChangeAspect="1"/>
-          </p:cNvPicPr>
-          <p:nvPr/>
-        </p:nvPicPr>
-        <p:blipFill>
-          <a:blip r:embed="rId4"/>
-          <a:stretch>
-            <a:fillRect/>
-          </a:stretch>
-        </p:blipFill>
-        <p:spPr>
-          <a:xfrm>
-            <a:off x="3983377" y="2310875"/>
-            <a:ext cx="4724400" cy="3290159"/>
-          </a:xfrm>
-          <a:prstGeom prst="rect">
-            <a:avLst/>
-          </a:prstGeom>
-        </p:spPr>
-      </p:pic>
-    </p:spTree>
-    <p:extLst>
-      <p:ext uri="{BB962C8B-B14F-4D97-AF65-F5344CB8AC3E}">
-        <p14:creationId xmlns:p14="http://schemas.microsoft.com/office/powerpoint/2010/main" val="4029996501"/>
-      </p:ext>
-    </p:extLst>
-  </p:cSld>
-  <p:clrMapOvr>
-    <a:masterClrMapping/>
-  </p:clrMapOvr>
-</p:sld>
-</file>
-
-<file path=ppt/slides/slide13.xml><?xml version="1.0" encoding="utf-8"?>
-<p:sld xmlns:a="http://schemas.openxmlformats.org/drawingml/2006/main" xmlns:r="http://schemas.openxmlformats.org/officeDocument/2006/relationships" xmlns:p="http://schemas.openxmlformats.org/presentationml/2006/main">
-  <p:cSld>
-    <p:spTree>
-      <p:nvGrpSpPr>
-        <p:cNvPr id="1" name="">
-          <a:extLst>
-            <a:ext uri="{FF2B5EF4-FFF2-40B4-BE49-F238E27FC236}">
-              <a16:creationId xmlns:a16="http://schemas.microsoft.com/office/drawing/2014/main" id="{C920975D-7E44-9AEF-0477-4944F3E39B14}"/>
-            </a:ext>
-          </a:extLst>
-        </p:cNvPr>
-        <p:cNvGrpSpPr/>
-        <p:nvPr/>
-      </p:nvGrpSpPr>
-      <p:grpSpPr>
-        <a:xfrm>
-          <a:off x="0" y="0"/>
-          <a:ext cx="0" cy="0"/>
-          <a:chOff x="0" y="0"/>
-          <a:chExt cx="0" cy="0"/>
-        </a:xfrm>
-      </p:grpSpPr>
-      <p:sp>
-        <p:nvSpPr>
-          <p:cNvPr id="2" name="Title 1">
-            <a:extLst>
-              <a:ext uri="{FF2B5EF4-FFF2-40B4-BE49-F238E27FC236}">
-                <a16:creationId xmlns:a16="http://schemas.microsoft.com/office/drawing/2014/main" id="{CD029E75-4D71-A0ED-8C7A-AFABF4A88CE9}"/>
-              </a:ext>
-            </a:extLst>
-          </p:cNvPr>
-          <p:cNvSpPr>
-            <a:spLocks noGrp="1"/>
-          </p:cNvSpPr>
-          <p:nvPr>
-            <p:ph type="title"/>
-          </p:nvPr>
-        </p:nvSpPr>
-        <p:spPr/>
-        <p:txBody>
-          <a:bodyPr/>
-          <a:lstStyle/>
-          <a:p>
-            <a:r>
-              <a:t>Outputs</a:t>
-            </a:r>
-          </a:p>
-        </p:txBody>
-      </p:sp>
-      <p:sp>
-        <p:nvSpPr>
-          <p:cNvPr id="3" name="Content Placeholder 2">
-            <a:extLst>
-              <a:ext uri="{FF2B5EF4-FFF2-40B4-BE49-F238E27FC236}">
-                <a16:creationId xmlns:a16="http://schemas.microsoft.com/office/drawing/2014/main" id="{091E49A6-B0B9-A5AD-4A01-1BA3515EDC37}"/>
-              </a:ext>
-            </a:extLst>
-          </p:cNvPr>
-          <p:cNvSpPr>
-            <a:spLocks noGrp="1"/>
-          </p:cNvSpPr>
-          <p:nvPr>
-            <p:ph idx="1"/>
-          </p:nvPr>
-        </p:nvSpPr>
-        <p:spPr/>
-        <p:txBody>
-          <a:bodyPr/>
-          <a:lstStyle/>
-          <a:p>
-            <a:r>
-              <a:rPr dirty="0"/>
-              <a:t>- </a:t>
-            </a:r>
-            <a:r>
-              <a:rPr dirty="0" err="1"/>
-              <a:t>data_cleaned.dta</a:t>
-            </a:r>
-            <a:endParaRPr dirty="0"/>
-          </a:p>
-        </p:txBody>
-      </p:sp>
-      <p:pic>
-        <p:nvPicPr>
-          <p:cNvPr id="5" name="Picture 4">
-            <a:extLst>
-              <a:ext uri="{FF2B5EF4-FFF2-40B4-BE49-F238E27FC236}">
-                <a16:creationId xmlns:a16="http://schemas.microsoft.com/office/drawing/2014/main" id="{CA5058B4-89D0-32CC-5262-F2A8B825633F}"/>
-              </a:ext>
-            </a:extLst>
-          </p:cNvPr>
-          <p:cNvPicPr>
-            <a:picLocks noChangeAspect="1"/>
-          </p:cNvPicPr>
-          <p:nvPr/>
-        </p:nvPicPr>
-        <p:blipFill>
-          <a:blip r:embed="rId3"/>
-          <a:stretch>
-            <a:fillRect/>
-          </a:stretch>
-        </p:blipFill>
-        <p:spPr>
-          <a:xfrm>
-            <a:off x="1089659" y="2216284"/>
-            <a:ext cx="7231382" cy="3761183"/>
-          </a:xfrm>
-          <a:prstGeom prst="rect">
-            <a:avLst/>
-          </a:prstGeom>
-        </p:spPr>
-      </p:pic>
-    </p:spTree>
-    <p:extLst>
-      <p:ext uri="{BB962C8B-B14F-4D97-AF65-F5344CB8AC3E}">
-        <p14:creationId xmlns:p14="http://schemas.microsoft.com/office/powerpoint/2010/main" val="2069186012"/>
-      </p:ext>
-    </p:extLst>
-  </p:cSld>
-  <p:clrMapOvr>
-    <a:masterClrMapping/>
-  </p:clrMapOvr>
-</p:sld>
-</file>
-
-<file path=ppt/slides/slide14.xml><?xml version="1.0" encoding="utf-8"?>
-<p:sld xmlns:a="http://schemas.openxmlformats.org/drawingml/2006/main" xmlns:r="http://schemas.openxmlformats.org/officeDocument/2006/relationships" xmlns:p="http://schemas.openxmlformats.org/presentationml/2006/main">
-  <p:cSld>
-    <p:spTree>
-      <p:nvGrpSpPr>
-        <p:cNvPr id="1" name="">
-          <a:extLst>
-            <a:ext uri="{FF2B5EF4-FFF2-40B4-BE49-F238E27FC236}">
-              <a16:creationId xmlns:a16="http://schemas.microsoft.com/office/drawing/2014/main" id="{A49D1D80-DB3D-7BD4-C59D-2FF8F4B923E4}"/>
-            </a:ext>
-          </a:extLst>
-        </p:cNvPr>
-        <p:cNvGrpSpPr/>
-        <p:nvPr/>
-      </p:nvGrpSpPr>
-      <p:grpSpPr>
-        <a:xfrm>
-          <a:off x="0" y="0"/>
-          <a:ext cx="0" cy="0"/>
-          <a:chOff x="0" y="0"/>
-          <a:chExt cx="0" cy="0"/>
-        </a:xfrm>
-      </p:grpSpPr>
-      <p:sp>
-        <p:nvSpPr>
-          <p:cNvPr id="2" name="Title 1">
-            <a:extLst>
-              <a:ext uri="{FF2B5EF4-FFF2-40B4-BE49-F238E27FC236}">
-                <a16:creationId xmlns:a16="http://schemas.microsoft.com/office/drawing/2014/main" id="{867A9599-ACDA-E06C-EE77-85D1FF41321A}"/>
-              </a:ext>
-            </a:extLst>
-          </p:cNvPr>
-          <p:cNvSpPr>
-            <a:spLocks noGrp="1"/>
-          </p:cNvSpPr>
-          <p:nvPr>
-            <p:ph type="title"/>
-          </p:nvPr>
-        </p:nvSpPr>
-        <p:spPr/>
-        <p:txBody>
-          <a:bodyPr/>
-          <a:lstStyle/>
-          <a:p>
-            <a:r>
-              <a:t>Outputs</a:t>
-            </a:r>
-          </a:p>
-        </p:txBody>
-      </p:sp>
-      <p:sp>
-        <p:nvSpPr>
-          <p:cNvPr id="3" name="Content Placeholder 2">
-            <a:extLst>
-              <a:ext uri="{FF2B5EF4-FFF2-40B4-BE49-F238E27FC236}">
-                <a16:creationId xmlns:a16="http://schemas.microsoft.com/office/drawing/2014/main" id="{1575E058-8DE9-FC99-1880-31262546154C}"/>
-              </a:ext>
-            </a:extLst>
-          </p:cNvPr>
-          <p:cNvSpPr>
-            <a:spLocks noGrp="1"/>
-          </p:cNvSpPr>
-          <p:nvPr>
-            <p:ph idx="1"/>
-          </p:nvPr>
-        </p:nvSpPr>
-        <p:spPr/>
-        <p:txBody>
-          <a:bodyPr/>
-          <a:lstStyle/>
-          <a:p>
-            <a:r>
-              <a:rPr dirty="0"/>
-              <a:t>- Automated Word report</a:t>
-            </a:r>
-            <a:endParaRPr lang="en-US" dirty="0"/>
-          </a:p>
-          <a:p>
-            <a:endParaRPr dirty="0"/>
-          </a:p>
-        </p:txBody>
-      </p:sp>
-      <p:graphicFrame>
-        <p:nvGraphicFramePr>
-          <p:cNvPr id="4" name="Object 3">
-            <a:extLst>
-              <a:ext uri="{FF2B5EF4-FFF2-40B4-BE49-F238E27FC236}">
-                <a16:creationId xmlns:a16="http://schemas.microsoft.com/office/drawing/2014/main" id="{DB6FF022-AE78-AC82-8B94-42FD7441080A}"/>
-              </a:ext>
-            </a:extLst>
-          </p:cNvPr>
-          <p:cNvGraphicFramePr>
-            <a:graphicFrameLocks noChangeAspect="1"/>
-          </p:cNvGraphicFramePr>
-          <p:nvPr>
-            <p:extLst>
-              <p:ext uri="{D42A27DB-BD31-4B8C-83A1-F6EECF244321}">
-                <p14:modId xmlns:p14="http://schemas.microsoft.com/office/powerpoint/2010/main" val="1735811751"/>
-              </p:ext>
-            </p:extLst>
-          </p:nvPr>
-        </p:nvGraphicFramePr>
-        <p:xfrm>
-          <a:off x="2308860" y="2207684"/>
-          <a:ext cx="3441950" cy="3769783"/>
-        </p:xfrm>
-        <a:graphic>
-          <a:graphicData uri="http://schemas.openxmlformats.org/presentationml/2006/ole">
-            <mc:AlternateContent xmlns:mc="http://schemas.openxmlformats.org/markup-compatibility/2006">
-              <mc:Choice xmlns:v="urn:schemas-microsoft-com:vml" Requires="v">
-                <p:oleObj name="Document" r:id="rId3" imgW="5956042" imgH="8041861" progId="Word.Document.12">
-                  <p:embed/>
-                </p:oleObj>
-              </mc:Choice>
-              <mc:Fallback>
-                <p:oleObj name="Document" r:id="rId3" imgW="5956042" imgH="8041861" progId="Word.Document.12">
-                  <p:embed/>
-                  <p:pic>
-                    <p:nvPicPr>
-                      <p:cNvPr id="0" name=""/>
-                      <p:cNvPicPr/>
-                      <p:nvPr/>
-                    </p:nvPicPr>
-                    <p:blipFill>
-                      <a:blip r:embed="rId4"/>
-                      <a:stretch>
-                        <a:fillRect/>
-                      </a:stretch>
-                    </p:blipFill>
-                    <p:spPr>
-                      <a:xfrm>
-                        <a:off x="2308860" y="2207684"/>
-                        <a:ext cx="3441950" cy="3769783"/>
-                      </a:xfrm>
-                      <a:prstGeom prst="rect">
-                        <a:avLst/>
-                      </a:prstGeom>
-                    </p:spPr>
-                  </p:pic>
-                </p:oleObj>
-              </mc:Fallback>
-            </mc:AlternateContent>
-          </a:graphicData>
-        </a:graphic>
-      </p:graphicFrame>
-    </p:spTree>
-    <p:extLst>
-      <p:ext uri="{BB962C8B-B14F-4D97-AF65-F5344CB8AC3E}">
-        <p14:creationId xmlns:p14="http://schemas.microsoft.com/office/powerpoint/2010/main" val="2337707613"/>
-      </p:ext>
-    </p:extLst>
-  </p:cSld>
-  <p:clrMapOvr>
-    <a:masterClrMapping/>
-  </p:clrMapOvr>
-</p:sld>
-</file>
-
-<file path=ppt/slides/slide15.xml><?xml version="1.0" encoding="utf-8"?>
-<p:sld xmlns:a="http://schemas.openxmlformats.org/drawingml/2006/main" xmlns:r="http://schemas.openxmlformats.org/officeDocument/2006/relationships" xmlns:p="http://schemas.openxmlformats.org/presentationml/2006/main">
-  <p:cSld>
-    <p:spTree>
-      <p:nvGrpSpPr>
-        <p:cNvPr id="1" name=""/>
-        <p:cNvGrpSpPr/>
-        <p:nvPr/>
-      </p:nvGrpSpPr>
-      <p:grpSpPr>
-        <a:xfrm>
-          <a:off x="0" y="0"/>
-          <a:ext cx="0" cy="0"/>
-          <a:chOff x="0" y="0"/>
-          <a:chExt cx="0" cy="0"/>
-        </a:xfrm>
-      </p:grpSpPr>
-      <p:sp>
-        <p:nvSpPr>
-          <p:cNvPr id="2" name="Title 1"/>
-          <p:cNvSpPr>
-            <a:spLocks noGrp="1"/>
-          </p:cNvSpPr>
-          <p:nvPr>
-            <p:ph type="title"/>
-          </p:nvPr>
-        </p:nvSpPr>
-        <p:spPr/>
-        <p:txBody>
-          <a:bodyPr/>
-          <a:lstStyle/>
-          <a:p>
-            <a:r>
-              <a:t>What Went Well</a:t>
-            </a:r>
-          </a:p>
-        </p:txBody>
-      </p:sp>
-      <p:sp>
-        <p:nvSpPr>
-          <p:cNvPr id="3" name="Content Placeholder 2"/>
-          <p:cNvSpPr>
-            <a:spLocks noGrp="1"/>
-          </p:cNvSpPr>
-          <p:nvPr>
-            <p:ph idx="1"/>
-          </p:nvPr>
-        </p:nvSpPr>
-        <p:spPr/>
-        <p:txBody>
-          <a:bodyPr/>
-          <a:lstStyle/>
-          <a:p>
-            <a:pPr>
-              <a:buFont typeface="Arial" panose="020B0604020202020204" pitchFamily="34" charset="0"/>
-              <a:buChar char="•"/>
-            </a:pPr>
-            <a:r>
-              <a:rPr dirty="0"/>
-              <a:t> </a:t>
-            </a:r>
-            <a:r>
-              <a:rPr lang="en-US" dirty="0"/>
-              <a:t>  </a:t>
-            </a:r>
-            <a:r>
-              <a:rPr dirty="0"/>
-              <a:t>Successfully built a modular pipeline</a:t>
-            </a:r>
-          </a:p>
-          <a:p>
-            <a:pPr>
-              <a:buFont typeface="Arial" panose="020B0604020202020204" pitchFamily="34" charset="0"/>
-              <a:buChar char="•"/>
-            </a:pPr>
-            <a:r>
-              <a:rPr dirty="0"/>
-              <a:t> </a:t>
-            </a:r>
-            <a:r>
-              <a:rPr lang="en-US" dirty="0"/>
-              <a:t>  </a:t>
-            </a:r>
-            <a:r>
-              <a:rPr dirty="0"/>
-              <a:t>Resolved duplicate identity issues</a:t>
-            </a:r>
-          </a:p>
-          <a:p>
-            <a:pPr>
-              <a:buFont typeface="Arial" panose="020B0604020202020204" pitchFamily="34" charset="0"/>
-              <a:buChar char="•"/>
-            </a:pPr>
-            <a:r>
-              <a:rPr dirty="0"/>
-              <a:t> </a:t>
-            </a:r>
-            <a:r>
-              <a:rPr lang="en-US" dirty="0"/>
-              <a:t>  </a:t>
-            </a:r>
-            <a:r>
-              <a:rPr dirty="0"/>
-              <a:t>Automated reporting with R Markdown</a:t>
-            </a:r>
-          </a:p>
-          <a:p>
-            <a:pPr>
-              <a:buFont typeface="Arial" panose="020B0604020202020204" pitchFamily="34" charset="0"/>
-              <a:buChar char="•"/>
-            </a:pPr>
-            <a:r>
-              <a:rPr lang="en-US" dirty="0"/>
-              <a:t>  </a:t>
-            </a:r>
-            <a:r>
-              <a:rPr dirty="0"/>
-              <a:t> Achieved full end-to-end execution</a:t>
-            </a:r>
-          </a:p>
-        </p:txBody>
-      </p:sp>
-    </p:spTree>
-  </p:cSld>
-  <p:clrMapOvr>
-    <a:masterClrMapping/>
-  </p:clrMapOvr>
-</p:sld>
-</file>
-
-<file path=ppt/slides/slide16.xml><?xml version="1.0" encoding="utf-8"?>
 <p:sld xmlns:a="http://schemas.openxmlformats.org/drawingml/2006/main" xmlns:r="http://schemas.openxmlformats.org/officeDocument/2006/relationships" xmlns:p="http://schemas.openxmlformats.org/presentationml/2006/main">
   <p:cSld>
     <p:spTree>
@@ -11660,9 +10760,28 @@
         </p:spPr>
         <p:txBody>
           <a:bodyPr>
-            <a:normAutofit lnSpcReduction="10000"/>
+            <a:normAutofit fontScale="55000" lnSpcReduction="20000"/>
           </a:bodyPr>
           <a:lstStyle/>
+          <a:p>
+            <a:pPr marL="182563" lvl="1" indent="-182563">
+              <a:buFont typeface="Arial" panose="020B0604020202020204" pitchFamily="34" charset="0"/>
+              <a:buChar char="•"/>
+            </a:pPr>
+            <a:r>
+              <a:rPr lang="en-GY" sz="2000" dirty="0"/>
+              <a:t>Resolving duplicate patient identities with conflicting information</a:t>
+            </a:r>
+            <a:r>
+              <a:rPr lang="en-US" sz="2000" dirty="0"/>
+              <a:t> while preserving traceability</a:t>
+            </a:r>
+            <a:r>
+              <a:rPr lang="en-US" dirty="0"/>
+              <a:t>.</a:t>
+            </a:r>
+            <a:endParaRPr lang="en-GY" dirty="0"/>
+          </a:p>
           <a:p>
             <a:pPr>
               <a:buFont typeface="Arial" panose="020B0604020202020204" pitchFamily="34" charset="0"/>
@@ -11674,7 +10793,7 @@
             </a:r>
             <a:r>
               <a:rPr lang="en-GY" dirty="0"/>
-              <a:t>Resolving duplicate patient identities with conflicting information</a:t>
+              <a:t>Deciding how to handle missing values</a:t>
             </a:r>
           </a:p>
           <a:p>
@@ -11688,7 +10807,7 @@
             </a:r>
             <a:r>
               <a:rPr lang="en-GY" dirty="0"/>
-              <a:t>Deciding how to handle missing values</a:t>
+              <a:t>Separating cleaning from imputation logically</a:t>
             </a:r>
           </a:p>
           <a:p>
@@ -11702,8 +10821,9 @@
             </a:r>
             <a:r>
               <a:rPr lang="en-GY" dirty="0"/>
-              <a:t>Separating cleaning from imputation logically</a:t>
-            </a:r>
+              <a:t>Managing pipeline dependencies and file paths</a:t>
+            </a:r>
+            <a:endParaRPr lang="en-US" dirty="0"/>
           </a:p>
           <a:p>
             <a:pPr>
@@ -11712,12 +10832,34 @@
             </a:pPr>
             <a:r>
               <a:rPr lang="en-US" dirty="0"/>
-              <a:t>   </a:t>
-            </a:r>
-            <a:r>
-              <a:rPr lang="en-GY" dirty="0"/>
-              <a:t>Managing pipeline dependencies and file paths</a:t>
-            </a:r>
+              <a:t>   Debugging dynamic data dictionary generation</a:t>
+            </a:r>
+          </a:p>
+          <a:p>
+            <a:pPr>
+              <a:buFont typeface="Arial" panose="020B0604020202020204" pitchFamily="34" charset="0"/>
+              <a:buChar char="•"/>
+            </a:pPr>
+            <a:r>
+              <a:rPr lang="en-US" dirty="0"/>
+              <a:t>   Fixing R Markdown rendering errors</a:t>
+            </a:r>
+          </a:p>
+          <a:p>
+            <a:pPr>
+              <a:buFont typeface="Arial" panose="020B0604020202020204" pitchFamily="34" charset="0"/>
+              <a:buChar char="•"/>
+            </a:pPr>
+            <a:r>
+              <a:rPr lang="en-US" dirty="0"/>
+              <a:t>   Balancing technical work with documentation requirements</a:t>
+            </a:r>
+          </a:p>
+          <a:p>
+            <a:pPr>
+              <a:buFont typeface="Arial" panose="020B0604020202020204" pitchFamily="34" charset="0"/>
+              <a:buChar char="•"/>
+            </a:pPr>
             <a:endParaRPr lang="en-US" dirty="0"/>
           </a:p>
           <a:p>
@@ -11795,7 +10937,7 @@
 </p:sld>
 </file>
 
-<file path=ppt/slides/slide17.xml><?xml version="1.0" encoding="utf-8"?>
+<file path=ppt/slides/slide12.xml><?xml version="1.0" encoding="utf-8"?>
 <p:sld xmlns:a="http://schemas.openxmlformats.org/drawingml/2006/main" xmlns:r="http://schemas.openxmlformats.org/officeDocument/2006/relationships" xmlns:p="http://schemas.openxmlformats.org/presentationml/2006/main">
   <p:cSld>
     <p:spTree>
@@ -11886,7 +11028,7 @@
           <p:nvPr>
             <p:extLst>
               <p:ext uri="{D42A27DB-BD31-4B8C-83A1-F6EECF244321}">
-                <p14:modId xmlns:p14="http://schemas.microsoft.com/office/powerpoint/2010/main" val="1469654579"/>
+                <p14:modId xmlns:p14="http://schemas.microsoft.com/office/powerpoint/2010/main" val="1721487519"/>
               </p:ext>
             </p:extLst>
           </p:nvPr>
@@ -12159,7 +11301,7 @@
                       <a:pPr algn="ctr"/>
                       <a:r>
                         <a:rPr lang="en-US" dirty="0"/>
-                        <a:t>8</a:t>
+                        <a:t>10</a:t>
                       </a:r>
                       <a:endParaRPr lang="en-GY" dirty="0"/>
                     </a:p>
@@ -12184,7 +11326,7 @@
 </p:sld>
 </file>
 
-<file path=ppt/slides/slide18.xml><?xml version="1.0" encoding="utf-8"?>
+<file path=ppt/slides/slide13.xml><?xml version="1.0" encoding="utf-8"?>
 <p:sld xmlns:a="http://schemas.openxmlformats.org/drawingml/2006/main" xmlns:r="http://schemas.openxmlformats.org/officeDocument/2006/relationships" xmlns:p="http://schemas.openxmlformats.org/presentationml/2006/main">
   <p:cSld>
     <p:spTree>
@@ -12239,7 +11381,9 @@
           </a:xfrm>
         </p:spPr>
         <p:txBody>
-          <a:bodyPr/>
+          <a:bodyPr>
+            <a:normAutofit/>
+          </a:bodyPr>
           <a:lstStyle/>
           <a:p>
             <a:pPr>
@@ -12270,12 +11414,9 @@
             </a:r>
             <a:r>
               <a:rPr lang="en-US" dirty="0"/>
-              <a:t>   </a:t>
-            </a:r>
-            <a:r>
-              <a:rPr dirty="0"/>
-              <a:t>Apply advanced imputation methods</a:t>
-            </a:r>
+              <a:t>   Implement additional imputation strategies</a:t>
+            </a:r>
+            <a:endParaRPr dirty="0"/>
           </a:p>
           <a:p>
             <a:pPr>
@@ -12308,6 +11449,38 @@
               <a:rPr dirty="0"/>
               <a:t>Expand analysis beyond cleaning</a:t>
             </a:r>
+            <a:endParaRPr lang="en-US" dirty="0"/>
+          </a:p>
+          <a:p>
+            <a:pPr>
+              <a:buFont typeface="Arial" panose="020B0604020202020204" pitchFamily="34" charset="0"/>
+              <a:buChar char="•"/>
+            </a:pPr>
+            <a:r>
+              <a:rPr lang="en-US" dirty="0"/>
+              <a:t>    Expand validation and outlier flagging</a:t>
+            </a:r>
+          </a:p>
+          <a:p>
+            <a:pPr>
+              <a:buFont typeface="Arial" panose="020B0604020202020204" pitchFamily="34" charset="0"/>
+              <a:buChar char="•"/>
+            </a:pPr>
+            <a:r>
+              <a:rPr lang="en-US" dirty="0"/>
+              <a:t>    Enhance logging and monitoring outputs</a:t>
+            </a:r>
+          </a:p>
+          <a:p>
+            <a:pPr>
+              <a:buFont typeface="Arial" panose="020B0604020202020204" pitchFamily="34" charset="0"/>
+              <a:buChar char="•"/>
+            </a:pPr>
+            <a:r>
+              <a:rPr lang="en-US" dirty="0"/>
+              <a:t>    Increase automated testing coverage</a:t>
+            </a:r>
+            <a:endParaRPr dirty="0"/>
           </a:p>
         </p:txBody>
       </p:sp>
@@ -12319,7 +11492,7 @@
 </p:sld>
 </file>
 
-<file path=ppt/slides/slide19.xml><?xml version="1.0" encoding="utf-8"?>
+<file path=ppt/slides/slide14.xml><?xml version="1.0" encoding="utf-8"?>
 <p:sld xmlns:a="http://schemas.openxmlformats.org/drawingml/2006/main" xmlns:r="http://schemas.openxmlformats.org/officeDocument/2006/relationships" xmlns:p="http://schemas.openxmlformats.org/presentationml/2006/main">
   <p:cSld>
     <p:spTree>
@@ -12576,10 +11749,7 @@
             <a:pPr marL="0" indent="0">
               <a:buNone/>
             </a:pPr>
-            <a:r>
-              <a:rPr lang="en-US" sz="1400" dirty="0"/>
-              <a:t>Name: Tynisha Niles                        # 6657177</a:t>
-            </a:r>
+            <a:endParaRPr lang="en-US" sz="1400" dirty="0"/>
           </a:p>
         </p:txBody>
       </p:sp>
@@ -12997,6 +12167,7 @@
           <a:lstStyle/>
           <a:p>
             <a:r>
+              <a:rPr dirty="0"/>
               <a:t>Objective</a:t>
             </a:r>
           </a:p>
@@ -13020,7 +12191,7 @@
         </p:spPr>
         <p:txBody>
           <a:bodyPr>
-            <a:normAutofit fontScale="92500" lnSpcReduction="10000"/>
+            <a:normAutofit/>
           </a:bodyPr>
           <a:lstStyle/>
           <a:p>
@@ -13068,7 +12239,7 @@
             </a:pPr>
             <a:r>
               <a:rPr dirty="0"/>
-              <a:t> Age</a:t>
+              <a:t> Condition</a:t>
             </a:r>
           </a:p>
           <a:p>
@@ -13078,7 +12249,7 @@
             </a:pPr>
             <a:r>
               <a:rPr dirty="0"/>
-              <a:t> Condition</a:t>
+              <a:t> Medication</a:t>
             </a:r>
           </a:p>
           <a:p>
@@ -13088,27 +12259,7 @@
             </a:pPr>
             <a:r>
               <a:rPr dirty="0"/>
-              <a:t> Medication</a:t>
-            </a:r>
-          </a:p>
-          <a:p>
-            <a:pPr>
-              <a:buFont typeface="Wingdings" panose="05000000000000000000" pitchFamily="2" charset="2"/>
-              <a:buChar char="ü"/>
-            </a:pPr>
-            <a:r>
-              <a:rPr dirty="0"/>
               <a:t> Visit Date</a:t>
-            </a:r>
-          </a:p>
-          <a:p>
-            <a:pPr>
-              <a:buFont typeface="Wingdings" panose="05000000000000000000" pitchFamily="2" charset="2"/>
-              <a:buChar char="ü"/>
-            </a:pPr>
-            <a:r>
-              <a:rPr dirty="0"/>
-              <a:t> Phone Number</a:t>
             </a:r>
           </a:p>
         </p:txBody>
@@ -13122,148 +12273,6 @@
 </file>
 
 <file path=ppt/slides/slide4.xml><?xml version="1.0" encoding="utf-8"?>
-<p:sld xmlns:a="http://schemas.openxmlformats.org/drawingml/2006/main" xmlns:r="http://schemas.openxmlformats.org/officeDocument/2006/relationships" xmlns:p="http://schemas.openxmlformats.org/presentationml/2006/main">
-  <p:cSld>
-    <p:spTree>
-      <p:nvGrpSpPr>
-        <p:cNvPr id="1" name=""/>
-        <p:cNvGrpSpPr/>
-        <p:nvPr/>
-      </p:nvGrpSpPr>
-      <p:grpSpPr>
-        <a:xfrm>
-          <a:off x="0" y="0"/>
-          <a:ext cx="0" cy="0"/>
-          <a:chOff x="0" y="0"/>
-          <a:chExt cx="0" cy="0"/>
-        </a:xfrm>
-      </p:grpSpPr>
-      <p:sp>
-        <p:nvSpPr>
-          <p:cNvPr id="2" name="Title 1"/>
-          <p:cNvSpPr>
-            <a:spLocks noGrp="1"/>
-          </p:cNvSpPr>
-          <p:nvPr>
-            <p:ph type="title"/>
-          </p:nvPr>
-        </p:nvSpPr>
-        <p:spPr/>
-        <p:txBody>
-          <a:bodyPr/>
-          <a:lstStyle/>
-          <a:p>
-            <a:r>
-              <a:rPr dirty="0"/>
-              <a:t>Pipeline Architecture</a:t>
-            </a:r>
-          </a:p>
-        </p:txBody>
-      </p:sp>
-      <p:sp>
-        <p:nvSpPr>
-          <p:cNvPr id="3" name="Content Placeholder 2"/>
-          <p:cNvSpPr>
-            <a:spLocks noGrp="1"/>
-          </p:cNvSpPr>
-          <p:nvPr>
-            <p:ph idx="1"/>
-          </p:nvPr>
-        </p:nvSpPr>
-        <p:spPr>
-          <a:xfrm>
-            <a:off x="262328" y="2520292"/>
-            <a:ext cx="8619343" cy="2201610"/>
-          </a:xfrm>
-        </p:spPr>
-        <p:txBody>
-          <a:bodyPr>
-            <a:noAutofit/>
-          </a:bodyPr>
-          <a:lstStyle/>
-          <a:p>
-            <a:r>
-              <a:rPr sz="3200" dirty="0"/>
-              <a:t>Raw Data </a:t>
-            </a:r>
-            <a:r>
-              <a:rPr sz="3200" b="1" dirty="0"/>
-              <a:t>→</a:t>
-            </a:r>
-            <a:r>
-              <a:rPr sz="3200" dirty="0"/>
-              <a:t> 01_ingest.R </a:t>
-            </a:r>
-            <a:r>
-              <a:rPr sz="3200" b="1" dirty="0"/>
-              <a:t>→</a:t>
-            </a:r>
-            <a:r>
-              <a:rPr sz="3200" dirty="0"/>
-              <a:t> 02_diagnose.R </a:t>
-            </a:r>
-            <a:r>
-              <a:rPr sz="3200" b="1" dirty="0"/>
-              <a:t>→</a:t>
-            </a:r>
-            <a:endParaRPr lang="en-US" sz="3200" b="1" dirty="0"/>
-          </a:p>
-          <a:p>
-            <a:r>
-              <a:rPr sz="3200" dirty="0"/>
-              <a:t> 03_cleaning.R </a:t>
-            </a:r>
-            <a:r>
-              <a:rPr sz="3200" b="1" dirty="0"/>
-              <a:t>→</a:t>
-            </a:r>
-            <a:r>
-              <a:rPr sz="3200" dirty="0"/>
-              <a:t> 04_impute.R </a:t>
-            </a:r>
-            <a:r>
-              <a:rPr sz="3200" b="1" dirty="0"/>
-              <a:t>→</a:t>
-            </a:r>
-            <a:r>
-              <a:rPr sz="3200" dirty="0"/>
-              <a:t> 05_dictionary.R</a:t>
-            </a:r>
-            <a:endParaRPr lang="en-US" sz="3200" dirty="0"/>
-          </a:p>
-          <a:p>
-            <a:r>
-              <a:rPr sz="3200" dirty="0"/>
-              <a:t> </a:t>
-            </a:r>
-            <a:r>
-              <a:rPr sz="3200" b="1" dirty="0"/>
-              <a:t>→</a:t>
-            </a:r>
-            <a:r>
-              <a:rPr sz="3200" dirty="0"/>
-              <a:t> 06_export.R </a:t>
-            </a:r>
-            <a:r>
-              <a:rPr sz="3200" b="1" dirty="0"/>
-              <a:t>→</a:t>
-            </a:r>
-            <a:r>
-              <a:rPr sz="3200" dirty="0"/>
-              <a:t> 07_report.Rmd</a:t>
-            </a:r>
-          </a:p>
-        </p:txBody>
-      </p:sp>
-    </p:spTree>
-  </p:cSld>
-  <p:clrMapOvr>
-    <a:masterClrMapping/>
-  </p:clrMapOvr>
-</p:sld>
-</file>
-
-<file path=ppt/slides/slide5.xml><?xml version="1.0" encoding="utf-8"?>
 <p:sld xmlns:a="http://schemas.openxmlformats.org/drawingml/2006/main" xmlns:r="http://schemas.openxmlformats.org/officeDocument/2006/relationships" xmlns:p="http://schemas.openxmlformats.org/presentationml/2006/main">
   <p:cSld>
     <p:spTree>
@@ -13330,14 +12339,14 @@
             <p:ph idx="1"/>
             <p:extLst>
               <p:ext uri="{D42A27DB-BD31-4B8C-83A1-F6EECF244321}">
-                <p14:modId xmlns:p14="http://schemas.microsoft.com/office/powerpoint/2010/main" val="3222892186"/>
+                <p14:modId xmlns:p14="http://schemas.microsoft.com/office/powerpoint/2010/main" val="956695702"/>
               </p:ext>
             </p:extLst>
           </p:nvPr>
         </p:nvGraphicFramePr>
         <p:xfrm>
-          <a:off x="2146433" y="2478505"/>
-          <a:ext cx="4266399" cy="2907546"/>
+          <a:off x="2146432" y="2478505"/>
+          <a:ext cx="4800277" cy="2907546"/>
         </p:xfrm>
         <a:graphic>
           <a:graphicData uri="http://schemas.openxmlformats.org/drawingml/2006/diagram">
@@ -13430,7 +12439,7 @@
 </p:sld>
 </file>
 
-<file path=ppt/slides/slide6.xml><?xml version="1.0" encoding="utf-8"?>
+<file path=ppt/slides/slide5.xml><?xml version="1.0" encoding="utf-8"?>
 <p:sld xmlns:a="http://schemas.openxmlformats.org/drawingml/2006/main" xmlns:r="http://schemas.openxmlformats.org/officeDocument/2006/relationships" xmlns:p="http://schemas.openxmlformats.org/presentationml/2006/main">
   <p:cSld>
     <p:spTree>
@@ -13494,17 +12503,13 @@
             </a:pPr>
             <a:r>
               <a:rPr lang="en-US" dirty="0"/>
-              <a:t>   </a:t>
-            </a:r>
-            <a:r>
-              <a:rPr dirty="0"/>
-              <a:t>Duplicate patient records</a:t>
-            </a:r>
-            <a:r>
-              <a:rPr lang="en-US" dirty="0"/>
-              <a:t> identified across repeated patient names</a:t>
-            </a:r>
-            <a:endParaRPr dirty="0"/>
+              <a:t>   Patient identifier inconsistencies in </a:t>
+            </a:r>
+            <a:r>
+              <a:rPr lang="en-US" i="1" dirty="0" err="1"/>
+              <a:t>Patient.Name</a:t>
+            </a:r>
+            <a:endParaRPr lang="en-US" i="1" dirty="0"/>
           </a:p>
           <a:p>
             <a:pPr>
@@ -13513,17 +12518,13 @@
             </a:pPr>
             <a:r>
               <a:rPr lang="en-US" dirty="0"/>
-              <a:t>   </a:t>
-            </a:r>
-            <a:r>
-              <a:rPr dirty="0"/>
-              <a:t>Inconsistent categorical values</a:t>
-            </a:r>
-            <a:r>
-              <a:rPr lang="en-US" dirty="0"/>
-              <a:t> in Gender and Medication fields</a:t>
-            </a:r>
-            <a:endParaRPr dirty="0"/>
+              <a:t>   Multiple date formats in </a:t>
+            </a:r>
+            <a:r>
+              <a:rPr lang="en-US" i="1" dirty="0" err="1"/>
+              <a:t>Visit.Date</a:t>
+            </a:r>
+            <a:endParaRPr lang="en-US" i="1" dirty="0"/>
           </a:p>
           <a:p>
             <a:pPr>
@@ -13532,17 +12533,12 @@
             </a:pPr>
             <a:r>
               <a:rPr lang="en-US" dirty="0"/>
-              <a:t>  </a:t>
-            </a:r>
-            <a:r>
-              <a:rPr dirty="0"/>
-              <a:t>Mixed data types in Age</a:t>
-            </a:r>
-            <a:r>
-              <a:rPr lang="en-US" dirty="0"/>
-              <a:t> including numeric values, text values (“forty”) and         NAN</a:t>
-            </a:r>
-            <a:endParaRPr dirty="0"/>
+              <a:t>   Free-text diagnosis inconsistencies in </a:t>
+            </a:r>
+            <a:r>
+              <a:rPr lang="en-US" i="1" dirty="0"/>
+              <a:t>Condition</a:t>
+            </a:r>
           </a:p>
           <a:p>
             <a:pPr>
@@ -13551,17 +12547,8 @@
             </a:pPr>
             <a:r>
               <a:rPr lang="en-US" dirty="0"/>
-              <a:t>   </a:t>
-            </a:r>
-            <a:r>
-              <a:rPr dirty="0"/>
-              <a:t>Missing values</a:t>
-            </a:r>
-            <a:r>
-              <a:rPr lang="en-US" dirty="0"/>
-              <a:t> in Age and Phone number</a:t>
-            </a:r>
-            <a:endParaRPr dirty="0"/>
+              <a:t>   Near-duplicate patient records requiring resolution</a:t>
+            </a:r>
           </a:p>
           <a:p>
             <a:pPr>
@@ -13570,17 +12557,21 @@
             </a:pPr>
             <a:r>
               <a:rPr lang="en-US" dirty="0"/>
-              <a:t>   </a:t>
-            </a:r>
-            <a:r>
-              <a:rPr dirty="0"/>
-              <a:t>Inconsistent date formats</a:t>
+              <a:t>   Inconsistent categorical coding in </a:t>
+            </a:r>
+            <a:r>
+              <a:rPr lang="en-US" i="1" dirty="0"/>
+              <a:t>Gender</a:t>
             </a:r>
             <a:r>
               <a:rPr lang="en-US" dirty="0"/>
-              <a:t> multiple date formats detected.</a:t>
-            </a:r>
-            <a:endParaRPr dirty="0"/>
+              <a:t> and </a:t>
+            </a:r>
+            <a:r>
+              <a:rPr lang="en-US" i="1" dirty="0"/>
+              <a:t>Medication</a:t>
+            </a:r>
+            <a:endParaRPr i="1" dirty="0"/>
           </a:p>
         </p:txBody>
       </p:sp>
@@ -13592,7 +12583,7 @@
 </p:sld>
 </file>
 
-<file path=ppt/slides/slide7.xml><?xml version="1.0" encoding="utf-8"?>
+<file path=ppt/slides/slide6.xml><?xml version="1.0" encoding="utf-8"?>
 <p:sld xmlns:a="http://schemas.openxmlformats.org/drawingml/2006/main" xmlns:r="http://schemas.openxmlformats.org/officeDocument/2006/relationships" xmlns:p="http://schemas.openxmlformats.org/presentationml/2006/main">
   <p:cSld>
     <p:spTree>
@@ -14098,7 +13089,7 @@
 </p:sld>
 </file>
 
-<file path=ppt/slides/slide8.xml><?xml version="1.0" encoding="utf-8"?>
+<file path=ppt/slides/slide7.xml><?xml version="1.0" encoding="utf-8"?>
 <p:sld xmlns:a="http://schemas.openxmlformats.org/drawingml/2006/main" xmlns:r="http://schemas.openxmlformats.org/officeDocument/2006/relationships" xmlns:p="http://schemas.openxmlformats.org/presentationml/2006/main">
   <p:cSld>
     <p:spTree>
@@ -14191,6 +13182,34 @@
               <a:rPr dirty="0"/>
               <a:t>Reason: Robust to outliers and maintains realistic values</a:t>
             </a:r>
+            <a:endParaRPr lang="en-US" dirty="0"/>
+          </a:p>
+          <a:p>
+            <a:pPr>
+              <a:buFont typeface="Arial" panose="020B0604020202020204" pitchFamily="34" charset="0"/>
+              <a:buChar char="•"/>
+            </a:pPr>
+            <a:r>
+              <a:rPr lang="en-US" dirty="0"/>
+              <a:t>   Imputation tracking variables created</a:t>
+            </a:r>
+          </a:p>
+          <a:p>
+            <a:pPr>
+              <a:buFont typeface="Arial" panose="020B0604020202020204" pitchFamily="34" charset="0"/>
+              <a:buChar char="•"/>
+            </a:pPr>
+            <a:r>
+              <a:rPr lang="en-US" dirty="0"/>
+              <a:t>   Imputation summary exported automatically</a:t>
+            </a:r>
+          </a:p>
+          <a:p>
+            <a:pPr>
+              <a:buFont typeface="Arial" panose="020B0604020202020204" pitchFamily="34" charset="0"/>
+              <a:buChar char="•"/>
+            </a:pPr>
+            <a:endParaRPr dirty="0"/>
           </a:p>
         </p:txBody>
       </p:sp>
@@ -14202,7 +13221,7 @@
 </p:sld>
 </file>
 
-<file path=ppt/slides/slide9.xml><?xml version="1.0" encoding="utf-8"?>
+<file path=ppt/slides/slide8.xml><?xml version="1.0" encoding="utf-8"?>
 <p:sld xmlns:a="http://schemas.openxmlformats.org/drawingml/2006/main" xmlns:r="http://schemas.openxmlformats.org/officeDocument/2006/relationships" xmlns:p="http://schemas.openxmlformats.org/presentationml/2006/main">
   <p:cSld>
     <p:spTree>
@@ -14307,8 +13326,42 @@
         </p:blipFill>
         <p:spPr bwMode="auto">
           <a:xfrm>
-            <a:off x="1409700" y="1845734"/>
-            <a:ext cx="6724650" cy="4364566"/>
+            <a:off x="3028950" y="1845734"/>
+            <a:ext cx="3276600" cy="2173816"/>
+          </a:xfrm>
+          <a:prstGeom prst="rect">
+            <a:avLst/>
+          </a:prstGeom>
+          <a:noFill/>
+          <a:ln w="9525">
+            <a:noFill/>
+            <a:headEnd/>
+            <a:tailEnd/>
+          </a:ln>
+        </p:spPr>
+      </p:pic>
+      <p:pic>
+        <p:nvPicPr>
+          <p:cNvPr id="4" name="Picture">
+            <a:extLst>
+              <a:ext uri="{FF2B5EF4-FFF2-40B4-BE49-F238E27FC236}">
+                <a16:creationId xmlns:a16="http://schemas.microsoft.com/office/drawing/2014/main" id="{45F1B7F8-8DB2-55DC-DB23-807D8855C60B}"/>
+              </a:ext>
+            </a:extLst>
+          </p:cNvPr>
+          <p:cNvPicPr/>
+          <p:nvPr/>
+        </p:nvPicPr>
+        <p:blipFill>
+          <a:blip r:embed="rId4"/>
+          <a:stretch>
+            <a:fillRect/>
+          </a:stretch>
+        </p:blipFill>
+        <p:spPr bwMode="auto">
+          <a:xfrm>
+            <a:off x="822960" y="1845734"/>
+            <a:ext cx="6816089" cy="4516966"/>
           </a:xfrm>
           <a:prstGeom prst="rect">
             <a:avLst/>
@@ -14322,6 +13375,493 @@
         </p:spPr>
       </p:pic>
     </p:spTree>
+  </p:cSld>
+  <p:clrMapOvr>
+    <a:masterClrMapping/>
+  </p:clrMapOvr>
+</p:sld>
+</file>
+
+<file path=ppt/slides/slide9.xml><?xml version="1.0" encoding="utf-8"?>
+<p:sld xmlns:a="http://schemas.openxmlformats.org/drawingml/2006/main" xmlns:r="http://schemas.openxmlformats.org/officeDocument/2006/relationships" xmlns:p="http://schemas.openxmlformats.org/presentationml/2006/main">
+  <p:cSld>
+    <p:spTree>
+      <p:nvGrpSpPr>
+        <p:cNvPr id="1" name="">
+          <a:extLst>
+            <a:ext uri="{FF2B5EF4-FFF2-40B4-BE49-F238E27FC236}">
+              <a16:creationId xmlns:a16="http://schemas.microsoft.com/office/drawing/2014/main" id="{DF0E3C17-AC62-7A9C-AE11-300F477118E6}"/>
+            </a:ext>
+          </a:extLst>
+        </p:cNvPr>
+        <p:cNvGrpSpPr/>
+        <p:nvPr/>
+      </p:nvGrpSpPr>
+      <p:grpSpPr>
+        <a:xfrm>
+          <a:off x="0" y="0"/>
+          <a:ext cx="0" cy="0"/>
+          <a:chOff x="0" y="0"/>
+          <a:chExt cx="0" cy="0"/>
+        </a:xfrm>
+      </p:grpSpPr>
+      <p:sp>
+        <p:nvSpPr>
+          <p:cNvPr id="2" name="Title 1">
+            <a:extLst>
+              <a:ext uri="{FF2B5EF4-FFF2-40B4-BE49-F238E27FC236}">
+                <a16:creationId xmlns:a16="http://schemas.microsoft.com/office/drawing/2014/main" id="{9FA234AA-3943-6881-1732-9E2F9A69CA03}"/>
+              </a:ext>
+            </a:extLst>
+          </p:cNvPr>
+          <p:cNvSpPr>
+            <a:spLocks noGrp="1"/>
+          </p:cNvSpPr>
+          <p:nvPr>
+            <p:ph type="title"/>
+          </p:nvPr>
+        </p:nvSpPr>
+        <p:spPr/>
+        <p:txBody>
+          <a:bodyPr/>
+          <a:lstStyle/>
+          <a:p>
+            <a:r>
+              <a:t>Outputs</a:t>
+            </a:r>
+          </a:p>
+        </p:txBody>
+      </p:sp>
+      <p:sp>
+        <p:nvSpPr>
+          <p:cNvPr id="3" name="Content Placeholder 2">
+            <a:extLst>
+              <a:ext uri="{FF2B5EF4-FFF2-40B4-BE49-F238E27FC236}">
+                <a16:creationId xmlns:a16="http://schemas.microsoft.com/office/drawing/2014/main" id="{A1000D8F-115D-FD16-A9C6-1C28ECF8C536}"/>
+              </a:ext>
+            </a:extLst>
+          </p:cNvPr>
+          <p:cNvSpPr>
+            <a:spLocks noGrp="1"/>
+          </p:cNvSpPr>
+          <p:nvPr>
+            <p:ph idx="1"/>
+          </p:nvPr>
+        </p:nvSpPr>
+        <p:spPr/>
+        <p:txBody>
+          <a:bodyPr/>
+          <a:lstStyle/>
+          <a:p>
+            <a:pPr marL="0" indent="0">
+              <a:buNone/>
+            </a:pPr>
+            <a:endParaRPr lang="en-US" dirty="0"/>
+          </a:p>
+          <a:p>
+            <a:pPr>
+              <a:buFont typeface="Arial" panose="020B0604020202020204" pitchFamily="34" charset="0"/>
+              <a:buChar char="•"/>
+            </a:pPr>
+            <a:r>
+              <a:rPr lang="en-US" dirty="0"/>
+              <a:t>   .xlsx export with data dictionary</a:t>
+            </a:r>
+          </a:p>
+          <a:p>
+            <a:pPr>
+              <a:buFont typeface="Arial" panose="020B0604020202020204" pitchFamily="34" charset="0"/>
+              <a:buChar char="•"/>
+            </a:pPr>
+            <a:r>
+              <a:rPr lang="en-US" dirty="0"/>
+              <a:t>   .sav export (SPSS)</a:t>
+            </a:r>
+          </a:p>
+          <a:p>
+            <a:pPr>
+              <a:buFont typeface="Arial" panose="020B0604020202020204" pitchFamily="34" charset="0"/>
+              <a:buChar char="•"/>
+            </a:pPr>
+            <a:r>
+              <a:rPr lang="en-US" dirty="0"/>
+              <a:t>   .</a:t>
+            </a:r>
+            <a:r>
+              <a:rPr lang="en-US" dirty="0" err="1"/>
+              <a:t>dta</a:t>
+            </a:r>
+            <a:r>
+              <a:rPr lang="en-US" dirty="0"/>
+              <a:t> export (Stata)</a:t>
+            </a:r>
+          </a:p>
+          <a:p>
+            <a:pPr>
+              <a:buFont typeface="Arial" panose="020B0604020202020204" pitchFamily="34" charset="0"/>
+              <a:buChar char="•"/>
+            </a:pPr>
+            <a:r>
+              <a:rPr lang="en-US" dirty="0"/>
+              <a:t>   .</a:t>
+            </a:r>
+            <a:r>
+              <a:rPr lang="en-US" dirty="0" err="1"/>
+              <a:t>rds</a:t>
+            </a:r>
+            <a:r>
+              <a:rPr lang="en-US" dirty="0"/>
+              <a:t> export</a:t>
+            </a:r>
+          </a:p>
+          <a:p>
+            <a:pPr>
+              <a:buFont typeface="Arial" panose="020B0604020202020204" pitchFamily="34" charset="0"/>
+              <a:buChar char="•"/>
+            </a:pPr>
+            <a:r>
+              <a:rPr lang="en-US" dirty="0"/>
+              <a:t>   Automated Word report </a:t>
+            </a:r>
+          </a:p>
+          <a:p>
+            <a:pPr marL="0" indent="0">
+              <a:buNone/>
+            </a:pPr>
+            <a:endParaRPr lang="en-US" dirty="0"/>
+          </a:p>
+          <a:p>
+            <a:endParaRPr dirty="0"/>
+          </a:p>
+          <a:p>
+            <a:pPr marL="0" indent="0">
+              <a:buNone/>
+            </a:pPr>
+            <a:endParaRPr dirty="0"/>
+          </a:p>
+        </p:txBody>
+      </p:sp>
+      <p:graphicFrame>
+        <p:nvGraphicFramePr>
+          <p:cNvPr id="4" name="Object 3">
+            <a:extLst>
+              <a:ext uri="{FF2B5EF4-FFF2-40B4-BE49-F238E27FC236}">
+                <a16:creationId xmlns:a16="http://schemas.microsoft.com/office/drawing/2014/main" id="{8BF5BEA3-44D2-B57D-1D09-192708499463}"/>
+              </a:ext>
+            </a:extLst>
+          </p:cNvPr>
+          <p:cNvGraphicFramePr>
+            <a:graphicFrameLocks noChangeAspect="1"/>
+          </p:cNvGraphicFramePr>
+          <p:nvPr>
+            <p:extLst>
+              <p:ext uri="{D42A27DB-BD31-4B8C-83A1-F6EECF244321}">
+                <p14:modId xmlns:p14="http://schemas.microsoft.com/office/powerpoint/2010/main" val="1543333236"/>
+              </p:ext>
+            </p:extLst>
+          </p:nvPr>
+        </p:nvGraphicFramePr>
+        <p:xfrm>
+          <a:off x="2859205" y="3296726"/>
+          <a:ext cx="679608" cy="573419"/>
+        </p:xfrm>
+        <a:graphic>
+          <a:graphicData uri="http://schemas.openxmlformats.org/presentationml/2006/ole">
+            <mc:AlternateContent xmlns:mc="http://schemas.openxmlformats.org/markup-compatibility/2006">
+              <mc:Choice xmlns:v="urn:schemas-microsoft-com:vml" Requires="v">
+                <p:oleObj name="Packager Shell Object" showAsIcon="1" r:id="rId3" imgW="914570" imgH="771690" progId="Package">
+                  <p:embed/>
+                </p:oleObj>
+              </mc:Choice>
+              <mc:Fallback>
+                <p:oleObj name="Packager Shell Object" showAsIcon="1" r:id="rId3" imgW="914570" imgH="771690" progId="Package">
+                  <p:embed/>
+                  <p:pic>
+                    <p:nvPicPr>
+                      <p:cNvPr id="0" name=""/>
+                      <p:cNvPicPr/>
+                      <p:nvPr/>
+                    </p:nvPicPr>
+                    <p:blipFill>
+                      <a:blip r:embed="rId4"/>
+                      <a:stretch>
+                        <a:fillRect/>
+                      </a:stretch>
+                    </p:blipFill>
+                    <p:spPr>
+                      <a:xfrm>
+                        <a:off x="2859205" y="3296726"/>
+                        <a:ext cx="679608" cy="573419"/>
+                      </a:xfrm>
+                      <a:prstGeom prst="rect">
+                        <a:avLst/>
+                      </a:prstGeom>
+                    </p:spPr>
+                  </p:pic>
+                </p:oleObj>
+              </mc:Fallback>
+            </mc:AlternateContent>
+          </a:graphicData>
+        </a:graphic>
+      </p:graphicFrame>
+      <p:graphicFrame>
+        <p:nvGraphicFramePr>
+          <p:cNvPr id="6" name="Object 5">
+            <a:extLst>
+              <a:ext uri="{FF2B5EF4-FFF2-40B4-BE49-F238E27FC236}">
+                <a16:creationId xmlns:a16="http://schemas.microsoft.com/office/drawing/2014/main" id="{887736C3-579D-ED98-DF2A-FEF5F013E614}"/>
+              </a:ext>
+            </a:extLst>
+          </p:cNvPr>
+          <p:cNvGraphicFramePr>
+            <a:graphicFrameLocks noChangeAspect="1"/>
+          </p:cNvGraphicFramePr>
+          <p:nvPr>
+            <p:extLst>
+              <p:ext uri="{D42A27DB-BD31-4B8C-83A1-F6EECF244321}">
+                <p14:modId xmlns:p14="http://schemas.microsoft.com/office/powerpoint/2010/main" val="717107319"/>
+              </p:ext>
+            </p:extLst>
+          </p:nvPr>
+        </p:nvGraphicFramePr>
+        <p:xfrm>
+          <a:off x="2097711" y="3580024"/>
+          <a:ext cx="679608" cy="573419"/>
+        </p:xfrm>
+        <a:graphic>
+          <a:graphicData uri="http://schemas.openxmlformats.org/presentationml/2006/ole">
+            <mc:AlternateContent xmlns:mc="http://schemas.openxmlformats.org/markup-compatibility/2006">
+              <mc:Choice xmlns:v="urn:schemas-microsoft-com:vml" Requires="v">
+                <p:oleObj name="Packager Shell Object" showAsIcon="1" r:id="rId5" imgW="914570" imgH="771690" progId="Package">
+                  <p:embed/>
+                </p:oleObj>
+              </mc:Choice>
+              <mc:Fallback>
+                <p:oleObj name="Packager Shell Object" showAsIcon="1" r:id="rId5" imgW="914570" imgH="771690" progId="Package">
+                  <p:embed/>
+                  <p:pic>
+                    <p:nvPicPr>
+                      <p:cNvPr id="0" name=""/>
+                      <p:cNvPicPr/>
+                      <p:nvPr/>
+                    </p:nvPicPr>
+                    <p:blipFill>
+                      <a:blip r:embed="rId6"/>
+                      <a:stretch>
+                        <a:fillRect/>
+                      </a:stretch>
+                    </p:blipFill>
+                    <p:spPr>
+                      <a:xfrm>
+                        <a:off x="2097711" y="3580024"/>
+                        <a:ext cx="679608" cy="573419"/>
+                      </a:xfrm>
+                      <a:prstGeom prst="rect">
+                        <a:avLst/>
+                      </a:prstGeom>
+                    </p:spPr>
+                  </p:pic>
+                </p:oleObj>
+              </mc:Fallback>
+            </mc:AlternateContent>
+          </a:graphicData>
+        </a:graphic>
+      </p:graphicFrame>
+      <p:graphicFrame>
+        <p:nvGraphicFramePr>
+          <p:cNvPr id="7" name="Object 6">
+            <a:extLst>
+              <a:ext uri="{FF2B5EF4-FFF2-40B4-BE49-F238E27FC236}">
+                <a16:creationId xmlns:a16="http://schemas.microsoft.com/office/drawing/2014/main" id="{F4FC83D4-38C8-6790-A048-0F8F1F2FDF1B}"/>
+              </a:ext>
+            </a:extLst>
+          </p:cNvPr>
+          <p:cNvGraphicFramePr>
+            <a:graphicFrameLocks noChangeAspect="1"/>
+          </p:cNvGraphicFramePr>
+          <p:nvPr>
+            <p:extLst>
+              <p:ext uri="{D42A27DB-BD31-4B8C-83A1-F6EECF244321}">
+                <p14:modId xmlns:p14="http://schemas.microsoft.com/office/powerpoint/2010/main" val="1712028627"/>
+              </p:ext>
+            </p:extLst>
+          </p:nvPr>
+        </p:nvGraphicFramePr>
+        <p:xfrm>
+          <a:off x="3272681" y="2793442"/>
+          <a:ext cx="532263" cy="449097"/>
+        </p:xfrm>
+        <a:graphic>
+          <a:graphicData uri="http://schemas.openxmlformats.org/presentationml/2006/ole">
+            <mc:AlternateContent xmlns:mc="http://schemas.openxmlformats.org/markup-compatibility/2006">
+              <mc:Choice xmlns:v="urn:schemas-microsoft-com:vml" Requires="v">
+                <p:oleObj name="Packager Shell Object" showAsIcon="1" r:id="rId7" imgW="914570" imgH="771690" progId="Package">
+                  <p:embed/>
+                </p:oleObj>
+              </mc:Choice>
+              <mc:Fallback>
+                <p:oleObj name="Packager Shell Object" showAsIcon="1" r:id="rId7" imgW="914570" imgH="771690" progId="Package">
+                  <p:embed/>
+                  <p:pic>
+                    <p:nvPicPr>
+                      <p:cNvPr id="0" name=""/>
+                      <p:cNvPicPr/>
+                      <p:nvPr/>
+                    </p:nvPicPr>
+                    <p:blipFill>
+                      <a:blip r:embed="rId8"/>
+                      <a:stretch>
+                        <a:fillRect/>
+                      </a:stretch>
+                    </p:blipFill>
+                    <p:spPr>
+                      <a:xfrm>
+                        <a:off x="3272681" y="2793442"/>
+                        <a:ext cx="532263" cy="449097"/>
+                      </a:xfrm>
+                      <a:prstGeom prst="rect">
+                        <a:avLst/>
+                      </a:prstGeom>
+                    </p:spPr>
+                  </p:pic>
+                </p:oleObj>
+              </mc:Fallback>
+            </mc:AlternateContent>
+          </a:graphicData>
+        </a:graphic>
+      </p:graphicFrame>
+      <p:graphicFrame>
+        <p:nvGraphicFramePr>
+          <p:cNvPr id="8" name="Object 7">
+            <a:extLst>
+              <a:ext uri="{FF2B5EF4-FFF2-40B4-BE49-F238E27FC236}">
+                <a16:creationId xmlns:a16="http://schemas.microsoft.com/office/drawing/2014/main" id="{0E29F489-12DA-F13F-2DF0-3187E0015275}"/>
+              </a:ext>
+            </a:extLst>
+          </p:cNvPr>
+          <p:cNvGraphicFramePr>
+            <a:graphicFrameLocks noChangeAspect="1"/>
+          </p:cNvGraphicFramePr>
+          <p:nvPr>
+            <p:extLst>
+              <p:ext uri="{D42A27DB-BD31-4B8C-83A1-F6EECF244321}">
+                <p14:modId xmlns:p14="http://schemas.microsoft.com/office/powerpoint/2010/main" val="127216904"/>
+              </p:ext>
+            </p:extLst>
+          </p:nvPr>
+        </p:nvGraphicFramePr>
+        <p:xfrm>
+          <a:off x="4572000" y="2195287"/>
+          <a:ext cx="708926" cy="598156"/>
+        </p:xfrm>
+        <a:graphic>
+          <a:graphicData uri="http://schemas.openxmlformats.org/presentationml/2006/ole">
+            <mc:AlternateContent xmlns:mc="http://schemas.openxmlformats.org/markup-compatibility/2006">
+              <mc:Choice xmlns:v="urn:schemas-microsoft-com:vml" Requires="v">
+                <p:oleObj name="Worksheet" showAsIcon="1" r:id="rId9" imgW="914570" imgH="771690" progId="Excel.Sheet.12">
+                  <p:embed/>
+                </p:oleObj>
+              </mc:Choice>
+              <mc:Fallback>
+                <p:oleObj name="Worksheet" showAsIcon="1" r:id="rId9" imgW="914570" imgH="771690" progId="Excel.Sheet.12">
+                  <p:embed/>
+                  <p:pic>
+                    <p:nvPicPr>
+                      <p:cNvPr id="0" name=""/>
+                      <p:cNvPicPr/>
+                      <p:nvPr/>
+                    </p:nvPicPr>
+                    <p:blipFill>
+                      <a:blip r:embed="rId10"/>
+                      <a:stretch>
+                        <a:fillRect/>
+                      </a:stretch>
+                    </p:blipFill>
+                    <p:spPr>
+                      <a:xfrm>
+                        <a:off x="4572000" y="2195287"/>
+                        <a:ext cx="708926" cy="598156"/>
+                      </a:xfrm>
+                      <a:prstGeom prst="rect">
+                        <a:avLst/>
+                      </a:prstGeom>
+                    </p:spPr>
+                  </p:pic>
+                </p:oleObj>
+              </mc:Fallback>
+            </mc:AlternateContent>
+          </a:graphicData>
+        </a:graphic>
+      </p:graphicFrame>
+      <p:graphicFrame>
+        <p:nvGraphicFramePr>
+          <p:cNvPr id="9" name="Object 8">
+            <a:extLst>
+              <a:ext uri="{FF2B5EF4-FFF2-40B4-BE49-F238E27FC236}">
+                <a16:creationId xmlns:a16="http://schemas.microsoft.com/office/drawing/2014/main" id="{72BE34EE-93AD-616F-4505-D71616E12D1A}"/>
+              </a:ext>
+            </a:extLst>
+          </p:cNvPr>
+          <p:cNvGraphicFramePr>
+            <a:graphicFrameLocks noChangeAspect="1"/>
+          </p:cNvGraphicFramePr>
+          <p:nvPr>
+            <p:extLst>
+              <p:ext uri="{D42A27DB-BD31-4B8C-83A1-F6EECF244321}">
+                <p14:modId xmlns:p14="http://schemas.microsoft.com/office/powerpoint/2010/main" val="4063968632"/>
+              </p:ext>
+            </p:extLst>
+          </p:nvPr>
+        </p:nvGraphicFramePr>
+        <p:xfrm>
+          <a:off x="3785939" y="4106718"/>
+          <a:ext cx="532264" cy="449098"/>
+        </p:xfrm>
+        <a:graphic>
+          <a:graphicData uri="http://schemas.openxmlformats.org/presentationml/2006/ole">
+            <mc:AlternateContent xmlns:mc="http://schemas.openxmlformats.org/markup-compatibility/2006">
+              <mc:Choice xmlns:v="urn:schemas-microsoft-com:vml" Requires="v">
+                <p:oleObj name="Document" showAsIcon="1" r:id="rId11" imgW="914570" imgH="771690" progId="Word.Document.12">
+                  <p:embed/>
+                </p:oleObj>
+              </mc:Choice>
+              <mc:Fallback>
+                <p:oleObj name="Document" showAsIcon="1" r:id="rId11" imgW="914570" imgH="771690" progId="Word.Document.12">
+                  <p:embed/>
+                  <p:pic>
+                    <p:nvPicPr>
+                      <p:cNvPr id="0" name=""/>
+                      <p:cNvPicPr/>
+                      <p:nvPr/>
+                    </p:nvPicPr>
+                    <p:blipFill>
+                      <a:blip r:embed="rId12"/>
+                      <a:stretch>
+                        <a:fillRect/>
+                      </a:stretch>
+                    </p:blipFill>
+                    <p:spPr>
+                      <a:xfrm>
+                        <a:off x="3785939" y="4106718"/>
+                        <a:ext cx="532264" cy="449098"/>
+                      </a:xfrm>
+                      <a:prstGeom prst="rect">
+                        <a:avLst/>
+                      </a:prstGeom>
+                    </p:spPr>
+                  </p:pic>
+                </p:oleObj>
+              </mc:Fallback>
+            </mc:AlternateContent>
+          </a:graphicData>
+        </a:graphic>
+      </p:graphicFrame>
+    </p:spTree>
+    <p:extLst>
+      <p:ext uri="{BB962C8B-B14F-4D97-AF65-F5344CB8AC3E}">
+        <p14:creationId xmlns:p14="http://schemas.microsoft.com/office/powerpoint/2010/main" val="2241275322"/>
+      </p:ext>
+    </p:extLst>
   </p:cSld>
   <p:clrMapOvr>
     <a:masterClrMapping/>

</xml_diff>